<commit_message>
Remove em dashes, fix slide 5 alignment, drop Random from baselines
</commit_message>
<xml_diff>
--- a/deliverables/enterprise_marl_benchmark.pptx
+++ b/deliverables/enterprise_marl_benchmark.pptx
@@ -3911,7 +3911,7 @@
                   <a:srgbClr val="FFFFFF"/>
                 </a:solidFill>
               </a:rPr>
-              <a:t>SECTION 1 — THE ENVIRONMENT</a:t>
+              <a:t>SECTION 1: THE ENVIRONMENT</a:t>
             </a:r>
           </a:p>
         </p:txBody>
@@ -3979,7 +3979,7 @@
                   <a:srgbClr val="2E9CFF"/>
                 </a:solidFill>
               </a:rPr>
-              <a:t>Four-tier policy taxonomy · Wilson 95% CI · HTML trajectory viewer</a:t>
+              <a:t>Three-tier policy taxonomy · Wilson 95% CI · HTML trajectory viewer</a:t>
             </a:r>
           </a:p>
         </p:txBody>
@@ -3992,119 +3992,8 @@
         </p:nvSpPr>
         <p:spPr>
           <a:xfrm>
-            <a:off x="457200" y="4142232"/>
-            <a:ext cx="2286000" cy="109728"/>
-          </a:xfrm>
-          <a:prstGeom prst="rect">
-            <a:avLst/>
-          </a:prstGeom>
-          <a:solidFill>
-            <a:srgbClr val="8A9BAD"/>
-          </a:solidFill>
-          <a:ln>
-            <a:noFill/>
-          </a:ln>
-        </p:spPr>
-        <p:style>
-          <a:lnRef idx="1">
-            <a:schemeClr val="accent1"/>
-          </a:lnRef>
-          <a:fillRef idx="3">
-            <a:schemeClr val="accent1"/>
-          </a:fillRef>
-          <a:effectRef idx="2">
-            <a:schemeClr val="accent1"/>
-          </a:effectRef>
-          <a:fontRef idx="minor">
-            <a:schemeClr val="lt1"/>
-          </a:fontRef>
-        </p:style>
-        <p:txBody>
-          <a:bodyPr rtlCol="0" anchor="ctr"/>
-          <a:lstStyle/>
-          <a:p>
-            <a:pPr algn="ctr"/>
-          </a:p>
-        </p:txBody>
-      </p:sp>
-      <p:sp>
-        <p:nvSpPr>
-          <p:cNvPr id="8" name="TextBox 7"/>
-          <p:cNvSpPr txBox="1"/>
-          <p:nvPr/>
-        </p:nvSpPr>
-        <p:spPr>
-          <a:xfrm>
-            <a:off x="457200" y="3776472"/>
-            <a:ext cx="2286000" cy="320040"/>
-          </a:xfrm>
-          <a:prstGeom prst="rect">
-            <a:avLst/>
-          </a:prstGeom>
-          <a:noFill/>
-        </p:spPr>
-        <p:txBody>
-          <a:bodyPr wrap="square">
-            <a:spAutoFit/>
-          </a:bodyPr>
-          <a:lstStyle/>
-          <a:p>
-            <a:pPr algn="ctr"/>
-            <a:r>
-              <a:rPr sz="1300" b="1" i="0">
-                <a:solidFill>
-                  <a:srgbClr val="8A9BAD"/>
-                </a:solidFill>
-              </a:rPr>
-              <a:t>0 / 30</a:t>
-            </a:r>
-          </a:p>
-        </p:txBody>
-      </p:sp>
-      <p:sp>
-        <p:nvSpPr>
-          <p:cNvPr id="9" name="TextBox 8"/>
-          <p:cNvSpPr txBox="1"/>
-          <p:nvPr/>
-        </p:nvSpPr>
-        <p:spPr>
-          <a:xfrm>
-            <a:off x="457200" y="4325112"/>
-            <a:ext cx="2286000" cy="411480"/>
-          </a:xfrm>
-          <a:prstGeom prst="rect">
-            <a:avLst/>
-          </a:prstGeom>
-          <a:noFill/>
-        </p:spPr>
-        <p:txBody>
-          <a:bodyPr wrap="square">
-            <a:spAutoFit/>
-          </a:bodyPr>
-          <a:lstStyle/>
-          <a:p>
-            <a:pPr algn="ctr"/>
-            <a:r>
-              <a:rPr sz="1100" b="0" i="0">
-                <a:solidFill>
-                  <a:srgbClr val="1A2B3C"/>
-                </a:solidFill>
-              </a:rPr>
-              <a:t>Random</a:t>
-            </a:r>
-          </a:p>
-        </p:txBody>
-      </p:sp>
-      <p:sp>
-        <p:nvSpPr>
-          <p:cNvPr id="10" name="Rectangle 9"/>
-          <p:cNvSpPr/>
-          <p:nvPr/>
-        </p:nvSpPr>
-        <p:spPr>
-          <a:xfrm>
-            <a:off x="3108960" y="4142232"/>
-            <a:ext cx="2286000" cy="109728"/>
+            <a:off x="914400" y="4142232"/>
+            <a:ext cx="2926080" cy="109728"/>
           </a:xfrm>
           <a:prstGeom prst="rect">
             <a:avLst/>
@@ -4140,29 +4029,29 @@
       </p:sp>
       <p:sp>
         <p:nvSpPr>
-          <p:cNvPr id="11" name="TextBox 10"/>
-          <p:cNvSpPr txBox="1"/>
-          <p:nvPr/>
-        </p:nvSpPr>
-        <p:spPr>
-          <a:xfrm>
-            <a:off x="3108960" y="3776472"/>
-            <a:ext cx="2286000" cy="320040"/>
-          </a:xfrm>
-          <a:prstGeom prst="rect">
-            <a:avLst/>
-          </a:prstGeom>
-          <a:noFill/>
-        </p:spPr>
-        <p:txBody>
-          <a:bodyPr wrap="square">
-            <a:spAutoFit/>
-          </a:bodyPr>
-          <a:lstStyle/>
-          <a:p>
-            <a:pPr algn="ctr"/>
-            <a:r>
-              <a:rPr sz="1300" b="1" i="0">
+          <p:cNvPr id="8" name="TextBox 7"/>
+          <p:cNvSpPr txBox="1"/>
+          <p:nvPr/>
+        </p:nvSpPr>
+        <p:spPr>
+          <a:xfrm>
+            <a:off x="914400" y="3776472"/>
+            <a:ext cx="2926080" cy="320040"/>
+          </a:xfrm>
+          <a:prstGeom prst="rect">
+            <a:avLst/>
+          </a:prstGeom>
+          <a:noFill/>
+        </p:spPr>
+        <p:txBody>
+          <a:bodyPr wrap="square">
+            <a:spAutoFit/>
+          </a:bodyPr>
+          <a:lstStyle/>
+          <a:p>
+            <a:pPr algn="ctr"/>
+            <a:r>
+              <a:rPr sz="1400" b="1" i="0">
                 <a:solidFill>
                   <a:srgbClr val="FFA52A"/>
                 </a:solidFill>
@@ -4174,29 +4063,29 @@
       </p:sp>
       <p:sp>
         <p:nvSpPr>
-          <p:cNvPr id="12" name="TextBox 11"/>
-          <p:cNvSpPr txBox="1"/>
-          <p:nvPr/>
-        </p:nvSpPr>
-        <p:spPr>
-          <a:xfrm>
-            <a:off x="3108960" y="4325112"/>
-            <a:ext cx="2286000" cy="411480"/>
-          </a:xfrm>
-          <a:prstGeom prst="rect">
-            <a:avLst/>
-          </a:prstGeom>
-          <a:noFill/>
-        </p:spPr>
-        <p:txBody>
-          <a:bodyPr wrap="square">
-            <a:spAutoFit/>
-          </a:bodyPr>
-          <a:lstStyle/>
-          <a:p>
-            <a:pPr algn="ctr"/>
-            <a:r>
-              <a:rPr sz="1100" b="0" i="0">
+          <p:cNvPr id="9" name="TextBox 8"/>
+          <p:cNvSpPr txBox="1"/>
+          <p:nvPr/>
+        </p:nvSpPr>
+        <p:spPr>
+          <a:xfrm>
+            <a:off x="914400" y="4325112"/>
+            <a:ext cx="2926080" cy="411480"/>
+          </a:xfrm>
+          <a:prstGeom prst="rect">
+            <a:avLst/>
+          </a:prstGeom>
+          <a:noFill/>
+        </p:spPr>
+        <p:txBody>
+          <a:bodyPr wrap="square">
+            <a:spAutoFit/>
+          </a:bodyPr>
+          <a:lstStyle/>
+          <a:p>
+            <a:pPr algn="ctr"/>
+            <a:r>
+              <a:rPr sz="1200" b="0" i="0">
                 <a:solidFill>
                   <a:srgbClr val="1A2B3C"/>
                 </a:solidFill>
@@ -4208,14 +4097,14 @@
       </p:sp>
       <p:sp>
         <p:nvSpPr>
-          <p:cNvPr id="13" name="Rectangle 12"/>
+          <p:cNvPr id="10" name="Rectangle 9"/>
           <p:cNvSpPr/>
           <p:nvPr/>
         </p:nvSpPr>
         <p:spPr>
           <a:xfrm>
-            <a:off x="5760720" y="2203704"/>
-            <a:ext cx="2286000" cy="2048256"/>
+            <a:off x="4343400" y="2203704"/>
+            <a:ext cx="2926080" cy="2048256"/>
           </a:xfrm>
           <a:prstGeom prst="rect">
             <a:avLst/>
@@ -4251,29 +4140,29 @@
       </p:sp>
       <p:sp>
         <p:nvSpPr>
-          <p:cNvPr id="14" name="TextBox 13"/>
-          <p:cNvSpPr txBox="1"/>
-          <p:nvPr/>
-        </p:nvSpPr>
-        <p:spPr>
-          <a:xfrm>
-            <a:off x="5760720" y="1837944"/>
-            <a:ext cx="2286000" cy="320040"/>
-          </a:xfrm>
-          <a:prstGeom prst="rect">
-            <a:avLst/>
-          </a:prstGeom>
-          <a:noFill/>
-        </p:spPr>
-        <p:txBody>
-          <a:bodyPr wrap="square">
-            <a:spAutoFit/>
-          </a:bodyPr>
-          <a:lstStyle/>
-          <a:p>
-            <a:pPr algn="ctr"/>
-            <a:r>
-              <a:rPr sz="1300" b="1" i="0">
+          <p:cNvPr id="11" name="TextBox 10"/>
+          <p:cNvSpPr txBox="1"/>
+          <p:nvPr/>
+        </p:nvSpPr>
+        <p:spPr>
+          <a:xfrm>
+            <a:off x="4343400" y="1837944"/>
+            <a:ext cx="2926080" cy="320040"/>
+          </a:xfrm>
+          <a:prstGeom prst="rect">
+            <a:avLst/>
+          </a:prstGeom>
+          <a:noFill/>
+        </p:spPr>
+        <p:txBody>
+          <a:bodyPr wrap="square">
+            <a:spAutoFit/>
+          </a:bodyPr>
+          <a:lstStyle/>
+          <a:p>
+            <a:pPr algn="ctr"/>
+            <a:r>
+              <a:rPr sz="1400" b="1" i="0">
                 <a:solidFill>
                   <a:srgbClr val="2E9CFF"/>
                 </a:solidFill>
@@ -4285,29 +4174,29 @@
       </p:sp>
       <p:sp>
         <p:nvSpPr>
-          <p:cNvPr id="15" name="TextBox 14"/>
-          <p:cNvSpPr txBox="1"/>
-          <p:nvPr/>
-        </p:nvSpPr>
-        <p:spPr>
-          <a:xfrm>
-            <a:off x="5760720" y="4325112"/>
-            <a:ext cx="2286000" cy="411480"/>
-          </a:xfrm>
-          <a:prstGeom prst="rect">
-            <a:avLst/>
-          </a:prstGeom>
-          <a:noFill/>
-        </p:spPr>
-        <p:txBody>
-          <a:bodyPr wrap="square">
-            <a:spAutoFit/>
-          </a:bodyPr>
-          <a:lstStyle/>
-          <a:p>
-            <a:pPr algn="ctr"/>
-            <a:r>
-              <a:rPr sz="1100" b="0" i="0">
+          <p:cNvPr id="12" name="TextBox 11"/>
+          <p:cNvSpPr txBox="1"/>
+          <p:nvPr/>
+        </p:nvSpPr>
+        <p:spPr>
+          <a:xfrm>
+            <a:off x="4343400" y="4325112"/>
+            <a:ext cx="2926080" cy="411480"/>
+          </a:xfrm>
+          <a:prstGeom prst="rect">
+            <a:avLst/>
+          </a:prstGeom>
+          <a:noFill/>
+        </p:spPr>
+        <p:txBody>
+          <a:bodyPr wrap="square">
+            <a:spAutoFit/>
+          </a:bodyPr>
+          <a:lstStyle/>
+          <a:p>
+            <a:pPr algn="ctr"/>
+            <a:r>
+              <a:rPr sz="1200" b="0" i="0">
                 <a:solidFill>
                   <a:srgbClr val="1A2B3C"/>
                 </a:solidFill>
@@ -4319,14 +4208,14 @@
       </p:sp>
       <p:sp>
         <p:nvSpPr>
-          <p:cNvPr id="16" name="Rectangle 15"/>
+          <p:cNvPr id="13" name="Rectangle 12"/>
           <p:cNvSpPr/>
           <p:nvPr/>
         </p:nvSpPr>
         <p:spPr>
           <a:xfrm>
-            <a:off x="8412480" y="1691640"/>
-            <a:ext cx="2286000" cy="2560320"/>
+            <a:off x="7772400" y="1691640"/>
+            <a:ext cx="2926080" cy="2560320"/>
           </a:xfrm>
           <a:prstGeom prst="rect">
             <a:avLst/>
@@ -4362,29 +4251,29 @@
       </p:sp>
       <p:sp>
         <p:nvSpPr>
-          <p:cNvPr id="17" name="TextBox 16"/>
-          <p:cNvSpPr txBox="1"/>
-          <p:nvPr/>
-        </p:nvSpPr>
-        <p:spPr>
-          <a:xfrm>
-            <a:off x="8412480" y="1325880"/>
-            <a:ext cx="2286000" cy="320040"/>
-          </a:xfrm>
-          <a:prstGeom prst="rect">
-            <a:avLst/>
-          </a:prstGeom>
-          <a:noFill/>
-        </p:spPr>
-        <p:txBody>
-          <a:bodyPr wrap="square">
-            <a:spAutoFit/>
-          </a:bodyPr>
-          <a:lstStyle/>
-          <a:p>
-            <a:pPr algn="ctr"/>
-            <a:r>
-              <a:rPr sz="1300" b="1" i="0">
+          <p:cNvPr id="14" name="TextBox 13"/>
+          <p:cNvSpPr txBox="1"/>
+          <p:nvPr/>
+        </p:nvSpPr>
+        <p:spPr>
+          <a:xfrm>
+            <a:off x="7772400" y="1325880"/>
+            <a:ext cx="2926080" cy="320040"/>
+          </a:xfrm>
+          <a:prstGeom prst="rect">
+            <a:avLst/>
+          </a:prstGeom>
+          <a:noFill/>
+        </p:spPr>
+        <p:txBody>
+          <a:bodyPr wrap="square">
+            <a:spAutoFit/>
+          </a:bodyPr>
+          <a:lstStyle/>
+          <a:p>
+            <a:pPr algn="ctr"/>
+            <a:r>
+              <a:rPr sz="1400" b="1" i="0">
                 <a:solidFill>
                   <a:srgbClr val="1AB070"/>
                 </a:solidFill>
@@ -4396,29 +4285,29 @@
       </p:sp>
       <p:sp>
         <p:nvSpPr>
-          <p:cNvPr id="18" name="TextBox 17"/>
-          <p:cNvSpPr txBox="1"/>
-          <p:nvPr/>
-        </p:nvSpPr>
-        <p:spPr>
-          <a:xfrm>
-            <a:off x="8412480" y="4325112"/>
-            <a:ext cx="2286000" cy="411480"/>
-          </a:xfrm>
-          <a:prstGeom prst="rect">
-            <a:avLst/>
-          </a:prstGeom>
-          <a:noFill/>
-        </p:spPr>
-        <p:txBody>
-          <a:bodyPr wrap="square">
-            <a:spAutoFit/>
-          </a:bodyPr>
-          <a:lstStyle/>
-          <a:p>
-            <a:pPr algn="ctr"/>
-            <a:r>
-              <a:rPr sz="1100" b="0" i="0">
+          <p:cNvPr id="15" name="TextBox 14"/>
+          <p:cNvSpPr txBox="1"/>
+          <p:nvPr/>
+        </p:nvSpPr>
+        <p:spPr>
+          <a:xfrm>
+            <a:off x="7772400" y="4325112"/>
+            <a:ext cx="2926080" cy="411480"/>
+          </a:xfrm>
+          <a:prstGeom prst="rect">
+            <a:avLst/>
+          </a:prstGeom>
+          <a:noFill/>
+        </p:spPr>
+        <p:txBody>
+          <a:bodyPr wrap="square">
+            <a:spAutoFit/>
+          </a:bodyPr>
+          <a:lstStyle/>
+          <a:p>
+            <a:pPr algn="ctr"/>
+            <a:r>
+              <a:rPr sz="1200" b="0" i="0">
                 <a:solidFill>
                   <a:srgbClr val="1A2B3C"/>
                 </a:solidFill>
@@ -4430,14 +4319,14 @@
       </p:sp>
       <p:sp>
         <p:nvSpPr>
-          <p:cNvPr id="19" name="Rectangle 18"/>
+          <p:cNvPr id="16" name="Rectangle 15"/>
           <p:cNvSpPr/>
           <p:nvPr/>
         </p:nvSpPr>
         <p:spPr>
           <a:xfrm>
-            <a:off x="365760" y="4251960"/>
-            <a:ext cx="11430000" cy="36576"/>
+            <a:off x="822960" y="4251960"/>
+            <a:ext cx="10515600" cy="36576"/>
           </a:xfrm>
           <a:prstGeom prst="rect">
             <a:avLst/>
@@ -4473,7 +4362,7 @@
       </p:sp>
       <p:sp>
         <p:nvSpPr>
-          <p:cNvPr id="20" name="Rectangle 19"/>
+          <p:cNvPr id="17" name="Rectangle 16"/>
           <p:cNvSpPr/>
           <p:nvPr/>
         </p:nvSpPr>
@@ -4516,7 +4405,7 @@
       </p:sp>
       <p:sp>
         <p:nvSpPr>
-          <p:cNvPr id="21" name="TextBox 20"/>
+          <p:cNvPr id="18" name="TextBox 17"/>
           <p:cNvSpPr txBox="1"/>
           <p:nvPr/>
         </p:nvSpPr>
@@ -4550,7 +4439,7 @@
       </p:sp>
       <p:sp>
         <p:nvSpPr>
-          <p:cNvPr id="22" name="TextBox 21"/>
+          <p:cNvPr id="19" name="TextBox 18"/>
           <p:cNvSpPr txBox="1"/>
           <p:nvPr/>
         </p:nvSpPr>
@@ -4584,7 +4473,7 @@
       </p:sp>
       <p:sp>
         <p:nvSpPr>
-          <p:cNvPr id="23" name="TextBox 22"/>
+          <p:cNvPr id="20" name="TextBox 19"/>
           <p:cNvSpPr txBox="1"/>
           <p:nvPr/>
         </p:nvSpPr>
@@ -4618,14 +4507,14 @@
       </p:sp>
       <p:sp>
         <p:nvSpPr>
-          <p:cNvPr id="24" name="Rectangle 23"/>
+          <p:cNvPr id="21" name="Rectangle 20"/>
           <p:cNvSpPr/>
           <p:nvPr/>
         </p:nvSpPr>
         <p:spPr>
           <a:xfrm>
             <a:off x="457200" y="5074920"/>
-            <a:ext cx="11247120" cy="384048"/>
+            <a:ext cx="11247120" cy="393192"/>
           </a:xfrm>
           <a:prstGeom prst="rect">
             <a:avLst/>
@@ -4663,7 +4552,7 @@
       </p:sp>
       <p:sp>
         <p:nvSpPr>
-          <p:cNvPr id="25" name="TextBox 24"/>
+          <p:cNvPr id="22" name="TextBox 21"/>
           <p:cNvSpPr txBox="1"/>
           <p:nvPr/>
         </p:nvSpPr>
@@ -4690,14 +4579,14 @@
                   <a:srgbClr val="1A2B3C"/>
                 </a:solidFill>
               </a:rPr>
-              <a:t>Random</a:t>
-            </a:r>
-          </a:p>
-        </p:txBody>
-      </p:sp>
-      <p:sp>
-        <p:nvSpPr>
-          <p:cNvPr id="26" name="TextBox 25"/>
+              <a:t>Zero-Shot LLM</a:t>
+            </a:r>
+          </a:p>
+        </p:txBody>
+      </p:sp>
+      <p:sp>
+        <p:nvSpPr>
+          <p:cNvPr id="23" name="TextBox 22"/>
           <p:cNvSpPr txBox="1"/>
           <p:nvPr/>
         </p:nvSpPr>
@@ -4724,14 +4613,14 @@
                   <a:srgbClr val="1A2B3C"/>
                 </a:solidFill>
               </a:rPr>
-              <a:t>0/30 episodes</a:t>
-            </a:r>
-          </a:p>
-        </p:txBody>
-      </p:sp>
-      <p:sp>
-        <p:nvSpPr>
-          <p:cNvPr id="27" name="TextBox 26"/>
+              <a:t>0/30 ep (5 ep/task)</a:t>
+            </a:r>
+          </a:p>
+        </p:txBody>
+      </p:sp>
+      <p:sp>
+        <p:nvSpPr>
+          <p:cNvPr id="24" name="TextBox 23"/>
           <p:cNvSpPr txBox="1"/>
           <p:nvPr/>
         </p:nvSpPr>
@@ -4758,21 +4647,21 @@
                   <a:srgbClr val="1A2B3C"/>
                 </a:solidFill>
               </a:rPr>
-              <a:t>Lower bound — tasks non-trivial</a:t>
-            </a:r>
-          </a:p>
-        </p:txBody>
-      </p:sp>
-      <p:sp>
-        <p:nvSpPr>
-          <p:cNvPr id="28" name="Rectangle 27"/>
+              <a:t>qwen2.5:3b - model-dependent result</a:t>
+            </a:r>
+          </a:p>
+        </p:txBody>
+      </p:sp>
+      <p:sp>
+        <p:nvSpPr>
+          <p:cNvPr id="25" name="Rectangle 24"/>
           <p:cNvSpPr/>
           <p:nvPr/>
         </p:nvSpPr>
         <p:spPr>
           <a:xfrm>
-            <a:off x="457200" y="5468112"/>
-            <a:ext cx="11247120" cy="384048"/>
+            <a:off x="457200" y="5495544"/>
+            <a:ext cx="11247120" cy="393192"/>
           </a:xfrm>
           <a:prstGeom prst="rect">
             <a:avLst/>
@@ -4810,13 +4699,13 @@
       </p:sp>
       <p:sp>
         <p:nvSpPr>
-          <p:cNvPr id="29" name="TextBox 28"/>
-          <p:cNvSpPr txBox="1"/>
-          <p:nvPr/>
-        </p:nvSpPr>
-        <p:spPr>
-          <a:xfrm>
-            <a:off x="502920" y="5541264"/>
+          <p:cNvPr id="26" name="TextBox 25"/>
+          <p:cNvSpPr txBox="1"/>
+          <p:nvPr/>
+        </p:nvSpPr>
+        <p:spPr>
+          <a:xfrm>
+            <a:off x="502920" y="5568696"/>
             <a:ext cx="3017520" cy="256032"/>
           </a:xfrm>
           <a:prstGeom prst="rect">
@@ -4837,20 +4726,20 @@
                   <a:srgbClr val="1A2B3C"/>
                 </a:solidFill>
               </a:rPr>
-              <a:t>Zero-Shot LLM</a:t>
-            </a:r>
-          </a:p>
-        </p:txBody>
-      </p:sp>
-      <p:sp>
-        <p:nvSpPr>
-          <p:cNvPr id="30" name="TextBox 29"/>
-          <p:cNvSpPr txBox="1"/>
-          <p:nvPr/>
-        </p:nvSpPr>
-        <p:spPr>
-          <a:xfrm>
-            <a:off x="3520439" y="5541264"/>
+              <a:t>Hint-Guided LLM</a:t>
+            </a:r>
+          </a:p>
+        </p:txBody>
+      </p:sp>
+      <p:sp>
+        <p:nvSpPr>
+          <p:cNvPr id="27" name="TextBox 26"/>
+          <p:cNvSpPr txBox="1"/>
+          <p:nvPr/>
+        </p:nvSpPr>
+        <p:spPr>
+          <a:xfrm>
+            <a:off x="3520439" y="5568696"/>
             <a:ext cx="2011680" cy="256032"/>
           </a:xfrm>
           <a:prstGeom prst="rect">
@@ -4871,20 +4760,20 @@
                   <a:srgbClr val="1A2B3C"/>
                 </a:solidFill>
               </a:rPr>
-              <a:t>0/30 ep (5 ep/task)</a:t>
-            </a:r>
-          </a:p>
-        </p:txBody>
-      </p:sp>
-      <p:sp>
-        <p:nvSpPr>
-          <p:cNvPr id="31" name="TextBox 30"/>
-          <p:cNvSpPr txBox="1"/>
-          <p:nvPr/>
-        </p:nvSpPr>
-        <p:spPr>
-          <a:xfrm>
-            <a:off x="5532120" y="5541264"/>
+              <a:t>24/30 ep (5 ep/task)</a:t>
+            </a:r>
+          </a:p>
+        </p:txBody>
+      </p:sp>
+      <p:sp>
+        <p:nvSpPr>
+          <p:cNvPr id="28" name="TextBox 27"/>
+          <p:cNvSpPr txBox="1"/>
+          <p:nvPr/>
+        </p:nvSpPr>
+        <p:spPr>
+          <a:xfrm>
+            <a:off x="5532120" y="5568696"/>
             <a:ext cx="6492240" cy="256032"/>
           </a:xfrm>
           <a:prstGeom prst="rect">
@@ -4905,21 +4794,21 @@
                   <a:srgbClr val="1A2B3C"/>
                 </a:solidFill>
               </a:rPr>
-              <a:t>qwen2.5:3b — model-dependent ceiling</a:t>
-            </a:r>
-          </a:p>
-        </p:txBody>
-      </p:sp>
-      <p:sp>
-        <p:nvSpPr>
-          <p:cNvPr id="32" name="Rectangle 31"/>
+              <a:t>SOP debug baseline - NOT autonomous capability</a:t>
+            </a:r>
+          </a:p>
+        </p:txBody>
+      </p:sp>
+      <p:sp>
+        <p:nvSpPr>
+          <p:cNvPr id="29" name="Rectangle 28"/>
           <p:cNvSpPr/>
           <p:nvPr/>
         </p:nvSpPr>
         <p:spPr>
           <a:xfrm>
-            <a:off x="457200" y="5861304"/>
-            <a:ext cx="11247120" cy="384048"/>
+            <a:off x="457200" y="5916168"/>
+            <a:ext cx="11247120" cy="393192"/>
           </a:xfrm>
           <a:prstGeom prst="rect">
             <a:avLst/>
@@ -4957,13 +4846,13 @@
       </p:sp>
       <p:sp>
         <p:nvSpPr>
-          <p:cNvPr id="33" name="TextBox 32"/>
-          <p:cNvSpPr txBox="1"/>
-          <p:nvPr/>
-        </p:nvSpPr>
-        <p:spPr>
-          <a:xfrm>
-            <a:off x="502920" y="5934456"/>
+          <p:cNvPr id="30" name="TextBox 29"/>
+          <p:cNvSpPr txBox="1"/>
+          <p:nvPr/>
+        </p:nvSpPr>
+        <p:spPr>
+          <a:xfrm>
+            <a:off x="502920" y="5989320"/>
             <a:ext cx="3017520" cy="256032"/>
           </a:xfrm>
           <a:prstGeom prst="rect">
@@ -4984,20 +4873,20 @@
                   <a:srgbClr val="1A2B3C"/>
                 </a:solidFill>
               </a:rPr>
-              <a:t>Hint-Guided LLM</a:t>
-            </a:r>
-          </a:p>
-        </p:txBody>
-      </p:sp>
-      <p:sp>
-        <p:nvSpPr>
-          <p:cNvPr id="34" name="TextBox 33"/>
-          <p:cNvSpPr txBox="1"/>
-          <p:nvPr/>
-        </p:nvSpPr>
-        <p:spPr>
-          <a:xfrm>
-            <a:off x="3520439" y="5934456"/>
+              <a:t>Oracle</a:t>
+            </a:r>
+          </a:p>
+        </p:txBody>
+      </p:sp>
+      <p:sp>
+        <p:nvSpPr>
+          <p:cNvPr id="31" name="TextBox 30"/>
+          <p:cNvSpPr txBox="1"/>
+          <p:nvPr/>
+        </p:nvSpPr>
+        <p:spPr>
+          <a:xfrm>
+            <a:off x="3520439" y="5989320"/>
             <a:ext cx="2011680" cy="256032"/>
           </a:xfrm>
           <a:prstGeom prst="rect">
@@ -5018,20 +4907,20 @@
                   <a:srgbClr val="1A2B3C"/>
                 </a:solidFill>
               </a:rPr>
-              <a:t>24/30 ep (5 ep/task)</a:t>
-            </a:r>
-          </a:p>
-        </p:txBody>
-      </p:sp>
-      <p:sp>
-        <p:nvSpPr>
-          <p:cNvPr id="35" name="TextBox 34"/>
-          <p:cNvSpPr txBox="1"/>
-          <p:nvPr/>
-        </p:nvSpPr>
-        <p:spPr>
-          <a:xfrm>
-            <a:off x="5532120" y="5934456"/>
+              <a:t>30/30 episodes</a:t>
+            </a:r>
+          </a:p>
+        </p:txBody>
+      </p:sp>
+      <p:sp>
+        <p:nvSpPr>
+          <p:cNvPr id="32" name="TextBox 31"/>
+          <p:cNvSpPr txBox="1"/>
+          <p:nvPr/>
+        </p:nvSpPr>
+        <p:spPr>
+          <a:xfrm>
+            <a:off x="5532120" y="5989320"/>
             <a:ext cx="6492240" cy="256032"/>
           </a:xfrm>
           <a:prstGeom prst="rect">
@@ -5052,154 +4941,7 @@
                   <a:srgbClr val="1A2B3C"/>
                 </a:solidFill>
               </a:rPr>
-              <a:t>SOP debug baseline — NOT autonomous capability</a:t>
-            </a:r>
-          </a:p>
-        </p:txBody>
-      </p:sp>
-      <p:sp>
-        <p:nvSpPr>
-          <p:cNvPr id="36" name="Rectangle 35"/>
-          <p:cNvSpPr/>
-          <p:nvPr/>
-        </p:nvSpPr>
-        <p:spPr>
-          <a:xfrm>
-            <a:off x="457200" y="6254496"/>
-            <a:ext cx="11247120" cy="384048"/>
-          </a:xfrm>
-          <a:prstGeom prst="rect">
-            <a:avLst/>
-          </a:prstGeom>
-          <a:solidFill>
-            <a:srgbClr val="EFF3F7"/>
-          </a:solidFill>
-          <a:ln w="3810">
-            <a:solidFill>
-              <a:srgbClr val="D0D8E0"/>
-            </a:solidFill>
-          </a:ln>
-        </p:spPr>
-        <p:style>
-          <a:lnRef idx="1">
-            <a:schemeClr val="accent1"/>
-          </a:lnRef>
-          <a:fillRef idx="3">
-            <a:schemeClr val="accent1"/>
-          </a:fillRef>
-          <a:effectRef idx="2">
-            <a:schemeClr val="accent1"/>
-          </a:effectRef>
-          <a:fontRef idx="minor">
-            <a:schemeClr val="lt1"/>
-          </a:fontRef>
-        </p:style>
-        <p:txBody>
-          <a:bodyPr rtlCol="0" anchor="ctr"/>
-          <a:lstStyle/>
-          <a:p>
-            <a:pPr algn="ctr"/>
-          </a:p>
-        </p:txBody>
-      </p:sp>
-      <p:sp>
-        <p:nvSpPr>
-          <p:cNvPr id="37" name="TextBox 36"/>
-          <p:cNvSpPr txBox="1"/>
-          <p:nvPr/>
-        </p:nvSpPr>
-        <p:spPr>
-          <a:xfrm>
-            <a:off x="502920" y="6327648"/>
-            <a:ext cx="3017520" cy="256032"/>
-          </a:xfrm>
-          <a:prstGeom prst="rect">
-            <a:avLst/>
-          </a:prstGeom>
-          <a:noFill/>
-        </p:spPr>
-        <p:txBody>
-          <a:bodyPr wrap="square">
-            <a:spAutoFit/>
-          </a:bodyPr>
-          <a:lstStyle/>
-          <a:p>
-            <a:pPr algn="l"/>
-            <a:r>
-              <a:rPr sz="1000" b="0" i="0">
-                <a:solidFill>
-                  <a:srgbClr val="1A2B3C"/>
-                </a:solidFill>
-              </a:rPr>
-              <a:t>Oracle</a:t>
-            </a:r>
-          </a:p>
-        </p:txBody>
-      </p:sp>
-      <p:sp>
-        <p:nvSpPr>
-          <p:cNvPr id="38" name="TextBox 37"/>
-          <p:cNvSpPr txBox="1"/>
-          <p:nvPr/>
-        </p:nvSpPr>
-        <p:spPr>
-          <a:xfrm>
-            <a:off x="3520439" y="6327648"/>
-            <a:ext cx="2011680" cy="256032"/>
-          </a:xfrm>
-          <a:prstGeom prst="rect">
-            <a:avLst/>
-          </a:prstGeom>
-          <a:noFill/>
-        </p:spPr>
-        <p:txBody>
-          <a:bodyPr wrap="square">
-            <a:spAutoFit/>
-          </a:bodyPr>
-          <a:lstStyle/>
-          <a:p>
-            <a:pPr algn="l"/>
-            <a:r>
-              <a:rPr sz="1000" b="0" i="0">
-                <a:solidFill>
-                  <a:srgbClr val="1A2B3C"/>
-                </a:solidFill>
-              </a:rPr>
-              <a:t>30/30 episodes</a:t>
-            </a:r>
-          </a:p>
-        </p:txBody>
-      </p:sp>
-      <p:sp>
-        <p:nvSpPr>
-          <p:cNvPr id="39" name="TextBox 38"/>
-          <p:cNvSpPr txBox="1"/>
-          <p:nvPr/>
-        </p:nvSpPr>
-        <p:spPr>
-          <a:xfrm>
-            <a:off x="5532120" y="6327648"/>
-            <a:ext cx="6492240" cy="256032"/>
-          </a:xfrm>
-          <a:prstGeom prst="rect">
-            <a:avLst/>
-          </a:prstGeom>
-          <a:noFill/>
-        </p:spPr>
-        <p:txBody>
-          <a:bodyPr wrap="square">
-            <a:spAutoFit/>
-          </a:bodyPr>
-          <a:lstStyle/>
-          <a:p>
-            <a:pPr algn="l"/>
-            <a:r>
-              <a:rPr sz="1000" b="0" i="0">
-                <a:solidFill>
-                  <a:srgbClr val="1A2B3C"/>
-                </a:solidFill>
-              </a:rPr>
-              <a:t>Scripted upper bound — proves solvability</a:t>
+              <a:t>Scripted upper bound - proves solvability</a:t>
             </a:r>
           </a:p>
         </p:txBody>
@@ -5337,7 +5079,7 @@
                   <a:srgbClr val="FFFFFF"/>
                 </a:solidFill>
               </a:rPr>
-              <a:t>SECTION 1 — THE ENVIRONMENT</a:t>
+              <a:t>SECTION 1: THE ENVIRONMENT</a:t>
             </a:r>
           </a:p>
         </p:txBody>
@@ -5484,7 +5226,7 @@
                   <a:srgbClr val="1AB070"/>
                 </a:solidFill>
               </a:rPr>
-              <a:t>✅  What this benchmark studies</a:t>
+              <a:t>What this benchmark studies</a:t>
             </a:r>
           </a:p>
         </p:txBody>
@@ -5518,7 +5260,7 @@
                   <a:srgbClr val="1A2B3C"/>
                 </a:solidFill>
               </a:rPr>
-              <a:t>•  Planning — multi-step reasoning across apps and roles</a:t>
+              <a:t>•  Planning: multi-step reasoning across apps and roles</a:t>
             </a:r>
           </a:p>
         </p:txBody>
@@ -5552,7 +5294,7 @@
                   <a:srgbClr val="1A2B3C"/>
                 </a:solidFill>
               </a:rPr>
-              <a:t>•  Tool use — structured semantic action under partial observability</a:t>
+              <a:t>•  Tool use: structured semantic action under partial observability</a:t>
             </a:r>
           </a:p>
         </p:txBody>
@@ -5586,7 +5328,7 @@
                   <a:srgbClr val="1A2B3C"/>
                 </a:solidFill>
               </a:rPr>
-              <a:t>•  Coordination — one agent's output blocks another's subgoal</a:t>
+              <a:t>•  Coordination: one agent's output blocks another's subgoal</a:t>
             </a:r>
           </a:p>
         </p:txBody>
@@ -5620,7 +5362,7 @@
                   <a:srgbClr val="1A2B3C"/>
                 </a:solidFill>
               </a:rPr>
-              <a:t>•  Delegation — transferring work across roles at the correct moment</a:t>
+              <a:t>•  Delegation: transferring work across roles at the correct moment</a:t>
             </a:r>
           </a:p>
         </p:txBody>
@@ -5654,7 +5396,7 @@
                   <a:srgbClr val="1A2B3C"/>
                 </a:solidFill>
               </a:rPr>
-              <a:t>•  Long-horizon reasoning — 8–17 subgoals, 25–45 step episodes</a:t>
+              <a:t>•  Long-horizon reasoning: 8-17 subgoals, 25-45 step episodes</a:t>
             </a:r>
           </a:p>
         </p:txBody>
@@ -5688,7 +5430,7 @@
                   <a:srgbClr val="1A2B3C"/>
                 </a:solidFill>
               </a:rPr>
-              <a:t>•  Partial observability — asymmetric info across heterogeneous agents</a:t>
+              <a:t>•  Partial observability: asymmetric info across heterogeneous agents</a:t>
             </a:r>
           </a:p>
         </p:txBody>
@@ -5722,7 +5464,7 @@
                   <a:srgbClr val="1A2B3C"/>
                 </a:solidFill>
               </a:rPr>
-              <a:t>•  Credit assignment — shaped reward over dependency-gated DAG</a:t>
+              <a:t>•  Credit assignment: shaped reward over dependency-gated DAG</a:t>
             </a:r>
           </a:p>
         </p:txBody>
@@ -5756,7 +5498,7 @@
                   <a:srgbClr val="1A2B3C"/>
                 </a:solidFill>
               </a:rPr>
-              <a:t>•  Error recovery — invalid action returns error; agent must adapt</a:t>
+              <a:t>•  Error recovery: invalid action returns error; agent must adapt</a:t>
             </a:r>
           </a:p>
         </p:txBody>
@@ -5835,7 +5577,7 @@
                   <a:srgbClr val="FFA52A"/>
                 </a:solidFill>
               </a:rPr>
-              <a:t>⚠  Honest Limitations</a:t>
+              <a:t>Honest Limitations</a:t>
             </a:r>
           </a:p>
         </p:txBody>
@@ -5869,7 +5611,7 @@
                   <a:srgbClr val="1A2B3C"/>
                 </a:solidFill>
               </a:rPr>
-              <a:t>•  Turn-based sequential — true parallel MARL needs action encoder</a:t>
+              <a:t>•  Turn-based sequential - true parallel MARL needs action encoder</a:t>
             </a:r>
           </a:p>
         </p:txBody>
@@ -5937,7 +5679,7 @@
                   <a:srgbClr val="1A2B3C"/>
                 </a:solidFill>
               </a:rPr>
-              <a:t>•  Entity IDs fixed per task family (Factory V1) — not entity-disjoint</a:t>
+              <a:t>•  Entity IDs fixed per task family (Factory V1) - not entity-disjoint</a:t>
             </a:r>
           </a:p>
         </p:txBody>
@@ -5971,7 +5713,7 @@
                   <a:srgbClr val="1A2B3C"/>
                 </a:solidFill>
               </a:rPr>
-              <a:t>•  Zero-shot measured on qwen2.5:3b only — model-dependent result</a:t>
+              <a:t>•  Zero-shot measured on qwen2.5:3b only - model-dependent result</a:t>
             </a:r>
           </a:p>
         </p:txBody>
@@ -6143,7 +5885,7 @@
                   <a:srgbClr val="FFFFFF"/>
                 </a:solidFill>
               </a:rPr>
-              <a:t>SECTION 1 — THE ENVIRONMENT</a:t>
+              <a:t>SECTION 1: THE ENVIRONMENT</a:t>
             </a:r>
           </a:p>
         </p:txBody>
@@ -6358,7 +6100,7 @@
                   <a:srgbClr val="1A2B3C"/>
                 </a:solidFill>
               </a:rPr>
-              <a:t>"inbox":    [email headers]  — body requires read_email</a:t>
+              <a:t>"inbox":    [email headers]  - body requires read_email</a:t>
             </a:r>
           </a:p>
         </p:txBody>
@@ -6392,7 +6134,7 @@
                   <a:srgbClr val="1A2B3C"/>
                 </a:solidFill>
               </a:rPr>
-              <a:t>"channels": [channel records]  — own channels only</a:t>
+              <a:t>"channels": [channel records]  - own channels only</a:t>
             </a:r>
           </a:p>
         </p:txBody>
@@ -6426,7 +6168,7 @@
                   <a:srgbClr val="1A2B3C"/>
                 </a:solidFill>
               </a:rPr>
-              <a:t>"calendar": [event records]  — own calendar only</a:t>
+              <a:t>"calendar": [event records]  - own calendar only</a:t>
             </a:r>
           </a:p>
         </p:txBody>
@@ -6724,7 +6466,7 @@
               </a:rPr>
               <a:t>obs, reward, terminated, truncated, info = env.step(action)
 info["eval"]  →  {progress, subgoals, reward_components}
-               # evaluator-only — NOT shown to agent</a:t>
+               # evaluator-only - NOT shown to agent</a:t>
             </a:r>
           </a:p>
         </p:txBody>
@@ -6836,8 +6578,8 @@
                 </a:solidFill>
               </a:rPr>
               <a:t>Training centralises info["eval"] subgoal labels for critic conditioning.
-Execution uses per-agent obs only — policies are fully decentralised.
-18 action types across 5 apps. Each agent sees only their permitted subset (14–18 actions).</a:t>
+Execution uses per-agent obs only - policies are fully decentralised.
+18 action types across 5 apps. Each agent sees only their permitted subset (14-18 actions).</a:t>
             </a:r>
           </a:p>
         </p:txBody>
@@ -6975,7 +6717,7 @@
                   <a:srgbClr val="FFFFFF"/>
                 </a:solidFill>
               </a:rPr>
-              <a:t>SECTION 1 — THE ENVIRONMENT</a:t>
+              <a:t>SECTION 1: THE ENVIRONMENT</a:t>
             </a:r>
           </a:p>
         </p:txBody>
@@ -7267,7 +7009,7 @@
                   <a:srgbClr val="1A2B3C"/>
                 </a:solidFill>
               </a:rPr>
-              <a:t>Can BC close 0% → 80%?</a:t>
+              <a:t>Can BC close 0% to 80%?</a:t>
             </a:r>
           </a:p>
         </p:txBody>
@@ -7595,7 +7337,7 @@
                   <a:srgbClr val="1A2B3C"/>
                 </a:solidFill>
               </a:rPr>
-              <a:t>PPO ± permission mask</a:t>
+              <a:t>PPO with/without permission mask</a:t>
             </a:r>
           </a:p>
         </p:txBody>
@@ -7742,7 +7484,7 @@
                   <a:srgbClr val="1A2B3C"/>
                 </a:solidFill>
               </a:rPr>
-              <a:t>RL across easy → adversarial presets</a:t>
+              <a:t>RL across easy to adversarial presets</a:t>
             </a:r>
           </a:p>
         </p:txBody>
@@ -7889,7 +7631,7 @@
                   <a:srgbClr val="1A2B3C"/>
                 </a:solidFill>
               </a:rPr>
-              <a:t>Train 0–999k, test 2M–3M</a:t>
+              <a:t>Train 0-999k, test 2M-3M</a:t>
             </a:r>
           </a:p>
         </p:txBody>
@@ -8294,7 +8036,7 @@
                   <a:srgbClr val="2E9CFF"/>
                 </a:solidFill>
               </a:rPr>
-              <a:t>Next: Behavioral Cloning on hint-guided trajectories  →  PPO against shaped reward  →  entity-disjoint OOD evaluation via Factory V2</a:t>
+              <a:t>Next: Behavioral Cloning on hint-guided trajectories → PPO against shaped reward → entity-disjoint OOD evaluation via Factory V2</a:t>
             </a:r>
           </a:p>
         </p:txBody>
@@ -8579,7 +8321,7 @@
                 </a:solidFill>
               </a:rPr>
               <a:t>ScenarioFactory V1
-All 6 tasks — IMPLEMENTED</a:t>
+All 6 tasks - IMPLEMENTED</a:t>
             </a:r>
           </a:p>
         </p:txBody>
@@ -8656,8 +8398,8 @@
                   <a:srgbClr val="FFFFFF"/>
                 </a:solidFill>
               </a:rPr>
-              <a:t>Factory V2 — entity-level
-Vendor onboarding — PROTOTYPE</a:t>
+              <a:t>Factory V2 - entity-level
+Vendor onboarding - PROTOTYPE</a:t>
             </a:r>
           </a:p>
         </p:txBody>
@@ -8795,7 +8537,7 @@
                   <a:srgbClr val="FFFFFF"/>
                 </a:solidFill>
               </a:rPr>
-              <a:t>SECTION 2 — THE SCENARIO FACTORY</a:t>
+              <a:t>SECTION 2: THE SCENARIO FACTORY</a:t>
             </a:r>
           </a:p>
         </p:txBody>
@@ -8863,7 +8605,7 @@
                   <a:srgbClr val="2E9CFF"/>
                 </a:solidFill>
               </a:rPr>
-              <a:t>RL training requires seed-disjoint episodes — 6 handcrafted tasks are not enough</a:t>
+              <a:t>RL training requires seed-disjoint episodes - 6 handcrafted tasks are not enough</a:t>
             </a:r>
           </a:p>
         </p:txBody>
@@ -8974,7 +8716,7 @@
                   <a:srgbClr val="FFFFFF"/>
                 </a:solidFill>
               </a:rPr>
-              <a:t>Without Factory ✗</a:t>
+              <a:t>Without Factory</a:t>
             </a:r>
           </a:p>
         </p:txBody>
@@ -9008,7 +8750,7 @@
                   <a:srgbClr val="FFFFFF"/>
                 </a:solidFill>
               </a:rPr>
-              <a:t>With Factory ✓</a:t>
+              <a:t>With Factory</a:t>
             </a:r>
           </a:p>
         </p:txBody>
@@ -9268,7 +9010,7 @@
                   <a:srgbClr val="E53E3E"/>
                 </a:solidFill>
               </a:rPr>
-              <a:t>Impossible — train = test</a:t>
+              <a:t>Impossible - train = test</a:t>
             </a:r>
           </a:p>
         </p:txBody>
@@ -9449,7 +9191,7 @@
                   <a:srgbClr val="1AB070"/>
                 </a:solidFill>
               </a:rPr>
-              <a:t>easy → adversarial presets</a:t>
+              <a:t>easy to adversarial presets</a:t>
             </a:r>
           </a:p>
         </p:txBody>
@@ -9596,7 +9338,7 @@
                   <a:srgbClr val="1AB070"/>
                 </a:solidFill>
               </a:rPr>
-              <a:t>Same seed → identical episode</a:t>
+              <a:t>Same seed, identical episode</a:t>
             </a:r>
           </a:p>
         </p:txBody>
@@ -9881,7 +9623,7 @@
                   <a:srgbClr val="FFFFFF"/>
                 </a:solidFill>
               </a:rPr>
-              <a:t>SECTION 2 — THE SCENARIO FACTORY</a:t>
+              <a:t>SECTION 2: THE SCENARIO FACTORY</a:t>
             </a:r>
           </a:p>
         </p:txBody>
@@ -9915,7 +9657,7 @@
                   <a:srgbClr val="1A2B3C"/>
                 </a:solidFill>
               </a:rPr>
-              <a:t>ScenarioFactory V1 — Implemented</a:t>
+              <a:t>ScenarioFactory V1 - Implemented</a:t>
             </a:r>
           </a:p>
         </p:txBody>
@@ -10066,12 +9808,12 @@
           <a:p>
             <a:pPr algn="ctr"/>
             <a:r>
-              <a:rPr sz="1300" b="1" i="0">
+              <a:rPr sz="900" b="1" i="0">
                 <a:solidFill>
                   <a:srgbClr val="FFFFFF"/>
                 </a:solidFill>
               </a:rPr>
-              <a:t>✓</a:t>
+              <a:t>Yes</a:t>
             </a:r>
           </a:p>
         </p:txBody>
@@ -10256,12 +9998,12 @@
           <a:p>
             <a:pPr algn="ctr"/>
             <a:r>
-              <a:rPr sz="1300" b="1" i="0">
+              <a:rPr sz="900" b="1" i="0">
                 <a:solidFill>
                   <a:srgbClr val="FFFFFF"/>
                 </a:solidFill>
               </a:rPr>
-              <a:t>✓</a:t>
+              <a:t>Yes</a:t>
             </a:r>
           </a:p>
         </p:txBody>
@@ -10446,12 +10188,12 @@
           <a:p>
             <a:pPr algn="ctr"/>
             <a:r>
-              <a:rPr sz="1300" b="1" i="0">
+              <a:rPr sz="900" b="1" i="0">
                 <a:solidFill>
                   <a:srgbClr val="FFFFFF"/>
                 </a:solidFill>
               </a:rPr>
-              <a:t>✓</a:t>
+              <a:t>Yes</a:t>
             </a:r>
           </a:p>
         </p:txBody>
@@ -10636,12 +10378,12 @@
           <a:p>
             <a:pPr algn="ctr"/>
             <a:r>
-              <a:rPr sz="1300" b="1" i="0">
+              <a:rPr sz="900" b="1" i="0">
                 <a:solidFill>
                   <a:srgbClr val="FFFFFF"/>
                 </a:solidFill>
               </a:rPr>
-              <a:t>✓</a:t>
+              <a:t>Yes</a:t>
             </a:r>
           </a:p>
         </p:txBody>
@@ -10709,7 +10451,7 @@
                   <a:srgbClr val="8A9BAD"/>
                 </a:solidFill>
               </a:rPr>
-              <a:t>train: 0–999k  /  dev: 1M–2M  /  test: 2M–3M</a:t>
+              <a:t>train: 0-999k  /  dev: 1M-2M  /  test: 2M-3M</a:t>
             </a:r>
           </a:p>
         </p:txBody>
@@ -10826,12 +10568,12 @@
           <a:p>
             <a:pPr algn="ctr"/>
             <a:r>
-              <a:rPr sz="1300" b="1" i="0">
+              <a:rPr sz="900" b="1" i="0">
                 <a:solidFill>
                   <a:srgbClr val="FFFFFF"/>
                 </a:solidFill>
               </a:rPr>
-              <a:t>✓</a:t>
+              <a:t>Yes</a:t>
             </a:r>
           </a:p>
         </p:txBody>
@@ -11016,12 +10758,12 @@
           <a:p>
             <a:pPr algn="ctr"/>
             <a:r>
-              <a:rPr sz="1300" b="1" i="0">
+              <a:rPr sz="900" b="1" i="0">
                 <a:solidFill>
                   <a:srgbClr val="FFFFFF"/>
                 </a:solidFill>
               </a:rPr>
-              <a:t>✓</a:t>
+              <a:t>Yes</a:t>
             </a:r>
           </a:p>
         </p:txBody>
@@ -11206,12 +10948,12 @@
           <a:p>
             <a:pPr algn="ctr"/>
             <a:r>
-              <a:rPr sz="1300" b="1" i="0">
+              <a:rPr sz="900" b="1" i="0">
                 <a:solidFill>
                   <a:srgbClr val="FFFFFF"/>
                 </a:solidFill>
               </a:rPr>
-              <a:t>✓</a:t>
+              <a:t>Yes</a:t>
             </a:r>
           </a:p>
         </p:txBody>
@@ -11496,7 +11238,7 @@
                   <a:srgbClr val="FFFFFF"/>
                 </a:solidFill>
               </a:rPr>
-              <a:t>SECTION 2 — THE SCENARIO FACTORY</a:t>
+              <a:t>SECTION 2: THE SCENARIO FACTORY</a:t>
             </a:r>
           </a:p>
         </p:txBody>
@@ -11530,7 +11272,7 @@
                   <a:srgbClr val="1A2B3C"/>
                 </a:solidFill>
               </a:rPr>
-              <a:t>Factory V2 — Entity-Level World Generation</a:t>
+              <a:t>Factory V2 - Entity-Level World Generation</a:t>
             </a:r>
           </a:p>
         </p:txBody>
@@ -11847,7 +11589,7 @@
                   <a:srgbClr val="1AB070"/>
                 </a:solidFill>
               </a:rPr>
-              <a:t>Oracle: ✓ PASS</a:t>
+              <a:t>Oracle: PASS</a:t>
             </a:r>
           </a:p>
         </p:txBody>
@@ -12130,7 +11872,7 @@
                   <a:srgbClr val="1AB070"/>
                 </a:solidFill>
               </a:rPr>
-              <a:t>Oracle: ✓ PASS</a:t>
+              <a:t>Oracle: PASS</a:t>
             </a:r>
           </a:p>
         </p:txBody>
@@ -12346,7 +12088,7 @@
                   <a:srgbClr val="FFFFFF"/>
                 </a:solidFill>
               </a:rPr>
-              <a:t>SECTION 2 — THE SCENARIO FACTORY</a:t>
+              <a:t>SECTION 2: THE SCENARIO FACTORY</a:t>
             </a:r>
           </a:p>
         </p:txBody>
@@ -12414,7 +12156,7 @@
                   <a:srgbClr val="2E9CFF"/>
                 </a:solidFill>
               </a:rPr>
-              <a:t>Delivered · Experimental · Planned — clearly separated</a:t>
+              <a:t>Delivered · Experimental · Planned - clearly separated</a:t>
             </a:r>
           </a:p>
         </p:txBody>
@@ -12491,7 +12233,7 @@
                   <a:srgbClr val="FFFFFF"/>
                 </a:solidFill>
               </a:rPr>
-              <a:t>IMPLEMENTED ✅</a:t>
+              <a:t>IMPLEMENTED</a:t>
             </a:r>
           </a:p>
         </p:txBody>
@@ -13279,7 +13021,7 @@
                   <a:srgbClr val="FFFFFF"/>
                 </a:solidFill>
               </a:rPr>
-              <a:t>PROTOTYPE / EXPERIMENTAL ⚗</a:t>
+              <a:t>PROTOTYPE / EXPERIMENTAL</a:t>
             </a:r>
           </a:p>
         </p:txBody>
@@ -13672,7 +13414,7 @@
                   <a:srgbClr val="FFFFFF"/>
                 </a:solidFill>
               </a:rPr>
-              <a:t>ROADMAP 🗺</a:t>
+              <a:t>ROADMAP</a:t>
             </a:r>
           </a:p>
         </p:txBody>
@@ -14361,7 +14103,7 @@
                   <a:srgbClr val="FFFFFF"/>
                 </a:solidFill>
               </a:rPr>
-              <a:t>SECTION 2 — THE SCENARIO FACTORY</a:t>
+              <a:t>SECTION 2: THE SCENARIO FACTORY</a:t>
             </a:r>
           </a:p>
         </p:txBody>
@@ -14764,7 +14506,7 @@
                   <a:srgbClr val="1A2B3C"/>
                 </a:solidFill>
               </a:rPr>
-              <a:t>Minimal noise — near-direct path</a:t>
+              <a:t>Minimal noise - near-direct path</a:t>
             </a:r>
           </a:p>
         </p:txBody>
@@ -15144,7 +14886,7 @@
                   <a:srgbClr val="1A2B3C"/>
                 </a:solidFill>
               </a:rPr>
-              <a:t>Heavy noise — same domain, wrong details</a:t>
+              <a:t>Heavy noise - same domain, wrong details</a:t>
             </a:r>
           </a:p>
         </p:txBody>
@@ -15479,7 +15221,7 @@
                   <a:srgbClr val="FFFFFF"/>
                 </a:solidFill>
               </a:rPr>
-              <a:t>0 – 999k</a:t>
+              <a:t>0 to 999k</a:t>
             </a:r>
           </a:p>
         </p:txBody>
@@ -15547,7 +15289,7 @@
                   <a:srgbClr val="FFFFFF"/>
                 </a:solidFill>
               </a:rPr>
-              <a:t>1M – 2M</a:t>
+              <a:t>1M to 2M</a:t>
             </a:r>
           </a:p>
         </p:txBody>
@@ -15615,7 +15357,7 @@
                   <a:srgbClr val="FFFFFF"/>
                 </a:solidFill>
               </a:rPr>
-              <a:t>2M – 3M</a:t>
+              <a:t>2M to 3M</a:t>
             </a:r>
           </a:p>
         </p:txBody>
@@ -15762,7 +15504,7 @@
                   <a:srgbClr val="8A9BAD"/>
                 </a:solidFill>
               </a:rPr>
-              <a:t># Oracle = 100% at all difficulty levels  ·  Random = 0% at all difficulty levels</a:t>
+              <a:t># Oracle = 100% at all difficulty levels  ·  Zero-Shot = 0% at all difficulty levels</a:t>
             </a:r>
           </a:p>
         </p:txBody>
@@ -15839,7 +15581,7 @@
                   <a:srgbClr val="2E9CFF"/>
                 </a:solidFill>
               </a:rPr>
-              <a:t>Disjoint seed ranges prevent episode reuse across train/dev/test. Same seed → identical episode, always — fully reproducible.</a:t>
+              <a:t>Disjoint seed ranges prevent episode reuse across train/dev/test. Same seed → identical episode, always - fully reproducible.</a:t>
             </a:r>
           </a:p>
         </p:txBody>
@@ -15977,7 +15719,7 @@
                   <a:srgbClr val="FFFFFF"/>
                 </a:solidFill>
               </a:rPr>
-              <a:t>SECTION 1 — THE ENVIRONMENT</a:t>
+              <a:t>SECTION 1: THE ENVIRONMENT</a:t>
             </a:r>
           </a:p>
         </p:txBody>
@@ -16987,7 +16729,7 @@
                   <a:srgbClr val="0A6A42"/>
                 </a:solidFill>
               </a:rPr>
-              <a:t>Per-role × per-app × per-sheet</a:t>
+              <a:t>Per-role x per-app x per-sheet</a:t>
             </a:r>
           </a:p>
         </p:txBody>
@@ -17145,7 +16887,7 @@
                   <a:srgbClr val="6A6A6A"/>
                 </a:solidFill>
               </a:rPr>
-              <a:t>1–5 steps</a:t>
+              <a:t>1-5 steps</a:t>
             </a:r>
           </a:p>
         </p:txBody>
@@ -17224,7 +16966,7 @@
                   <a:srgbClr val="0A6A42"/>
                 </a:solidFill>
               </a:rPr>
-              <a:t>8–17 subgoals, 25–45 steps</a:t>
+              <a:t>8-17 subgoals, 25-45 steps</a:t>
             </a:r>
           </a:p>
         </p:txBody>
@@ -17461,7 +17203,7 @@
                   <a:srgbClr val="0A6A42"/>
                 </a:solidFill>
               </a:rPr>
-              <a:t>Gated DAG — later credit blocked</a:t>
+              <a:t>Gated DAG: later credit blocked</a:t>
             </a:r>
           </a:p>
         </p:txBody>
@@ -18150,7 +17892,7 @@
                   <a:srgbClr val="FFFFFF"/>
                 </a:solidFill>
               </a:rPr>
-              <a:t>SECTION 2 — THE SCENARIO FACTORY  ·  CLOSING</a:t>
+              <a:t>SECTION 2: THE SCENARIO FACTORY  ·  CLOSING</a:t>
             </a:r>
           </a:p>
         </p:txBody>
@@ -18510,7 +18252,7 @@
                   <a:srgbClr val="FFFFFF"/>
                 </a:solidFill>
               </a:rPr>
-              <a:t>✅  6 long-horizon multi-agent tasks</a:t>
+              <a:t>  6 long-horizon multi-agent tasks</a:t>
             </a:r>
           </a:p>
         </p:txBody>
@@ -18544,7 +18286,7 @@
                   <a:srgbClr val="FFFFFF"/>
                 </a:solidFill>
               </a:rPr>
-              <a:t>✅  5 apps · 5 agents · role-based permissions</a:t>
+              <a:t>  5 apps · 5 agents · role-based permissions</a:t>
             </a:r>
           </a:p>
         </p:txBody>
@@ -18578,7 +18320,7 @@
                   <a:srgbClr val="FFFFFF"/>
                 </a:solidFill>
               </a:rPr>
-              <a:t>✅  Dependency-gated subgoal DAGs</a:t>
+              <a:t>  Dependency-gated subgoal DAGs</a:t>
             </a:r>
           </a:p>
         </p:txBody>
@@ -18612,7 +18354,7 @@
                   <a:srgbClr val="FFFFFF"/>
                 </a:solidFill>
               </a:rPr>
-              <a:t>✅  Deterministic DB-state verification</a:t>
+              <a:t>  Deterministic DB-state verification</a:t>
             </a:r>
           </a:p>
         </p:txBody>
@@ -18646,7 +18388,7 @@
                   <a:srgbClr val="FFFFFF"/>
                 </a:solidFill>
               </a:rPr>
-              <a:t>✅  Oracle 30/30 · Hint-guided 24/30 · Zero-Shot 0/30</a:t>
+              <a:t>  Oracle 30/30 · Hint-guided 24/30 · Zero-Shot 0/30</a:t>
             </a:r>
           </a:p>
         </p:txBody>
@@ -18680,7 +18422,7 @@
                   <a:srgbClr val="FFFFFF"/>
                 </a:solidFill>
               </a:rPr>
-              <a:t>✅  ScenarioFactory: seeds × difficulty × splits</a:t>
+              <a:t>  ScenarioFactory: seeds x difficulty x splits</a:t>
             </a:r>
           </a:p>
         </p:txBody>
@@ -18714,7 +18456,7 @@
                   <a:srgbClr val="FFFFFF"/>
                 </a:solidFill>
               </a:rPr>
-              <a:t>✅  Factory V2: entity-level world generation (prototype)</a:t>
+              <a:t>  Factory V2: entity-level world generation (prototype)</a:t>
             </a:r>
           </a:p>
         </p:txBody>
@@ -18748,7 +18490,7 @@
                   <a:srgbClr val="FFFFFF"/>
                 </a:solidFill>
               </a:rPr>
-              <a:t>✅  118 automated tests · 0 flaky</a:t>
+              <a:t>  118 automated tests · 0 flaky</a:t>
             </a:r>
           </a:p>
         </p:txBody>
@@ -18782,7 +18524,7 @@
                   <a:srgbClr val="FFFFFF"/>
                 </a:solidFill>
               </a:rPr>
-              <a:t>✅  Docker Compose reproducible deployment</a:t>
+              <a:t>  Docker Compose reproducible deployment</a:t>
             </a:r>
           </a:p>
         </p:txBody>
@@ -18997,7 +18739,7 @@
                   <a:srgbClr val="FFFFFF"/>
                 </a:solidFill>
               </a:rPr>
-              <a:t>SECTION 1 — THE ENVIRONMENT</a:t>
+              <a:t>SECTION 1: THE ENVIRONMENT</a:t>
             </a:r>
           </a:p>
         </p:txBody>
@@ -19561,7 +19303,7 @@
                   <a:srgbClr val="2E9CFF"/>
                 </a:solidFill>
               </a:rPr>
-              <a:t>SQLite  —  Shared Company State</a:t>
+              <a:t>SQLite: Shared Company State</a:t>
             </a:r>
           </a:p>
         </p:txBody>
@@ -19785,7 +19527,7 @@
                   <a:srgbClr val="1A2B3C"/>
                 </a:solidFill>
               </a:rPr>
-              <a:t>•  Evaluator state is NOT visible to agents — info["eval"] is separate</a:t>
+              <a:t>•  Evaluator state is NOT visible to agents - info["eval"] is separate</a:t>
             </a:r>
           </a:p>
         </p:txBody>
@@ -19819,7 +19561,7 @@
                   <a:srgbClr val="1A2B3C"/>
                 </a:solidFill>
               </a:rPr>
-              <a:t>•  Semantic tool actions — malformed calls are invalid transitions, not crashes</a:t>
+              <a:t>•  Semantic tool actions: malformed calls are invalid transitions, not crashes</a:t>
             </a:r>
           </a:p>
         </p:txBody>
@@ -19853,7 +19595,7 @@
                   <a:srgbClr val="1A2B3C"/>
                 </a:solidFill>
               </a:rPr>
-              <a:t>•  An agent cannot succeed by claiming 'task complete' in Slack — the DB must match</a:t>
+              <a:t>•  An agent cannot succeed by claiming 'task complete' in Slack - the DB must match</a:t>
             </a:r>
           </a:p>
         </p:txBody>
@@ -19991,7 +19733,7 @@
                   <a:srgbClr val="FFFFFF"/>
                 </a:solidFill>
               </a:rPr>
-              <a:t>SECTION 1 — THE ENVIRONMENT</a:t>
+              <a:t>SECTION 1: THE ENVIRONMENT</a:t>
             </a:r>
           </a:p>
         </p:txBody>
@@ -20750,7 +20492,7 @@
                   <a:srgbClr val="C8E0FF"/>
                 </a:solidFill>
               </a:rPr>
-              <a:t>DAG + subgoal checks  →  reward + info["eval"]</a:t>
+              <a:t>DAG + subgoal checks → reward + info["eval"]</a:t>
             </a:r>
           </a:p>
         </p:txBody>
@@ -20852,7 +20594,7 @@
                   <a:srgbClr val="8A9BAD"/>
                 </a:solidFill>
               </a:rPr>
-              <a:t>•  PettingZoo AEC adapter available — EXPERIMENTAL (not fully tested)</a:t>
+              <a:t>•  PettingZoo AEC adapter available - EXPERIMENTAL (not fully tested)</a:t>
             </a:r>
           </a:p>
         </p:txBody>
@@ -20990,7 +20732,7 @@
                   <a:srgbClr val="FFFFFF"/>
                 </a:solidFill>
               </a:rPr>
-              <a:t>SECTION 1 — THE ENVIRONMENT</a:t>
+              <a:t>SECTION 1: THE ENVIRONMENT</a:t>
             </a:r>
           </a:p>
         </p:txBody>
@@ -21071,8 +20813,8 @@
         </p:nvSpPr>
         <p:spPr>
           <a:xfrm>
-            <a:off x="365760" y="1874519"/>
-            <a:ext cx="1417320" cy="566928"/>
+            <a:off x="365760" y="1828800"/>
+            <a:ext cx="1417320" cy="658368"/>
           </a:xfrm>
           <a:prstGeom prst="rect">
             <a:avLst/>
@@ -21114,23 +20856,23 @@
         </p:nvSpPr>
         <p:spPr>
           <a:xfrm>
-            <a:off x="411480" y="1965960"/>
-            <a:ext cx="1371600" cy="384048"/>
-          </a:xfrm>
-          <a:prstGeom prst="rect">
-            <a:avLst/>
-          </a:prstGeom>
-          <a:noFill/>
-        </p:spPr>
-        <p:txBody>
-          <a:bodyPr wrap="square">
-            <a:spAutoFit/>
-          </a:bodyPr>
-          <a:lstStyle/>
-          <a:p>
-            <a:pPr algn="ctr"/>
-            <a:r>
-              <a:rPr sz="1100" b="1" i="0">
+            <a:off x="411480" y="1828800"/>
+            <a:ext cx="1371600" cy="658368"/>
+          </a:xfrm>
+          <a:prstGeom prst="rect">
+            <a:avLst/>
+          </a:prstGeom>
+          <a:noFill/>
+        </p:spPr>
+        <p:txBody>
+          <a:bodyPr wrap="square" anchor="ctr">
+            <a:spAutoFit/>
+          </a:bodyPr>
+          <a:lstStyle/>
+          <a:p>
+            <a:pPr algn="ctr"/>
+            <a:r>
+              <a:rPr sz="1200" b="1" i="0">
                 <a:solidFill>
                   <a:srgbClr val="FFFFFF"/>
                 </a:solidFill>
@@ -21148,8 +20890,8 @@
         </p:nvSpPr>
         <p:spPr>
           <a:xfrm>
-            <a:off x="1828800" y="1874519"/>
-            <a:ext cx="2148840" cy="566928"/>
+            <a:off x="1828800" y="1828800"/>
+            <a:ext cx="2240280" cy="658368"/>
           </a:xfrm>
           <a:prstGeom prst="rect">
             <a:avLst/>
@@ -21191,23 +20933,23 @@
         </p:nvSpPr>
         <p:spPr>
           <a:xfrm>
-            <a:off x="1874519" y="1965960"/>
-            <a:ext cx="2103120" cy="384048"/>
-          </a:xfrm>
-          <a:prstGeom prst="rect">
-            <a:avLst/>
-          </a:prstGeom>
-          <a:noFill/>
-        </p:spPr>
-        <p:txBody>
-          <a:bodyPr wrap="square">
-            <a:spAutoFit/>
-          </a:bodyPr>
-          <a:lstStyle/>
-          <a:p>
-            <a:pPr algn="ctr"/>
-            <a:r>
-              <a:rPr sz="1100" b="1" i="0">
+            <a:off x="1874519" y="1828800"/>
+            <a:ext cx="2194560" cy="658368"/>
+          </a:xfrm>
+          <a:prstGeom prst="rect">
+            <a:avLst/>
+          </a:prstGeom>
+          <a:noFill/>
+        </p:spPr>
+        <p:txBody>
+          <a:bodyPr wrap="square" anchor="ctr">
+            <a:spAutoFit/>
+          </a:bodyPr>
+          <a:lstStyle/>
+          <a:p>
+            <a:pPr algn="ctr"/>
+            <a:r>
+              <a:rPr sz="1200" b="1" i="0">
                 <a:solidFill>
                   <a:srgbClr val="FFFFFF"/>
                 </a:solidFill>
@@ -21225,8 +20967,8 @@
         </p:nvSpPr>
         <p:spPr>
           <a:xfrm>
-            <a:off x="4023360" y="1874519"/>
-            <a:ext cx="777240" cy="566928"/>
+            <a:off x="4114800" y="1828800"/>
+            <a:ext cx="822959" cy="658368"/>
           </a:xfrm>
           <a:prstGeom prst="rect">
             <a:avLst/>
@@ -21268,23 +21010,23 @@
         </p:nvSpPr>
         <p:spPr>
           <a:xfrm>
-            <a:off x="4069080" y="1965960"/>
-            <a:ext cx="731520" cy="384048"/>
-          </a:xfrm>
-          <a:prstGeom prst="rect">
-            <a:avLst/>
-          </a:prstGeom>
-          <a:noFill/>
-        </p:spPr>
-        <p:txBody>
-          <a:bodyPr wrap="square">
-            <a:spAutoFit/>
-          </a:bodyPr>
-          <a:lstStyle/>
-          <a:p>
-            <a:pPr algn="ctr"/>
-            <a:r>
-              <a:rPr sz="1100" b="1" i="0">
+            <a:off x="4160520" y="1828800"/>
+            <a:ext cx="777240" cy="658368"/>
+          </a:xfrm>
+          <a:prstGeom prst="rect">
+            <a:avLst/>
+          </a:prstGeom>
+          <a:noFill/>
+        </p:spPr>
+        <p:txBody>
+          <a:bodyPr wrap="square" anchor="ctr">
+            <a:spAutoFit/>
+          </a:bodyPr>
+          <a:lstStyle/>
+          <a:p>
+            <a:pPr algn="ctr"/>
+            <a:r>
+              <a:rPr sz="1200" b="1" i="0">
                 <a:solidFill>
                   <a:srgbClr val="FFFFFF"/>
                 </a:solidFill>
@@ -21302,8 +21044,8 @@
         </p:nvSpPr>
         <p:spPr>
           <a:xfrm>
-            <a:off x="4846320" y="1874519"/>
-            <a:ext cx="777240" cy="566928"/>
+            <a:off x="4983480" y="1828800"/>
+            <a:ext cx="822959" cy="658368"/>
           </a:xfrm>
           <a:prstGeom prst="rect">
             <a:avLst/>
@@ -21345,23 +21087,23 @@
         </p:nvSpPr>
         <p:spPr>
           <a:xfrm>
-            <a:off x="4892040" y="1965960"/>
-            <a:ext cx="731520" cy="384048"/>
-          </a:xfrm>
-          <a:prstGeom prst="rect">
-            <a:avLst/>
-          </a:prstGeom>
-          <a:noFill/>
-        </p:spPr>
-        <p:txBody>
-          <a:bodyPr wrap="square">
-            <a:spAutoFit/>
-          </a:bodyPr>
-          <a:lstStyle/>
-          <a:p>
-            <a:pPr algn="ctr"/>
-            <a:r>
-              <a:rPr sz="1100" b="1" i="0">
+            <a:off x="5029200" y="1828800"/>
+            <a:ext cx="777240" cy="658368"/>
+          </a:xfrm>
+          <a:prstGeom prst="rect">
+            <a:avLst/>
+          </a:prstGeom>
+          <a:noFill/>
+        </p:spPr>
+        <p:txBody>
+          <a:bodyPr wrap="square" anchor="ctr">
+            <a:spAutoFit/>
+          </a:bodyPr>
+          <a:lstStyle/>
+          <a:p>
+            <a:pPr algn="ctr"/>
+            <a:r>
+              <a:rPr sz="1200" b="1" i="0">
                 <a:solidFill>
                   <a:srgbClr val="FFFFFF"/>
                 </a:solidFill>
@@ -21379,8 +21121,8 @@
         </p:nvSpPr>
         <p:spPr>
           <a:xfrm>
-            <a:off x="5669280" y="1874519"/>
-            <a:ext cx="777240" cy="566928"/>
+            <a:off x="5852160" y="1828800"/>
+            <a:ext cx="731519" cy="658368"/>
           </a:xfrm>
           <a:prstGeom prst="rect">
             <a:avLst/>
@@ -21422,23 +21164,23 @@
         </p:nvSpPr>
         <p:spPr>
           <a:xfrm>
-            <a:off x="5715000" y="1965960"/>
-            <a:ext cx="731520" cy="384048"/>
-          </a:xfrm>
-          <a:prstGeom prst="rect">
-            <a:avLst/>
-          </a:prstGeom>
-          <a:noFill/>
-        </p:spPr>
-        <p:txBody>
-          <a:bodyPr wrap="square">
-            <a:spAutoFit/>
-          </a:bodyPr>
-          <a:lstStyle/>
-          <a:p>
-            <a:pPr algn="ctr"/>
-            <a:r>
-              <a:rPr sz="1100" b="1" i="0">
+            <a:off x="5897880" y="1828800"/>
+            <a:ext cx="685800" cy="658368"/>
+          </a:xfrm>
+          <a:prstGeom prst="rect">
+            <a:avLst/>
+          </a:prstGeom>
+          <a:noFill/>
+        </p:spPr>
+        <p:txBody>
+          <a:bodyPr wrap="square" anchor="ctr">
+            <a:spAutoFit/>
+          </a:bodyPr>
+          <a:lstStyle/>
+          <a:p>
+            <a:pPr algn="ctr"/>
+            <a:r>
+              <a:rPr sz="1200" b="1" i="0">
                 <a:solidFill>
                   <a:srgbClr val="FFFFFF"/>
                 </a:solidFill>
@@ -21456,8 +21198,8 @@
         </p:nvSpPr>
         <p:spPr>
           <a:xfrm>
-            <a:off x="6492240" y="1874519"/>
-            <a:ext cx="960120" cy="566928"/>
+            <a:off x="6629400" y="1828800"/>
+            <a:ext cx="960120" cy="658368"/>
           </a:xfrm>
           <a:prstGeom prst="rect">
             <a:avLst/>
@@ -21499,23 +21241,23 @@
         </p:nvSpPr>
         <p:spPr>
           <a:xfrm>
-            <a:off x="6537960" y="1965960"/>
-            <a:ext cx="914400" cy="384048"/>
-          </a:xfrm>
-          <a:prstGeom prst="rect">
-            <a:avLst/>
-          </a:prstGeom>
-          <a:noFill/>
-        </p:spPr>
-        <p:txBody>
-          <a:bodyPr wrap="square">
-            <a:spAutoFit/>
-          </a:bodyPr>
-          <a:lstStyle/>
-          <a:p>
-            <a:pPr algn="ctr"/>
-            <a:r>
-              <a:rPr sz="1100" b="1" i="0">
+            <a:off x="6675120" y="1828800"/>
+            <a:ext cx="914400" cy="658368"/>
+          </a:xfrm>
+          <a:prstGeom prst="rect">
+            <a:avLst/>
+          </a:prstGeom>
+          <a:noFill/>
+        </p:spPr>
+        <p:txBody>
+          <a:bodyPr wrap="square" anchor="ctr">
+            <a:spAutoFit/>
+          </a:bodyPr>
+          <a:lstStyle/>
+          <a:p>
+            <a:pPr algn="ctr"/>
+            <a:r>
+              <a:rPr sz="1200" b="1" i="0">
                 <a:solidFill>
                   <a:srgbClr val="FFFFFF"/>
                 </a:solidFill>
@@ -21533,8 +21275,8 @@
         </p:nvSpPr>
         <p:spPr>
           <a:xfrm>
-            <a:off x="7498080" y="1874519"/>
-            <a:ext cx="1143000" cy="566928"/>
+            <a:off x="7635240" y="1828800"/>
+            <a:ext cx="1261872" cy="658368"/>
           </a:xfrm>
           <a:prstGeom prst="rect">
             <a:avLst/>
@@ -21576,23 +21318,23 @@
         </p:nvSpPr>
         <p:spPr>
           <a:xfrm>
-            <a:off x="7543800" y="1965960"/>
-            <a:ext cx="1097280" cy="384048"/>
-          </a:xfrm>
-          <a:prstGeom prst="rect">
-            <a:avLst/>
-          </a:prstGeom>
-          <a:noFill/>
-        </p:spPr>
-        <p:txBody>
-          <a:bodyPr wrap="square">
-            <a:spAutoFit/>
-          </a:bodyPr>
-          <a:lstStyle/>
-          <a:p>
-            <a:pPr algn="ctr"/>
-            <a:r>
-              <a:rPr sz="1100" b="1" i="0">
+            <a:off x="7680960" y="1828800"/>
+            <a:ext cx="1216151" cy="658368"/>
+          </a:xfrm>
+          <a:prstGeom prst="rect">
+            <a:avLst/>
+          </a:prstGeom>
+          <a:noFill/>
+        </p:spPr>
+        <p:txBody>
+          <a:bodyPr wrap="square" anchor="ctr">
+            <a:spAutoFit/>
+          </a:bodyPr>
+          <a:lstStyle/>
+          <a:p>
+            <a:pPr algn="ctr"/>
+            <a:r>
+              <a:rPr sz="1200" b="1" i="0">
                 <a:solidFill>
                   <a:srgbClr val="FFFFFF"/>
                 </a:solidFill>
@@ -21610,8 +21352,8 @@
         </p:nvSpPr>
         <p:spPr>
           <a:xfrm>
-            <a:off x="365760" y="2441448"/>
-            <a:ext cx="1417320" cy="566928"/>
+            <a:off x="365760" y="2487168"/>
+            <a:ext cx="1417320" cy="658368"/>
           </a:xfrm>
           <a:prstGeom prst="rect">
             <a:avLst/>
@@ -21655,16 +21397,16 @@
         </p:nvSpPr>
         <p:spPr>
           <a:xfrm>
-            <a:off x="411480" y="2551176"/>
-            <a:ext cx="1371600" cy="384048"/>
-          </a:xfrm>
-          <a:prstGeom prst="rect">
-            <a:avLst/>
-          </a:prstGeom>
-          <a:noFill/>
-        </p:spPr>
-        <p:txBody>
-          <a:bodyPr wrap="square">
+            <a:off x="411480" y="2487168"/>
+            <a:ext cx="1371600" cy="658368"/>
+          </a:xfrm>
+          <a:prstGeom prst="rect">
+            <a:avLst/>
+          </a:prstGeom>
+          <a:noFill/>
+        </p:spPr>
+        <p:txBody>
+          <a:bodyPr wrap="square" anchor="ctr">
             <a:spAutoFit/>
           </a:bodyPr>
           <a:lstStyle/>
@@ -21689,8 +21431,8 @@
         </p:nvSpPr>
         <p:spPr>
           <a:xfrm>
-            <a:off x="1828800" y="2441448"/>
-            <a:ext cx="2148840" cy="566928"/>
+            <a:off x="1828800" y="2487168"/>
+            <a:ext cx="2240280" cy="658368"/>
           </a:xfrm>
           <a:prstGeom prst="rect">
             <a:avLst/>
@@ -21734,16 +21476,16 @@
         </p:nvSpPr>
         <p:spPr>
           <a:xfrm>
-            <a:off x="1874519" y="2551176"/>
-            <a:ext cx="2103120" cy="384048"/>
-          </a:xfrm>
-          <a:prstGeom prst="rect">
-            <a:avLst/>
-          </a:prstGeom>
-          <a:noFill/>
-        </p:spPr>
-        <p:txBody>
-          <a:bodyPr wrap="square">
+            <a:off x="1874519" y="2487168"/>
+            <a:ext cx="2194560" cy="658368"/>
+          </a:xfrm>
+          <a:prstGeom prst="rect">
+            <a:avLst/>
+          </a:prstGeom>
+          <a:noFill/>
+        </p:spPr>
+        <p:txBody>
+          <a:bodyPr wrap="square" anchor="ctr">
             <a:spAutoFit/>
           </a:bodyPr>
           <a:lstStyle/>
@@ -21768,8 +21510,8 @@
         </p:nvSpPr>
         <p:spPr>
           <a:xfrm>
-            <a:off x="4023360" y="2441448"/>
-            <a:ext cx="777240" cy="566928"/>
+            <a:off x="4114800" y="2487168"/>
+            <a:ext cx="822959" cy="658368"/>
           </a:xfrm>
           <a:prstGeom prst="rect">
             <a:avLst/>
@@ -21813,16 +21555,16 @@
         </p:nvSpPr>
         <p:spPr>
           <a:xfrm>
-            <a:off x="4069080" y="2551176"/>
-            <a:ext cx="731520" cy="384048"/>
-          </a:xfrm>
-          <a:prstGeom prst="rect">
-            <a:avLst/>
-          </a:prstGeom>
-          <a:noFill/>
-        </p:spPr>
-        <p:txBody>
-          <a:bodyPr wrap="square">
+            <a:off x="4160520" y="2487168"/>
+            <a:ext cx="777240" cy="658368"/>
+          </a:xfrm>
+          <a:prstGeom prst="rect">
+            <a:avLst/>
+          </a:prstGeom>
+          <a:noFill/>
+        </p:spPr>
+        <p:txBody>
+          <a:bodyPr wrap="square" anchor="ctr">
             <a:spAutoFit/>
           </a:bodyPr>
           <a:lstStyle/>
@@ -21834,7 +21576,7 @@
                   <a:srgbClr val="1AB070"/>
                 </a:solidFill>
               </a:rPr>
-              <a:t>✓</a:t>
+              <a:t>Yes</a:t>
             </a:r>
           </a:p>
         </p:txBody>
@@ -21847,8 +21589,8 @@
         </p:nvSpPr>
         <p:spPr>
           <a:xfrm>
-            <a:off x="4846320" y="2441448"/>
-            <a:ext cx="777240" cy="566928"/>
+            <a:off x="4983480" y="2487168"/>
+            <a:ext cx="822959" cy="658368"/>
           </a:xfrm>
           <a:prstGeom prst="rect">
             <a:avLst/>
@@ -21892,16 +21634,16 @@
         </p:nvSpPr>
         <p:spPr>
           <a:xfrm>
-            <a:off x="4892040" y="2551176"/>
-            <a:ext cx="731520" cy="384048"/>
-          </a:xfrm>
-          <a:prstGeom prst="rect">
-            <a:avLst/>
-          </a:prstGeom>
-          <a:noFill/>
-        </p:spPr>
-        <p:txBody>
-          <a:bodyPr wrap="square">
+            <a:off x="5029200" y="2487168"/>
+            <a:ext cx="777240" cy="658368"/>
+          </a:xfrm>
+          <a:prstGeom prst="rect">
+            <a:avLst/>
+          </a:prstGeom>
+          <a:noFill/>
+        </p:spPr>
+        <p:txBody>
+          <a:bodyPr wrap="square" anchor="ctr">
             <a:spAutoFit/>
           </a:bodyPr>
           <a:lstStyle/>
@@ -21913,7 +21655,7 @@
                   <a:srgbClr val="1AB070"/>
                 </a:solidFill>
               </a:rPr>
-              <a:t>✓</a:t>
+              <a:t>Yes</a:t>
             </a:r>
           </a:p>
         </p:txBody>
@@ -21926,8 +21668,8 @@
         </p:nvSpPr>
         <p:spPr>
           <a:xfrm>
-            <a:off x="5669280" y="2441448"/>
-            <a:ext cx="777240" cy="566928"/>
+            <a:off x="5852160" y="2487168"/>
+            <a:ext cx="731519" cy="658368"/>
           </a:xfrm>
           <a:prstGeom prst="rect">
             <a:avLst/>
@@ -21971,16 +21713,16 @@
         </p:nvSpPr>
         <p:spPr>
           <a:xfrm>
-            <a:off x="5715000" y="2551176"/>
-            <a:ext cx="731520" cy="384048"/>
-          </a:xfrm>
-          <a:prstGeom prst="rect">
-            <a:avLst/>
-          </a:prstGeom>
-          <a:noFill/>
-        </p:spPr>
-        <p:txBody>
-          <a:bodyPr wrap="square">
+            <a:off x="5897880" y="2487168"/>
+            <a:ext cx="685800" cy="658368"/>
+          </a:xfrm>
+          <a:prstGeom prst="rect">
+            <a:avLst/>
+          </a:prstGeom>
+          <a:noFill/>
+        </p:spPr>
+        <p:txBody>
+          <a:bodyPr wrap="square" anchor="ctr">
             <a:spAutoFit/>
           </a:bodyPr>
           <a:lstStyle/>
@@ -21992,7 +21734,7 @@
                   <a:srgbClr val="1AB070"/>
                 </a:solidFill>
               </a:rPr>
-              <a:t>✓</a:t>
+              <a:t>Yes</a:t>
             </a:r>
           </a:p>
         </p:txBody>
@@ -22005,8 +21747,8 @@
         </p:nvSpPr>
         <p:spPr>
           <a:xfrm>
-            <a:off x="6492240" y="2441448"/>
-            <a:ext cx="960120" cy="566928"/>
+            <a:off x="6629400" y="2487168"/>
+            <a:ext cx="960120" cy="658368"/>
           </a:xfrm>
           <a:prstGeom prst="rect">
             <a:avLst/>
@@ -22050,16 +21792,16 @@
         </p:nvSpPr>
         <p:spPr>
           <a:xfrm>
-            <a:off x="6537960" y="2551176"/>
-            <a:ext cx="914400" cy="384048"/>
-          </a:xfrm>
-          <a:prstGeom prst="rect">
-            <a:avLst/>
-          </a:prstGeom>
-          <a:noFill/>
-        </p:spPr>
-        <p:txBody>
-          <a:bodyPr wrap="square">
+            <a:off x="6675120" y="2487168"/>
+            <a:ext cx="914400" cy="658368"/>
+          </a:xfrm>
+          <a:prstGeom prst="rect">
+            <a:avLst/>
+          </a:prstGeom>
+          <a:noFill/>
+        </p:spPr>
+        <p:txBody>
+          <a:bodyPr wrap="square" anchor="ctr">
             <a:spAutoFit/>
           </a:bodyPr>
           <a:lstStyle/>
@@ -22071,7 +21813,7 @@
                   <a:srgbClr val="1AB070"/>
                 </a:solidFill>
               </a:rPr>
-              <a:t>✓</a:t>
+              <a:t>Yes</a:t>
             </a:r>
           </a:p>
         </p:txBody>
@@ -22084,8 +21826,8 @@
         </p:nvSpPr>
         <p:spPr>
           <a:xfrm>
-            <a:off x="7498080" y="2441448"/>
-            <a:ext cx="1143000" cy="566928"/>
+            <a:off x="7635240" y="2487168"/>
+            <a:ext cx="1261872" cy="658368"/>
           </a:xfrm>
           <a:prstGeom prst="rect">
             <a:avLst/>
@@ -22129,16 +21871,16 @@
         </p:nvSpPr>
         <p:spPr>
           <a:xfrm>
-            <a:off x="7543800" y="2551176"/>
-            <a:ext cx="1097280" cy="384048"/>
-          </a:xfrm>
-          <a:prstGeom prst="rect">
-            <a:avLst/>
-          </a:prstGeom>
-          <a:noFill/>
-        </p:spPr>
-        <p:txBody>
-          <a:bodyPr wrap="square">
+            <a:off x="7680960" y="2487168"/>
+            <a:ext cx="1216151" cy="658368"/>
+          </a:xfrm>
+          <a:prstGeom prst="rect">
+            <a:avLst/>
+          </a:prstGeom>
+          <a:noFill/>
+        </p:spPr>
+        <p:txBody>
+          <a:bodyPr wrap="square" anchor="ctr">
             <a:spAutoFit/>
           </a:bodyPr>
           <a:lstStyle/>
@@ -22163,8 +21905,8 @@
         </p:nvSpPr>
         <p:spPr>
           <a:xfrm>
-            <a:off x="365760" y="3008376"/>
-            <a:ext cx="1417320" cy="566928"/>
+            <a:off x="365760" y="3145536"/>
+            <a:ext cx="1417320" cy="658368"/>
           </a:xfrm>
           <a:prstGeom prst="rect">
             <a:avLst/>
@@ -22208,16 +21950,16 @@
         </p:nvSpPr>
         <p:spPr>
           <a:xfrm>
-            <a:off x="411480" y="3118104"/>
-            <a:ext cx="1371600" cy="384048"/>
-          </a:xfrm>
-          <a:prstGeom prst="rect">
-            <a:avLst/>
-          </a:prstGeom>
-          <a:noFill/>
-        </p:spPr>
-        <p:txBody>
-          <a:bodyPr wrap="square">
+            <a:off x="411480" y="3145536"/>
+            <a:ext cx="1371600" cy="658368"/>
+          </a:xfrm>
+          <a:prstGeom prst="rect">
+            <a:avLst/>
+          </a:prstGeom>
+          <a:noFill/>
+        </p:spPr>
+        <p:txBody>
+          <a:bodyPr wrap="square" anchor="ctr">
             <a:spAutoFit/>
           </a:bodyPr>
           <a:lstStyle/>
@@ -22242,8 +21984,8 @@
         </p:nvSpPr>
         <p:spPr>
           <a:xfrm>
-            <a:off x="1828800" y="3008376"/>
-            <a:ext cx="2148840" cy="566928"/>
+            <a:off x="1828800" y="3145536"/>
+            <a:ext cx="2240280" cy="658368"/>
           </a:xfrm>
           <a:prstGeom prst="rect">
             <a:avLst/>
@@ -22287,16 +22029,16 @@
         </p:nvSpPr>
         <p:spPr>
           <a:xfrm>
-            <a:off x="1874519" y="3118104"/>
-            <a:ext cx="2103120" cy="384048"/>
-          </a:xfrm>
-          <a:prstGeom prst="rect">
-            <a:avLst/>
-          </a:prstGeom>
-          <a:noFill/>
-        </p:spPr>
-        <p:txBody>
-          <a:bodyPr wrap="square">
+            <a:off x="1874519" y="3145536"/>
+            <a:ext cx="2194560" cy="658368"/>
+          </a:xfrm>
+          <a:prstGeom prst="rect">
+            <a:avLst/>
+          </a:prstGeom>
+          <a:noFill/>
+        </p:spPr>
+        <p:txBody>
+          <a:bodyPr wrap="square" anchor="ctr">
             <a:spAutoFit/>
           </a:bodyPr>
           <a:lstStyle/>
@@ -22321,8 +22063,8 @@
         </p:nvSpPr>
         <p:spPr>
           <a:xfrm>
-            <a:off x="4023360" y="3008376"/>
-            <a:ext cx="777240" cy="566928"/>
+            <a:off x="4114800" y="3145536"/>
+            <a:ext cx="822959" cy="658368"/>
           </a:xfrm>
           <a:prstGeom prst="rect">
             <a:avLst/>
@@ -22366,16 +22108,16 @@
         </p:nvSpPr>
         <p:spPr>
           <a:xfrm>
-            <a:off x="4069080" y="3118104"/>
-            <a:ext cx="731520" cy="384048"/>
-          </a:xfrm>
-          <a:prstGeom prst="rect">
-            <a:avLst/>
-          </a:prstGeom>
-          <a:noFill/>
-        </p:spPr>
-        <p:txBody>
-          <a:bodyPr wrap="square">
+            <a:off x="4160520" y="3145536"/>
+            <a:ext cx="777240" cy="658368"/>
+          </a:xfrm>
+          <a:prstGeom prst="rect">
+            <a:avLst/>
+          </a:prstGeom>
+          <a:noFill/>
+        </p:spPr>
+        <p:txBody>
+          <a:bodyPr wrap="square" anchor="ctr">
             <a:spAutoFit/>
           </a:bodyPr>
           <a:lstStyle/>
@@ -22387,7 +22129,7 @@
                   <a:srgbClr val="8A9BAD"/>
                 </a:solidFill>
               </a:rPr>
-              <a:t>—</a:t>
+              <a:t>-</a:t>
             </a:r>
           </a:p>
         </p:txBody>
@@ -22400,8 +22142,8 @@
         </p:nvSpPr>
         <p:spPr>
           <a:xfrm>
-            <a:off x="4846320" y="3008376"/>
-            <a:ext cx="777240" cy="566928"/>
+            <a:off x="4983480" y="3145536"/>
+            <a:ext cx="822959" cy="658368"/>
           </a:xfrm>
           <a:prstGeom prst="rect">
             <a:avLst/>
@@ -22445,16 +22187,16 @@
         </p:nvSpPr>
         <p:spPr>
           <a:xfrm>
-            <a:off x="4892040" y="3118104"/>
-            <a:ext cx="731520" cy="384048"/>
-          </a:xfrm>
-          <a:prstGeom prst="rect">
-            <a:avLst/>
-          </a:prstGeom>
-          <a:noFill/>
-        </p:spPr>
-        <p:txBody>
-          <a:bodyPr wrap="square">
+            <a:off x="5029200" y="3145536"/>
+            <a:ext cx="777240" cy="658368"/>
+          </a:xfrm>
+          <a:prstGeom prst="rect">
+            <a:avLst/>
+          </a:prstGeom>
+          <a:noFill/>
+        </p:spPr>
+        <p:txBody>
+          <a:bodyPr wrap="square" anchor="ctr">
             <a:spAutoFit/>
           </a:bodyPr>
           <a:lstStyle/>
@@ -22466,7 +22208,7 @@
                   <a:srgbClr val="1AB070"/>
                 </a:solidFill>
               </a:rPr>
-              <a:t>✓</a:t>
+              <a:t>Yes</a:t>
             </a:r>
           </a:p>
         </p:txBody>
@@ -22479,8 +22221,8 @@
         </p:nvSpPr>
         <p:spPr>
           <a:xfrm>
-            <a:off x="5669280" y="3008376"/>
-            <a:ext cx="777240" cy="566928"/>
+            <a:off x="5852160" y="3145536"/>
+            <a:ext cx="731519" cy="658368"/>
           </a:xfrm>
           <a:prstGeom prst="rect">
             <a:avLst/>
@@ -22524,16 +22266,16 @@
         </p:nvSpPr>
         <p:spPr>
           <a:xfrm>
-            <a:off x="5715000" y="3118104"/>
-            <a:ext cx="731520" cy="384048"/>
-          </a:xfrm>
-          <a:prstGeom prst="rect">
-            <a:avLst/>
-          </a:prstGeom>
-          <a:noFill/>
-        </p:spPr>
-        <p:txBody>
-          <a:bodyPr wrap="square">
+            <a:off x="5897880" y="3145536"/>
+            <a:ext cx="685800" cy="658368"/>
+          </a:xfrm>
+          <a:prstGeom prst="rect">
+            <a:avLst/>
+          </a:prstGeom>
+          <a:noFill/>
+        </p:spPr>
+        <p:txBody>
+          <a:bodyPr wrap="square" anchor="ctr">
             <a:spAutoFit/>
           </a:bodyPr>
           <a:lstStyle/>
@@ -22545,7 +22287,7 @@
                   <a:srgbClr val="1AB070"/>
                 </a:solidFill>
               </a:rPr>
-              <a:t>✓</a:t>
+              <a:t>Yes</a:t>
             </a:r>
           </a:p>
         </p:txBody>
@@ -22558,8 +22300,8 @@
         </p:nvSpPr>
         <p:spPr>
           <a:xfrm>
-            <a:off x="6492240" y="3008376"/>
-            <a:ext cx="960120" cy="566928"/>
+            <a:off x="6629400" y="3145536"/>
+            <a:ext cx="960120" cy="658368"/>
           </a:xfrm>
           <a:prstGeom prst="rect">
             <a:avLst/>
@@ -22603,16 +22345,16 @@
         </p:nvSpPr>
         <p:spPr>
           <a:xfrm>
-            <a:off x="6537960" y="3118104"/>
-            <a:ext cx="914400" cy="384048"/>
-          </a:xfrm>
-          <a:prstGeom prst="rect">
-            <a:avLst/>
-          </a:prstGeom>
-          <a:noFill/>
-        </p:spPr>
-        <p:txBody>
-          <a:bodyPr wrap="square">
+            <a:off x="6675120" y="3145536"/>
+            <a:ext cx="914400" cy="658368"/>
+          </a:xfrm>
+          <a:prstGeom prst="rect">
+            <a:avLst/>
+          </a:prstGeom>
+          <a:noFill/>
+        </p:spPr>
+        <p:txBody>
+          <a:bodyPr wrap="square" anchor="ctr">
             <a:spAutoFit/>
           </a:bodyPr>
           <a:lstStyle/>
@@ -22624,7 +22366,7 @@
                   <a:srgbClr val="1AB070"/>
                 </a:solidFill>
               </a:rPr>
-              <a:t>✓</a:t>
+              <a:t>Yes</a:t>
             </a:r>
           </a:p>
         </p:txBody>
@@ -22637,8 +22379,8 @@
         </p:nvSpPr>
         <p:spPr>
           <a:xfrm>
-            <a:off x="7498080" y="3008376"/>
-            <a:ext cx="1143000" cy="566928"/>
+            <a:off x="7635240" y="3145536"/>
+            <a:ext cx="1261872" cy="658368"/>
           </a:xfrm>
           <a:prstGeom prst="rect">
             <a:avLst/>
@@ -22682,16 +22424,16 @@
         </p:nvSpPr>
         <p:spPr>
           <a:xfrm>
-            <a:off x="7543800" y="3118104"/>
-            <a:ext cx="1097280" cy="384048"/>
-          </a:xfrm>
-          <a:prstGeom prst="rect">
-            <a:avLst/>
-          </a:prstGeom>
-          <a:noFill/>
-        </p:spPr>
-        <p:txBody>
-          <a:bodyPr wrap="square">
+            <a:off x="7680960" y="3145536"/>
+            <a:ext cx="1216151" cy="658368"/>
+          </a:xfrm>
+          <a:prstGeom prst="rect">
+            <a:avLst/>
+          </a:prstGeom>
+          <a:noFill/>
+        </p:spPr>
+        <p:txBody>
+          <a:bodyPr wrap="square" anchor="ctr">
             <a:spAutoFit/>
           </a:bodyPr>
           <a:lstStyle/>
@@ -22716,8 +22458,8 @@
         </p:nvSpPr>
         <p:spPr>
           <a:xfrm>
-            <a:off x="365760" y="3575303"/>
-            <a:ext cx="1417320" cy="566928"/>
+            <a:off x="365760" y="3803904"/>
+            <a:ext cx="1417320" cy="658368"/>
           </a:xfrm>
           <a:prstGeom prst="rect">
             <a:avLst/>
@@ -22761,16 +22503,16 @@
         </p:nvSpPr>
         <p:spPr>
           <a:xfrm>
-            <a:off x="411480" y="3685031"/>
-            <a:ext cx="1371600" cy="384048"/>
-          </a:xfrm>
-          <a:prstGeom prst="rect">
-            <a:avLst/>
-          </a:prstGeom>
-          <a:noFill/>
-        </p:spPr>
-        <p:txBody>
-          <a:bodyPr wrap="square">
+            <a:off x="411480" y="3803904"/>
+            <a:ext cx="1371600" cy="658368"/>
+          </a:xfrm>
+          <a:prstGeom prst="rect">
+            <a:avLst/>
+          </a:prstGeom>
+          <a:noFill/>
+        </p:spPr>
+        <p:txBody>
+          <a:bodyPr wrap="square" anchor="ctr">
             <a:spAutoFit/>
           </a:bodyPr>
           <a:lstStyle/>
@@ -22795,8 +22537,8 @@
         </p:nvSpPr>
         <p:spPr>
           <a:xfrm>
-            <a:off x="1828800" y="3575303"/>
-            <a:ext cx="2148840" cy="566928"/>
+            <a:off x="1828800" y="3803904"/>
+            <a:ext cx="2240280" cy="658368"/>
           </a:xfrm>
           <a:prstGeom prst="rect">
             <a:avLst/>
@@ -22840,16 +22582,16 @@
         </p:nvSpPr>
         <p:spPr>
           <a:xfrm>
-            <a:off x="1874519" y="3685031"/>
-            <a:ext cx="2103120" cy="384048"/>
-          </a:xfrm>
-          <a:prstGeom prst="rect">
-            <a:avLst/>
-          </a:prstGeom>
-          <a:noFill/>
-        </p:spPr>
-        <p:txBody>
-          <a:bodyPr wrap="square">
+            <a:off x="1874519" y="3803904"/>
+            <a:ext cx="2194560" cy="658368"/>
+          </a:xfrm>
+          <a:prstGeom prst="rect">
+            <a:avLst/>
+          </a:prstGeom>
+          <a:noFill/>
+        </p:spPr>
+        <p:txBody>
+          <a:bodyPr wrap="square" anchor="ctr">
             <a:spAutoFit/>
           </a:bodyPr>
           <a:lstStyle/>
@@ -22874,8 +22616,8 @@
         </p:nvSpPr>
         <p:spPr>
           <a:xfrm>
-            <a:off x="4023360" y="3575303"/>
-            <a:ext cx="777240" cy="566928"/>
+            <a:off x="4114800" y="3803904"/>
+            <a:ext cx="822959" cy="658368"/>
           </a:xfrm>
           <a:prstGeom prst="rect">
             <a:avLst/>
@@ -22919,16 +22661,16 @@
         </p:nvSpPr>
         <p:spPr>
           <a:xfrm>
-            <a:off x="4069080" y="3685031"/>
-            <a:ext cx="731520" cy="384048"/>
-          </a:xfrm>
-          <a:prstGeom prst="rect">
-            <a:avLst/>
-          </a:prstGeom>
-          <a:noFill/>
-        </p:spPr>
-        <p:txBody>
-          <a:bodyPr wrap="square">
+            <a:off x="4160520" y="3803904"/>
+            <a:ext cx="777240" cy="658368"/>
+          </a:xfrm>
+          <a:prstGeom prst="rect">
+            <a:avLst/>
+          </a:prstGeom>
+          <a:noFill/>
+        </p:spPr>
+        <p:txBody>
+          <a:bodyPr wrap="square" anchor="ctr">
             <a:spAutoFit/>
           </a:bodyPr>
           <a:lstStyle/>
@@ -22940,7 +22682,7 @@
                   <a:srgbClr val="8A9BAD"/>
                 </a:solidFill>
               </a:rPr>
-              <a:t>—</a:t>
+              <a:t>-</a:t>
             </a:r>
           </a:p>
         </p:txBody>
@@ -22953,8 +22695,8 @@
         </p:nvSpPr>
         <p:spPr>
           <a:xfrm>
-            <a:off x="4846320" y="3575303"/>
-            <a:ext cx="777240" cy="566928"/>
+            <a:off x="4983480" y="3803904"/>
+            <a:ext cx="822959" cy="658368"/>
           </a:xfrm>
           <a:prstGeom prst="rect">
             <a:avLst/>
@@ -22998,16 +22740,16 @@
         </p:nvSpPr>
         <p:spPr>
           <a:xfrm>
-            <a:off x="4892040" y="3685031"/>
-            <a:ext cx="731520" cy="384048"/>
-          </a:xfrm>
-          <a:prstGeom prst="rect">
-            <a:avLst/>
-          </a:prstGeom>
-          <a:noFill/>
-        </p:spPr>
-        <p:txBody>
-          <a:bodyPr wrap="square">
+            <a:off x="5029200" y="3803904"/>
+            <a:ext cx="777240" cy="658368"/>
+          </a:xfrm>
+          <a:prstGeom prst="rect">
+            <a:avLst/>
+          </a:prstGeom>
+          <a:noFill/>
+        </p:spPr>
+        <p:txBody>
+          <a:bodyPr wrap="square" anchor="ctr">
             <a:spAutoFit/>
           </a:bodyPr>
           <a:lstStyle/>
@@ -23019,7 +22761,7 @@
                   <a:srgbClr val="1AB070"/>
                 </a:solidFill>
               </a:rPr>
-              <a:t>✓</a:t>
+              <a:t>Yes</a:t>
             </a:r>
           </a:p>
         </p:txBody>
@@ -23032,8 +22774,8 @@
         </p:nvSpPr>
         <p:spPr>
           <a:xfrm>
-            <a:off x="5669280" y="3575303"/>
-            <a:ext cx="777240" cy="566928"/>
+            <a:off x="5852160" y="3803904"/>
+            <a:ext cx="731519" cy="658368"/>
           </a:xfrm>
           <a:prstGeom prst="rect">
             <a:avLst/>
@@ -23077,16 +22819,16 @@
         </p:nvSpPr>
         <p:spPr>
           <a:xfrm>
-            <a:off x="5715000" y="3685031"/>
-            <a:ext cx="731520" cy="384048"/>
-          </a:xfrm>
-          <a:prstGeom prst="rect">
-            <a:avLst/>
-          </a:prstGeom>
-          <a:noFill/>
-        </p:spPr>
-        <p:txBody>
-          <a:bodyPr wrap="square">
+            <a:off x="5897880" y="3803904"/>
+            <a:ext cx="685800" cy="658368"/>
+          </a:xfrm>
+          <a:prstGeom prst="rect">
+            <a:avLst/>
+          </a:prstGeom>
+          <a:noFill/>
+        </p:spPr>
+        <p:txBody>
+          <a:bodyPr wrap="square" anchor="ctr">
             <a:spAutoFit/>
           </a:bodyPr>
           <a:lstStyle/>
@@ -23098,7 +22840,7 @@
                   <a:srgbClr val="1AB070"/>
                 </a:solidFill>
               </a:rPr>
-              <a:t>✓</a:t>
+              <a:t>Yes</a:t>
             </a:r>
           </a:p>
         </p:txBody>
@@ -23111,8 +22853,8 @@
         </p:nvSpPr>
         <p:spPr>
           <a:xfrm>
-            <a:off x="6492240" y="3575303"/>
-            <a:ext cx="960120" cy="566928"/>
+            <a:off x="6629400" y="3803904"/>
+            <a:ext cx="960120" cy="658368"/>
           </a:xfrm>
           <a:prstGeom prst="rect">
             <a:avLst/>
@@ -23156,16 +22898,16 @@
         </p:nvSpPr>
         <p:spPr>
           <a:xfrm>
-            <a:off x="6537960" y="3685031"/>
-            <a:ext cx="914400" cy="384048"/>
-          </a:xfrm>
-          <a:prstGeom prst="rect">
-            <a:avLst/>
-          </a:prstGeom>
-          <a:noFill/>
-        </p:spPr>
-        <p:txBody>
-          <a:bodyPr wrap="square">
+            <a:off x="6675120" y="3803904"/>
+            <a:ext cx="914400" cy="658368"/>
+          </a:xfrm>
+          <a:prstGeom prst="rect">
+            <a:avLst/>
+          </a:prstGeom>
+          <a:noFill/>
+        </p:spPr>
+        <p:txBody>
+          <a:bodyPr wrap="square" anchor="ctr">
             <a:spAutoFit/>
           </a:bodyPr>
           <a:lstStyle/>
@@ -23177,7 +22919,7 @@
                   <a:srgbClr val="8A9BAD"/>
                 </a:solidFill>
               </a:rPr>
-              <a:t>—</a:t>
+              <a:t>-</a:t>
             </a:r>
           </a:p>
         </p:txBody>
@@ -23190,8 +22932,8 @@
         </p:nvSpPr>
         <p:spPr>
           <a:xfrm>
-            <a:off x="7498080" y="3575303"/>
-            <a:ext cx="1143000" cy="566928"/>
+            <a:off x="7635240" y="3803904"/>
+            <a:ext cx="1261872" cy="658368"/>
           </a:xfrm>
           <a:prstGeom prst="rect">
             <a:avLst/>
@@ -23235,16 +22977,16 @@
         </p:nvSpPr>
         <p:spPr>
           <a:xfrm>
-            <a:off x="7543800" y="3685031"/>
-            <a:ext cx="1097280" cy="384048"/>
-          </a:xfrm>
-          <a:prstGeom prst="rect">
-            <a:avLst/>
-          </a:prstGeom>
-          <a:noFill/>
-        </p:spPr>
-        <p:txBody>
-          <a:bodyPr wrap="square">
+            <a:off x="7680960" y="3803904"/>
+            <a:ext cx="1216151" cy="658368"/>
+          </a:xfrm>
+          <a:prstGeom prst="rect">
+            <a:avLst/>
+          </a:prstGeom>
+          <a:noFill/>
+        </p:spPr>
+        <p:txBody>
+          <a:bodyPr wrap="square" anchor="ctr">
             <a:spAutoFit/>
           </a:bodyPr>
           <a:lstStyle/>
@@ -23269,8 +23011,8 @@
         </p:nvSpPr>
         <p:spPr>
           <a:xfrm>
-            <a:off x="365760" y="4142231"/>
-            <a:ext cx="1417320" cy="566928"/>
+            <a:off x="365760" y="4462272"/>
+            <a:ext cx="1417320" cy="658368"/>
           </a:xfrm>
           <a:prstGeom prst="rect">
             <a:avLst/>
@@ -23314,16 +23056,16 @@
         </p:nvSpPr>
         <p:spPr>
           <a:xfrm>
-            <a:off x="411480" y="4251959"/>
-            <a:ext cx="1371600" cy="384048"/>
-          </a:xfrm>
-          <a:prstGeom prst="rect">
-            <a:avLst/>
-          </a:prstGeom>
-          <a:noFill/>
-        </p:spPr>
-        <p:txBody>
-          <a:bodyPr wrap="square">
+            <a:off x="411480" y="4462272"/>
+            <a:ext cx="1371600" cy="658368"/>
+          </a:xfrm>
+          <a:prstGeom prst="rect">
+            <a:avLst/>
+          </a:prstGeom>
+          <a:noFill/>
+        </p:spPr>
+        <p:txBody>
+          <a:bodyPr wrap="square" anchor="ctr">
             <a:spAutoFit/>
           </a:bodyPr>
           <a:lstStyle/>
@@ -23348,8 +23090,8 @@
         </p:nvSpPr>
         <p:spPr>
           <a:xfrm>
-            <a:off x="1828800" y="4142231"/>
-            <a:ext cx="2148840" cy="566928"/>
+            <a:off x="1828800" y="4462272"/>
+            <a:ext cx="2240280" cy="658368"/>
           </a:xfrm>
           <a:prstGeom prst="rect">
             <a:avLst/>
@@ -23393,16 +23135,16 @@
         </p:nvSpPr>
         <p:spPr>
           <a:xfrm>
-            <a:off x="1874519" y="4251959"/>
-            <a:ext cx="2103120" cy="384048"/>
-          </a:xfrm>
-          <a:prstGeom prst="rect">
-            <a:avLst/>
-          </a:prstGeom>
-          <a:noFill/>
-        </p:spPr>
-        <p:txBody>
-          <a:bodyPr wrap="square">
+            <a:off x="1874519" y="4462272"/>
+            <a:ext cx="2194560" cy="658368"/>
+          </a:xfrm>
+          <a:prstGeom prst="rect">
+            <a:avLst/>
+          </a:prstGeom>
+          <a:noFill/>
+        </p:spPr>
+        <p:txBody>
+          <a:bodyPr wrap="square" anchor="ctr">
             <a:spAutoFit/>
           </a:bodyPr>
           <a:lstStyle/>
@@ -23427,8 +23169,8 @@
         </p:nvSpPr>
         <p:spPr>
           <a:xfrm>
-            <a:off x="4023360" y="4142231"/>
-            <a:ext cx="777240" cy="566928"/>
+            <a:off x="4114800" y="4462272"/>
+            <a:ext cx="822959" cy="658368"/>
           </a:xfrm>
           <a:prstGeom prst="rect">
             <a:avLst/>
@@ -23472,16 +23214,16 @@
         </p:nvSpPr>
         <p:spPr>
           <a:xfrm>
-            <a:off x="4069080" y="4251959"/>
-            <a:ext cx="731520" cy="384048"/>
-          </a:xfrm>
-          <a:prstGeom prst="rect">
-            <a:avLst/>
-          </a:prstGeom>
-          <a:noFill/>
-        </p:spPr>
-        <p:txBody>
-          <a:bodyPr wrap="square">
+            <a:off x="4160520" y="4462272"/>
+            <a:ext cx="777240" cy="658368"/>
+          </a:xfrm>
+          <a:prstGeom prst="rect">
+            <a:avLst/>
+          </a:prstGeom>
+          <a:noFill/>
+        </p:spPr>
+        <p:txBody>
+          <a:bodyPr wrap="square" anchor="ctr">
             <a:spAutoFit/>
           </a:bodyPr>
           <a:lstStyle/>
@@ -23493,7 +23235,7 @@
                   <a:srgbClr val="8A9BAD"/>
                 </a:solidFill>
               </a:rPr>
-              <a:t>—</a:t>
+              <a:t>-</a:t>
             </a:r>
           </a:p>
         </p:txBody>
@@ -23506,8 +23248,8 @@
         </p:nvSpPr>
         <p:spPr>
           <a:xfrm>
-            <a:off x="4846320" y="4142231"/>
-            <a:ext cx="777240" cy="566928"/>
+            <a:off x="4983480" y="4462272"/>
+            <a:ext cx="822959" cy="658368"/>
           </a:xfrm>
           <a:prstGeom prst="rect">
             <a:avLst/>
@@ -23551,16 +23293,16 @@
         </p:nvSpPr>
         <p:spPr>
           <a:xfrm>
-            <a:off x="4892040" y="4251959"/>
-            <a:ext cx="731520" cy="384048"/>
-          </a:xfrm>
-          <a:prstGeom prst="rect">
-            <a:avLst/>
-          </a:prstGeom>
-          <a:noFill/>
-        </p:spPr>
-        <p:txBody>
-          <a:bodyPr wrap="square">
+            <a:off x="5029200" y="4462272"/>
+            <a:ext cx="777240" cy="658368"/>
+          </a:xfrm>
+          <a:prstGeom prst="rect">
+            <a:avLst/>
+          </a:prstGeom>
+          <a:noFill/>
+        </p:spPr>
+        <p:txBody>
+          <a:bodyPr wrap="square" anchor="ctr">
             <a:spAutoFit/>
           </a:bodyPr>
           <a:lstStyle/>
@@ -23572,7 +23314,7 @@
                   <a:srgbClr val="1AB070"/>
                 </a:solidFill>
               </a:rPr>
-              <a:t>✓</a:t>
+              <a:t>Yes</a:t>
             </a:r>
           </a:p>
         </p:txBody>
@@ -23585,8 +23327,8 @@
         </p:nvSpPr>
         <p:spPr>
           <a:xfrm>
-            <a:off x="5669280" y="4142231"/>
-            <a:ext cx="777240" cy="566928"/>
+            <a:off x="5852160" y="4462272"/>
+            <a:ext cx="731519" cy="658368"/>
           </a:xfrm>
           <a:prstGeom prst="rect">
             <a:avLst/>
@@ -23630,16 +23372,16 @@
         </p:nvSpPr>
         <p:spPr>
           <a:xfrm>
-            <a:off x="5715000" y="4251959"/>
-            <a:ext cx="731520" cy="384048"/>
-          </a:xfrm>
-          <a:prstGeom prst="rect">
-            <a:avLst/>
-          </a:prstGeom>
-          <a:noFill/>
-        </p:spPr>
-        <p:txBody>
-          <a:bodyPr wrap="square">
+            <a:off x="5897880" y="4462272"/>
+            <a:ext cx="685800" cy="658368"/>
+          </a:xfrm>
+          <a:prstGeom prst="rect">
+            <a:avLst/>
+          </a:prstGeom>
+          <a:noFill/>
+        </p:spPr>
+        <p:txBody>
+          <a:bodyPr wrap="square" anchor="ctr">
             <a:spAutoFit/>
           </a:bodyPr>
           <a:lstStyle/>
@@ -23651,7 +23393,7 @@
                   <a:srgbClr val="1AB070"/>
                 </a:solidFill>
               </a:rPr>
-              <a:t>✓</a:t>
+              <a:t>Yes</a:t>
             </a:r>
           </a:p>
         </p:txBody>
@@ -23664,8 +23406,8 @@
         </p:nvSpPr>
         <p:spPr>
           <a:xfrm>
-            <a:off x="6492240" y="4142231"/>
-            <a:ext cx="960120" cy="566928"/>
+            <a:off x="6629400" y="4462272"/>
+            <a:ext cx="960120" cy="658368"/>
           </a:xfrm>
           <a:prstGeom prst="rect">
             <a:avLst/>
@@ -23709,16 +23451,16 @@
         </p:nvSpPr>
         <p:spPr>
           <a:xfrm>
-            <a:off x="6537960" y="4251959"/>
-            <a:ext cx="914400" cy="384048"/>
-          </a:xfrm>
-          <a:prstGeom prst="rect">
-            <a:avLst/>
-          </a:prstGeom>
-          <a:noFill/>
-        </p:spPr>
-        <p:txBody>
-          <a:bodyPr wrap="square">
+            <a:off x="6675120" y="4462272"/>
+            <a:ext cx="914400" cy="658368"/>
+          </a:xfrm>
+          <a:prstGeom prst="rect">
+            <a:avLst/>
+          </a:prstGeom>
+          <a:noFill/>
+        </p:spPr>
+        <p:txBody>
+          <a:bodyPr wrap="square" anchor="ctr">
             <a:spAutoFit/>
           </a:bodyPr>
           <a:lstStyle/>
@@ -23730,7 +23472,7 @@
                   <a:srgbClr val="1AB070"/>
                 </a:solidFill>
               </a:rPr>
-              <a:t>✓</a:t>
+              <a:t>Yes</a:t>
             </a:r>
           </a:p>
         </p:txBody>
@@ -23743,8 +23485,8 @@
         </p:nvSpPr>
         <p:spPr>
           <a:xfrm>
-            <a:off x="7498080" y="4142231"/>
-            <a:ext cx="1143000" cy="566928"/>
+            <a:off x="7635240" y="4462272"/>
+            <a:ext cx="1261872" cy="658368"/>
           </a:xfrm>
           <a:prstGeom prst="rect">
             <a:avLst/>
@@ -23788,16 +23530,16 @@
         </p:nvSpPr>
         <p:spPr>
           <a:xfrm>
-            <a:off x="7543800" y="4251959"/>
-            <a:ext cx="1097280" cy="384048"/>
-          </a:xfrm>
-          <a:prstGeom prst="rect">
-            <a:avLst/>
-          </a:prstGeom>
-          <a:noFill/>
-        </p:spPr>
-        <p:txBody>
-          <a:bodyPr wrap="square">
+            <a:off x="7680960" y="4462272"/>
+            <a:ext cx="1216151" cy="658368"/>
+          </a:xfrm>
+          <a:prstGeom prst="rect">
+            <a:avLst/>
+          </a:prstGeom>
+          <a:noFill/>
+        </p:spPr>
+        <p:txBody>
+          <a:bodyPr wrap="square" anchor="ctr">
             <a:spAutoFit/>
           </a:bodyPr>
           <a:lstStyle/>
@@ -23809,7 +23551,7 @@
                   <a:srgbClr val="8A9BAD"/>
                 </a:solidFill>
               </a:rPr>
-              <a:t>—</a:t>
+              <a:t>-</a:t>
             </a:r>
           </a:p>
         </p:txBody>
@@ -23822,8 +23564,8 @@
         </p:nvSpPr>
         <p:spPr>
           <a:xfrm>
-            <a:off x="365760" y="4709160"/>
-            <a:ext cx="1417320" cy="566928"/>
+            <a:off x="365760" y="5120640"/>
+            <a:ext cx="1417320" cy="658368"/>
           </a:xfrm>
           <a:prstGeom prst="rect">
             <a:avLst/>
@@ -23867,16 +23609,16 @@
         </p:nvSpPr>
         <p:spPr>
           <a:xfrm>
-            <a:off x="411480" y="4818888"/>
-            <a:ext cx="1371600" cy="384048"/>
-          </a:xfrm>
-          <a:prstGeom prst="rect">
-            <a:avLst/>
-          </a:prstGeom>
-          <a:noFill/>
-        </p:spPr>
-        <p:txBody>
-          <a:bodyPr wrap="square">
+            <a:off x="411480" y="5120640"/>
+            <a:ext cx="1371600" cy="658368"/>
+          </a:xfrm>
+          <a:prstGeom prst="rect">
+            <a:avLst/>
+          </a:prstGeom>
+          <a:noFill/>
+        </p:spPr>
+        <p:txBody>
+          <a:bodyPr wrap="square" anchor="ctr">
             <a:spAutoFit/>
           </a:bodyPr>
           <a:lstStyle/>
@@ -23901,8 +23643,8 @@
         </p:nvSpPr>
         <p:spPr>
           <a:xfrm>
-            <a:off x="1828800" y="4709160"/>
-            <a:ext cx="2148840" cy="566928"/>
+            <a:off x="1828800" y="5120640"/>
+            <a:ext cx="2240280" cy="658368"/>
           </a:xfrm>
           <a:prstGeom prst="rect">
             <a:avLst/>
@@ -23946,16 +23688,16 @@
         </p:nvSpPr>
         <p:spPr>
           <a:xfrm>
-            <a:off x="1874519" y="4818888"/>
-            <a:ext cx="2103120" cy="384048"/>
-          </a:xfrm>
-          <a:prstGeom prst="rect">
-            <a:avLst/>
-          </a:prstGeom>
-          <a:noFill/>
-        </p:spPr>
-        <p:txBody>
-          <a:bodyPr wrap="square">
+            <a:off x="1874519" y="5120640"/>
+            <a:ext cx="2194560" cy="658368"/>
+          </a:xfrm>
+          <a:prstGeom prst="rect">
+            <a:avLst/>
+          </a:prstGeom>
+          <a:noFill/>
+        </p:spPr>
+        <p:txBody>
+          <a:bodyPr wrap="square" anchor="ctr">
             <a:spAutoFit/>
           </a:bodyPr>
           <a:lstStyle/>
@@ -23980,8 +23722,8 @@
         </p:nvSpPr>
         <p:spPr>
           <a:xfrm>
-            <a:off x="4023360" y="4709160"/>
-            <a:ext cx="777240" cy="566928"/>
+            <a:off x="4114800" y="5120640"/>
+            <a:ext cx="822959" cy="658368"/>
           </a:xfrm>
           <a:prstGeom prst="rect">
             <a:avLst/>
@@ -24025,16 +23767,16 @@
         </p:nvSpPr>
         <p:spPr>
           <a:xfrm>
-            <a:off x="4069080" y="4818888"/>
-            <a:ext cx="731520" cy="384048"/>
-          </a:xfrm>
-          <a:prstGeom prst="rect">
-            <a:avLst/>
-          </a:prstGeom>
-          <a:noFill/>
-        </p:spPr>
-        <p:txBody>
-          <a:bodyPr wrap="square">
+            <a:off x="4160520" y="5120640"/>
+            <a:ext cx="777240" cy="658368"/>
+          </a:xfrm>
+          <a:prstGeom prst="rect">
+            <a:avLst/>
+          </a:prstGeom>
+          <a:noFill/>
+        </p:spPr>
+        <p:txBody>
+          <a:bodyPr wrap="square" anchor="ctr">
             <a:spAutoFit/>
           </a:bodyPr>
           <a:lstStyle/>
@@ -24046,7 +23788,7 @@
                   <a:srgbClr val="1AB070"/>
                 </a:solidFill>
               </a:rPr>
-              <a:t>✓</a:t>
+              <a:t>Yes</a:t>
             </a:r>
           </a:p>
         </p:txBody>
@@ -24059,8 +23801,8 @@
         </p:nvSpPr>
         <p:spPr>
           <a:xfrm>
-            <a:off x="4846320" y="4709160"/>
-            <a:ext cx="777240" cy="566928"/>
+            <a:off x="4983480" y="5120640"/>
+            <a:ext cx="822959" cy="658368"/>
           </a:xfrm>
           <a:prstGeom prst="rect">
             <a:avLst/>
@@ -24104,16 +23846,16 @@
         </p:nvSpPr>
         <p:spPr>
           <a:xfrm>
-            <a:off x="4892040" y="4818888"/>
-            <a:ext cx="731520" cy="384048"/>
-          </a:xfrm>
-          <a:prstGeom prst="rect">
-            <a:avLst/>
-          </a:prstGeom>
-          <a:noFill/>
-        </p:spPr>
-        <p:txBody>
-          <a:bodyPr wrap="square">
+            <a:off x="5029200" y="5120640"/>
+            <a:ext cx="777240" cy="658368"/>
+          </a:xfrm>
+          <a:prstGeom prst="rect">
+            <a:avLst/>
+          </a:prstGeom>
+          <a:noFill/>
+        </p:spPr>
+        <p:txBody>
+          <a:bodyPr wrap="square" anchor="ctr">
             <a:spAutoFit/>
           </a:bodyPr>
           <a:lstStyle/>
@@ -24125,7 +23867,7 @@
                   <a:srgbClr val="1AB070"/>
                 </a:solidFill>
               </a:rPr>
-              <a:t>✓</a:t>
+              <a:t>Yes</a:t>
             </a:r>
           </a:p>
         </p:txBody>
@@ -24138,8 +23880,8 @@
         </p:nvSpPr>
         <p:spPr>
           <a:xfrm>
-            <a:off x="5669280" y="4709160"/>
-            <a:ext cx="777240" cy="566928"/>
+            <a:off x="5852160" y="5120640"/>
+            <a:ext cx="731519" cy="658368"/>
           </a:xfrm>
           <a:prstGeom prst="rect">
             <a:avLst/>
@@ -24183,16 +23925,16 @@
         </p:nvSpPr>
         <p:spPr>
           <a:xfrm>
-            <a:off x="5715000" y="4818888"/>
-            <a:ext cx="731520" cy="384048"/>
-          </a:xfrm>
-          <a:prstGeom prst="rect">
-            <a:avLst/>
-          </a:prstGeom>
-          <a:noFill/>
-        </p:spPr>
-        <p:txBody>
-          <a:bodyPr wrap="square">
+            <a:off x="5897880" y="5120640"/>
+            <a:ext cx="685800" cy="658368"/>
+          </a:xfrm>
+          <a:prstGeom prst="rect">
+            <a:avLst/>
+          </a:prstGeom>
+          <a:noFill/>
+        </p:spPr>
+        <p:txBody>
+          <a:bodyPr wrap="square" anchor="ctr">
             <a:spAutoFit/>
           </a:bodyPr>
           <a:lstStyle/>
@@ -24204,7 +23946,7 @@
                   <a:srgbClr val="1AB070"/>
                 </a:solidFill>
               </a:rPr>
-              <a:t>✓</a:t>
+              <a:t>Yes</a:t>
             </a:r>
           </a:p>
         </p:txBody>
@@ -24217,8 +23959,8 @@
         </p:nvSpPr>
         <p:spPr>
           <a:xfrm>
-            <a:off x="6492240" y="4709160"/>
-            <a:ext cx="960120" cy="566928"/>
+            <a:off x="6629400" y="5120640"/>
+            <a:ext cx="960120" cy="658368"/>
           </a:xfrm>
           <a:prstGeom prst="rect">
             <a:avLst/>
@@ -24262,16 +24004,16 @@
         </p:nvSpPr>
         <p:spPr>
           <a:xfrm>
-            <a:off x="6537960" y="4818888"/>
-            <a:ext cx="914400" cy="384048"/>
-          </a:xfrm>
-          <a:prstGeom prst="rect">
-            <a:avLst/>
-          </a:prstGeom>
-          <a:noFill/>
-        </p:spPr>
-        <p:txBody>
-          <a:bodyPr wrap="square">
+            <a:off x="6675120" y="5120640"/>
+            <a:ext cx="914400" cy="658368"/>
+          </a:xfrm>
+          <a:prstGeom prst="rect">
+            <a:avLst/>
+          </a:prstGeom>
+          <a:noFill/>
+        </p:spPr>
+        <p:txBody>
+          <a:bodyPr wrap="square" anchor="ctr">
             <a:spAutoFit/>
           </a:bodyPr>
           <a:lstStyle/>
@@ -24283,7 +24025,7 @@
                   <a:srgbClr val="8A9BAD"/>
                 </a:solidFill>
               </a:rPr>
-              <a:t>—</a:t>
+              <a:t>-</a:t>
             </a:r>
           </a:p>
         </p:txBody>
@@ -24296,8 +24038,8 @@
         </p:nvSpPr>
         <p:spPr>
           <a:xfrm>
-            <a:off x="7498080" y="4709160"/>
-            <a:ext cx="1143000" cy="566928"/>
+            <a:off x="7635240" y="5120640"/>
+            <a:ext cx="1261872" cy="658368"/>
           </a:xfrm>
           <a:prstGeom prst="rect">
             <a:avLst/>
@@ -24341,16 +24083,16 @@
         </p:nvSpPr>
         <p:spPr>
           <a:xfrm>
-            <a:off x="7543800" y="4818888"/>
-            <a:ext cx="1097280" cy="384048"/>
-          </a:xfrm>
-          <a:prstGeom prst="rect">
-            <a:avLst/>
-          </a:prstGeom>
-          <a:noFill/>
-        </p:spPr>
-        <p:txBody>
-          <a:bodyPr wrap="square">
+            <a:off x="7680960" y="5120640"/>
+            <a:ext cx="1216151" cy="658368"/>
+          </a:xfrm>
+          <a:prstGeom prst="rect">
+            <a:avLst/>
+          </a:prstGeom>
+          <a:noFill/>
+        </p:spPr>
+        <p:txBody>
+          <a:bodyPr wrap="square" anchor="ctr">
             <a:spAutoFit/>
           </a:bodyPr>
           <a:lstStyle/>
@@ -24362,7 +24104,7 @@
                   <a:srgbClr val="8A9BAD"/>
                 </a:solidFill>
               </a:rPr>
-              <a:t>—</a:t>
+              <a:t>-</a:t>
             </a:r>
           </a:p>
         </p:txBody>
@@ -24375,7 +24117,7 @@
         </p:nvSpPr>
         <p:spPr>
           <a:xfrm>
-            <a:off x="457200" y="6035040"/>
+            <a:off x="457200" y="6080760"/>
             <a:ext cx="11247120" cy="320040"/>
           </a:xfrm>
           <a:prstGeom prst="rect">
@@ -24409,7 +24151,7 @@
         </p:nvSpPr>
         <p:spPr>
           <a:xfrm>
-            <a:off x="457200" y="6355080"/>
+            <a:off x="457200" y="6400800"/>
             <a:ext cx="11247120" cy="320040"/>
           </a:xfrm>
           <a:prstGeom prst="rect">
@@ -24568,7 +24310,7 @@
                   <a:srgbClr val="FFFFFF"/>
                 </a:solidFill>
               </a:rPr>
-              <a:t>SECTION 1 — THE ENVIRONMENT</a:t>
+              <a:t>SECTION 1: THE ENVIRONMENT</a:t>
             </a:r>
           </a:p>
         </p:txBody>
@@ -25136,7 +24878,7 @@
                   <a:srgbClr val="8A9BAD"/>
                 </a:solidFill>
               </a:rPr>
-              <a:t>⟵ parallel ⟶</a:t>
+              <a:t>parallel branch</a:t>
             </a:r>
           </a:p>
         </p:txBody>
@@ -25403,7 +25145,7 @@
                   <a:srgbClr val="8A9BAD"/>
                 </a:solidFill>
               </a:rPr>
-              <a:t>⟵ parallel ⟶</a:t>
+              <a:t>parallel branch</a:t>
             </a:r>
           </a:p>
         </p:txBody>
@@ -26412,7 +26154,7 @@
                   <a:srgbClr val="FFFFFF"/>
                 </a:solidFill>
               </a:rPr>
-              <a:t>Parallel branches (legal ∥ IT)</a:t>
+              <a:t>Parallel branches (legal + IT)</a:t>
             </a:r>
           </a:p>
         </p:txBody>
@@ -26781,7 +26523,7 @@
                   <a:srgbClr val="FFFFFF"/>
                 </a:solidFill>
               </a:rPr>
-              <a:t>SECTION 1 — THE ENVIRONMENT</a:t>
+              <a:t>SECTION 1: THE ENVIRONMENT</a:t>
             </a:r>
           </a:p>
         </p:txBody>
@@ -26815,7 +26557,7 @@
                   <a:srgbClr val="1A2B3C"/>
                 </a:solidFill>
               </a:rPr>
-              <a:t>Task Dependency DAG — Vendor Onboarding</a:t>
+              <a:t>Task Dependency DAG: Vendor Onboarding</a:t>
             </a:r>
           </a:p>
         </p:txBody>
@@ -26849,7 +26591,7 @@
                   <a:srgbClr val="2E9CFF"/>
                 </a:solidFill>
               </a:rPr>
-              <a:t>Credit fires when DB state matches the predicate — not when an agent says so</a:t>
+              <a:t>Credit fires when DB state matches the predicate, not when an agent says so</a:t>
             </a:r>
           </a:p>
         </p:txBody>
@@ -28077,7 +27819,7 @@
                   <a:srgbClr val="1A2B3C"/>
                 </a:solidFill>
               </a:rPr>
-              <a:t>•  Parallel branches (legal ∥ IT) both required before schedule_kickoff</a:t>
+              <a:t>•  Parallel branches (legal + IT) both required before schedule_kickoff</a:t>
             </a:r>
           </a:p>
         </p:txBody>
@@ -28249,7 +27991,7 @@
                   <a:srgbClr val="FFFFFF"/>
                 </a:solidFill>
               </a:rPr>
-              <a:t>SECTION 1 — THE ENVIRONMENT</a:t>
+              <a:t>SECTION 1: THE ENVIRONMENT</a:t>
             </a:r>
           </a:p>
         </p:txBody>
@@ -28317,7 +28059,7 @@
                   <a:srgbClr val="2E9CFF"/>
                 </a:solidFill>
               </a:rPr>
-              <a:t>Agents must search and discover — ticket IDs are never pre-known</a:t>
+              <a:t>Agents must search and discover - ticket IDs are never pre-known</a:t>
             </a:r>
           </a:p>
         </p:txBody>
@@ -28430,7 +28172,7 @@
                   <a:srgbClr val="1AB070"/>
                 </a:solidFill>
               </a:rPr>
-              <a:t>✓  Own email inbox headers (body requires read_email)</a:t>
+              <a:t>Yes  Own email inbox headers (body requires read_email)</a:t>
             </a:r>
           </a:p>
         </p:txBody>
@@ -28464,7 +28206,7 @@
                   <a:srgbClr val="1AB070"/>
                 </a:solidFill>
               </a:rPr>
-              <a:t>✓  Slack channels they belong to</a:t>
+              <a:t>Yes  Slack channels they belong to</a:t>
             </a:r>
           </a:p>
         </p:txBody>
@@ -28498,7 +28240,7 @@
                   <a:srgbClr val="1AB070"/>
                 </a:solidFill>
               </a:rPr>
-              <a:t>✓  Jira tickets returned by their own search query</a:t>
+              <a:t>Yes  Jira tickets returned by their own search query</a:t>
             </a:r>
           </a:p>
         </p:txBody>
@@ -28532,7 +28274,7 @@
                   <a:srgbClr val="1AB070"/>
                 </a:solidFill>
               </a:rPr>
-              <a:t>✓  Own calendar events only</a:t>
+              <a:t>Yes  Own calendar events only</a:t>
             </a:r>
           </a:p>
         </p:txBody>
@@ -28645,7 +28387,7 @@
                   <a:srgbClr val="E53E3E"/>
                 </a:solidFill>
               </a:rPr>
-              <a:t>✗  Other agents' inboxes</a:t>
+              <a:t>No   Other agents' inboxes</a:t>
             </a:r>
           </a:p>
         </p:txBody>
@@ -28679,7 +28421,7 @@
                   <a:srgbClr val="E53E3E"/>
                 </a:solidFill>
               </a:rPr>
-              <a:t>✗  Verifier progress or subgoal status</a:t>
+              <a:t>No   Verifier progress or subgoal status</a:t>
             </a:r>
           </a:p>
         </p:txBody>
@@ -28713,7 +28455,7 @@
                   <a:srgbClr val="E53E3E"/>
                 </a:solidFill>
               </a:rPr>
-              <a:t>✗  Full Jira database (search required)</a:t>
+              <a:t>No   Full Jira database (search required)</a:t>
             </a:r>
           </a:p>
         </p:txBody>
@@ -28747,7 +28489,7 @@
                   <a:srgbClr val="E53E3E"/>
                 </a:solidFill>
               </a:rPr>
-              <a:t>✗  Sheet cells outside membership role</a:t>
+              <a:t>No   Sheet cells outside membership role</a:t>
             </a:r>
           </a:p>
         </p:txBody>
@@ -28901,7 +28643,7 @@
                   <a:srgbClr val="2E9CFF"/>
                 </a:solidFill>
               </a:rPr>
-              <a:t>Wrong permission → {"success": false, "message": "Permission denied"} — not silent failure</a:t>
+              <a:t>Wrong permission → {"success": false, "message": "Permission denied"} - not silent failure</a:t>
             </a:r>
           </a:p>
         </p:txBody>
@@ -29039,7 +28781,7 @@
                   <a:srgbClr val="FFFFFF"/>
                 </a:solidFill>
               </a:rPr>
-              <a:t>SECTION 1 — THE ENVIRONMENT</a:t>
+              <a:t>SECTION 1: THE ENVIRONMENT</a:t>
             </a:r>
           </a:p>
         </p:txBody>
@@ -29232,7 +28974,7 @@
         <p:spPr>
           <a:xfrm>
             <a:off x="5074920" y="1901952"/>
-            <a:ext cx="3657600" cy="320040"/>
+            <a:ext cx="6675120" cy="320040"/>
           </a:xfrm>
           <a:prstGeom prst="rect">
             <a:avLst/>
@@ -29259,41 +29001,7 @@
       </p:sp>
       <p:sp>
         <p:nvSpPr>
-          <p:cNvPr id="11" name="TextBox 10"/>
-          <p:cNvSpPr txBox="1"/>
-          <p:nvPr/>
-        </p:nvSpPr>
-        <p:spPr>
-          <a:xfrm>
-            <a:off x="8732520" y="1901952"/>
-            <a:ext cx="2743200" cy="320040"/>
-          </a:xfrm>
-          <a:prstGeom prst="rect">
-            <a:avLst/>
-          </a:prstGeom>
-          <a:noFill/>
-        </p:spPr>
-        <p:txBody>
-          <a:bodyPr wrap="square">
-            <a:spAutoFit/>
-          </a:bodyPr>
-          <a:lstStyle/>
-          <a:p>
-            <a:pPr algn="l"/>
-            <a:r>
-              <a:rPr sz="1100" b="1" i="0">
-                <a:solidFill>
-                  <a:srgbClr val="FFFFFF"/>
-                </a:solidFill>
-              </a:rPr>
-              <a:t/>
-            </a:r>
-          </a:p>
-        </p:txBody>
-      </p:sp>
-      <p:sp>
-        <p:nvSpPr>
-          <p:cNvPr id="12" name="Rectangle 11"/>
+          <p:cNvPr id="11" name="Rectangle 10"/>
           <p:cNvSpPr/>
           <p:nvPr/>
         </p:nvSpPr>
@@ -29338,7 +29046,7 @@
       </p:sp>
       <p:sp>
         <p:nvSpPr>
-          <p:cNvPr id="13" name="TextBox 12"/>
+          <p:cNvPr id="12" name="TextBox 11"/>
           <p:cNvSpPr txBox="1"/>
           <p:nvPr/>
         </p:nvSpPr>
@@ -29372,7 +29080,7 @@
       </p:sp>
       <p:sp>
         <p:nvSpPr>
-          <p:cNvPr id="14" name="TextBox 13"/>
+          <p:cNvPr id="13" name="TextBox 12"/>
           <p:cNvSpPr txBox="1"/>
           <p:nvPr/>
         </p:nvSpPr>
@@ -29406,7 +29114,7 @@
       </p:sp>
       <p:sp>
         <p:nvSpPr>
-          <p:cNvPr id="15" name="TextBox 14"/>
+          <p:cNvPr id="14" name="TextBox 13"/>
           <p:cNvSpPr txBox="1"/>
           <p:nvPr/>
         </p:nvSpPr>
@@ -29440,7 +29148,7 @@
       </p:sp>
       <p:sp>
         <p:nvSpPr>
-          <p:cNvPr id="16" name="Rectangle 15"/>
+          <p:cNvPr id="15" name="Rectangle 14"/>
           <p:cNvSpPr/>
           <p:nvPr/>
         </p:nvSpPr>
@@ -29485,7 +29193,7 @@
       </p:sp>
       <p:sp>
         <p:nvSpPr>
-          <p:cNvPr id="17" name="TextBox 16"/>
+          <p:cNvPr id="16" name="TextBox 15"/>
           <p:cNvSpPr txBox="1"/>
           <p:nvPr/>
         </p:nvSpPr>
@@ -29519,7 +29227,7 @@
       </p:sp>
       <p:sp>
         <p:nvSpPr>
-          <p:cNvPr id="18" name="TextBox 17"/>
+          <p:cNvPr id="17" name="TextBox 16"/>
           <p:cNvSpPr txBox="1"/>
           <p:nvPr/>
         </p:nvSpPr>
@@ -29546,14 +29254,14 @@
                   <a:srgbClr val="2E9CFF"/>
                 </a:solidFill>
               </a:rPr>
-              <a:t>+8×(1/N)</a:t>
-            </a:r>
-          </a:p>
-        </p:txBody>
-      </p:sp>
-      <p:sp>
-        <p:nvSpPr>
-          <p:cNvPr id="19" name="TextBox 18"/>
+              <a:t>+8x(1/N)</a:t>
+            </a:r>
+          </a:p>
+        </p:txBody>
+      </p:sp>
+      <p:sp>
+        <p:nvSpPr>
+          <p:cNvPr id="18" name="TextBox 17"/>
           <p:cNvSpPr txBox="1"/>
           <p:nvPr/>
         </p:nvSpPr>
@@ -29587,7 +29295,7 @@
       </p:sp>
       <p:sp>
         <p:nvSpPr>
-          <p:cNvPr id="20" name="Rectangle 19"/>
+          <p:cNvPr id="19" name="Rectangle 18"/>
           <p:cNvSpPr/>
           <p:nvPr/>
         </p:nvSpPr>
@@ -29632,7 +29340,7 @@
       </p:sp>
       <p:sp>
         <p:nvSpPr>
-          <p:cNvPr id="21" name="TextBox 20"/>
+          <p:cNvPr id="20" name="TextBox 19"/>
           <p:cNvSpPr txBox="1"/>
           <p:nvPr/>
         </p:nvSpPr>
@@ -29666,7 +29374,7 @@
       </p:sp>
       <p:sp>
         <p:nvSpPr>
-          <p:cNvPr id="22" name="TextBox 21"/>
+          <p:cNvPr id="21" name="TextBox 20"/>
           <p:cNvSpPr txBox="1"/>
           <p:nvPr/>
         </p:nvSpPr>
@@ -29700,7 +29408,7 @@
       </p:sp>
       <p:sp>
         <p:nvSpPr>
-          <p:cNvPr id="23" name="TextBox 22"/>
+          <p:cNvPr id="22" name="TextBox 21"/>
           <p:cNvSpPr txBox="1"/>
           <p:nvPr/>
         </p:nvSpPr>
@@ -29734,7 +29442,7 @@
       </p:sp>
       <p:sp>
         <p:nvSpPr>
-          <p:cNvPr id="24" name="Rectangle 23"/>
+          <p:cNvPr id="23" name="Rectangle 22"/>
           <p:cNvSpPr/>
           <p:nvPr/>
         </p:nvSpPr>
@@ -29779,7 +29487,7 @@
       </p:sp>
       <p:sp>
         <p:nvSpPr>
-          <p:cNvPr id="25" name="TextBox 24"/>
+          <p:cNvPr id="24" name="TextBox 23"/>
           <p:cNvSpPr txBox="1"/>
           <p:nvPr/>
         </p:nvSpPr>
@@ -29813,7 +29521,7 @@
       </p:sp>
       <p:sp>
         <p:nvSpPr>
-          <p:cNvPr id="26" name="TextBox 25"/>
+          <p:cNvPr id="25" name="TextBox 24"/>
           <p:cNvSpPr txBox="1"/>
           <p:nvPr/>
         </p:nvSpPr>
@@ -29847,7 +29555,7 @@
       </p:sp>
       <p:sp>
         <p:nvSpPr>
-          <p:cNvPr id="27" name="TextBox 26"/>
+          <p:cNvPr id="26" name="TextBox 25"/>
           <p:cNvSpPr txBox="1"/>
           <p:nvPr/>
         </p:nvSpPr>
@@ -29881,7 +29589,7 @@
       </p:sp>
       <p:sp>
         <p:nvSpPr>
-          <p:cNvPr id="28" name="Rectangle 27"/>
+          <p:cNvPr id="27" name="Rectangle 26"/>
           <p:cNvSpPr/>
           <p:nvPr/>
         </p:nvSpPr>
@@ -29926,7 +29634,7 @@
       </p:sp>
       <p:sp>
         <p:nvSpPr>
-          <p:cNvPr id="29" name="TextBox 28"/>
+          <p:cNvPr id="28" name="TextBox 27"/>
           <p:cNvSpPr txBox="1"/>
           <p:nvPr/>
         </p:nvSpPr>
@@ -29960,7 +29668,7 @@
       </p:sp>
       <p:sp>
         <p:nvSpPr>
-          <p:cNvPr id="30" name="TextBox 29"/>
+          <p:cNvPr id="29" name="TextBox 28"/>
           <p:cNvSpPr txBox="1"/>
           <p:nvPr/>
         </p:nvSpPr>
@@ -29987,14 +29695,14 @@
                   <a:srgbClr val="E53E3E"/>
                 </a:solidFill>
               </a:rPr>
-              <a:t>−1.0</a:t>
-            </a:r>
-          </a:p>
-        </p:txBody>
-      </p:sp>
-      <p:sp>
-        <p:nvSpPr>
-          <p:cNvPr id="31" name="TextBox 30"/>
+              <a:t>-1.0</a:t>
+            </a:r>
+          </a:p>
+        </p:txBody>
+      </p:sp>
+      <p:sp>
+        <p:nvSpPr>
+          <p:cNvPr id="30" name="TextBox 29"/>
           <p:cNvSpPr txBox="1"/>
           <p:nvPr/>
         </p:nvSpPr>
@@ -30028,7 +29736,7 @@
       </p:sp>
       <p:sp>
         <p:nvSpPr>
-          <p:cNvPr id="32" name="Rectangle 31"/>
+          <p:cNvPr id="31" name="Rectangle 30"/>
           <p:cNvSpPr/>
           <p:nvPr/>
         </p:nvSpPr>
@@ -30073,7 +29781,7 @@
       </p:sp>
       <p:sp>
         <p:nvSpPr>
-          <p:cNvPr id="33" name="TextBox 32"/>
+          <p:cNvPr id="32" name="TextBox 31"/>
           <p:cNvSpPr txBox="1"/>
           <p:nvPr/>
         </p:nvSpPr>
@@ -30107,7 +29815,7 @@
       </p:sp>
       <p:sp>
         <p:nvSpPr>
-          <p:cNvPr id="34" name="TextBox 33"/>
+          <p:cNvPr id="33" name="TextBox 32"/>
           <p:cNvSpPr txBox="1"/>
           <p:nvPr/>
         </p:nvSpPr>
@@ -30134,14 +29842,14 @@
                   <a:srgbClr val="CC6000"/>
                 </a:solidFill>
               </a:rPr>
-              <a:t>−0.10</a:t>
-            </a:r>
-          </a:p>
-        </p:txBody>
-      </p:sp>
-      <p:sp>
-        <p:nvSpPr>
-          <p:cNvPr id="35" name="TextBox 34"/>
+              <a:t>-0.10</a:t>
+            </a:r>
+          </a:p>
+        </p:txBody>
+      </p:sp>
+      <p:sp>
+        <p:nvSpPr>
+          <p:cNvPr id="34" name="TextBox 33"/>
           <p:cNvSpPr txBox="1"/>
           <p:nvPr/>
         </p:nvSpPr>
@@ -30175,7 +29883,7 @@
       </p:sp>
       <p:sp>
         <p:nvSpPr>
-          <p:cNvPr id="36" name="Rectangle 35"/>
+          <p:cNvPr id="35" name="Rectangle 34"/>
           <p:cNvSpPr/>
           <p:nvPr/>
         </p:nvSpPr>
@@ -30220,7 +29928,7 @@
       </p:sp>
       <p:sp>
         <p:nvSpPr>
-          <p:cNvPr id="37" name="TextBox 36"/>
+          <p:cNvPr id="36" name="TextBox 35"/>
           <p:cNvSpPr txBox="1"/>
           <p:nvPr/>
         </p:nvSpPr>
@@ -30254,7 +29962,7 @@
       </p:sp>
       <p:sp>
         <p:nvSpPr>
-          <p:cNvPr id="38" name="TextBox 37"/>
+          <p:cNvPr id="37" name="TextBox 36"/>
           <p:cNvSpPr txBox="1"/>
           <p:nvPr/>
         </p:nvSpPr>
@@ -30281,14 +29989,14 @@
                   <a:srgbClr val="E53E3E"/>
                 </a:solidFill>
               </a:rPr>
-              <a:t>−15.0</a:t>
-            </a:r>
-          </a:p>
-        </p:txBody>
-      </p:sp>
-      <p:sp>
-        <p:nvSpPr>
-          <p:cNvPr id="39" name="TextBox 38"/>
+              <a:t>-15.0</a:t>
+            </a:r>
+          </a:p>
+        </p:txBody>
+      </p:sp>
+      <p:sp>
+        <p:nvSpPr>
+          <p:cNvPr id="38" name="TextBox 37"/>
           <p:cNvSpPr txBox="1"/>
           <p:nvPr/>
         </p:nvSpPr>
@@ -30322,7 +30030,7 @@
       </p:sp>
       <p:sp>
         <p:nvSpPr>
-          <p:cNvPr id="40" name="Rectangle 39"/>
+          <p:cNvPr id="39" name="Rectangle 38"/>
           <p:cNvSpPr/>
           <p:nvPr/>
         </p:nvSpPr>
@@ -30365,7 +30073,7 @@
       </p:sp>
       <p:sp>
         <p:nvSpPr>
-          <p:cNvPr id="41" name="TextBox 40"/>
+          <p:cNvPr id="40" name="TextBox 39"/>
           <p:cNvSpPr txBox="1"/>
           <p:nvPr/>
         </p:nvSpPr>
@@ -30392,7 +30100,7 @@
                   <a:srgbClr val="0A5A36"/>
                 </a:solidFill>
               </a:rPr>
-              <a:t>Verification: Success = state predicate over SQLite — not string match, not LLM judge. Clause-boundary negation detection: "NOT approved" → fail · "Approved. No further action." → pass</a:t>
+              <a:t>Verification: Success = state predicate over SQLite - not string match, not LLM judge. Clause-boundary negation detection: "NOT approved" → fail · "Approved. No further action." → pass</a:t>
             </a:r>
           </a:p>
         </p:txBody>

</xml_diff>

<commit_message>
Update presentation with manual edits
</commit_message>
<xml_diff>
--- a/deliverables/enterprise_marl_benchmark.pptx
+++ b/deliverables/enterprise_marl_benchmark.pptx
@@ -4,29 +4,32 @@
   <p:sldMasterIdLst>
     <p:sldMasterId id="2147483648" r:id="rId1"/>
   </p:sldMasterIdLst>
+  <p:notesMasterIdLst>
+    <p:notesMasterId r:id="rId22"/>
+  </p:notesMasterIdLst>
   <p:sldIdLst>
-    <p:sldId id="256" r:id="rId7"/>
-    <p:sldId id="257" r:id="rId8"/>
-    <p:sldId id="258" r:id="rId9"/>
-    <p:sldId id="259" r:id="rId10"/>
-    <p:sldId id="260" r:id="rId11"/>
-    <p:sldId id="261" r:id="rId12"/>
-    <p:sldId id="262" r:id="rId13"/>
-    <p:sldId id="263" r:id="rId14"/>
-    <p:sldId id="264" r:id="rId15"/>
-    <p:sldId id="265" r:id="rId16"/>
-    <p:sldId id="266" r:id="rId17"/>
-    <p:sldId id="267" r:id="rId18"/>
-    <p:sldId id="268" r:id="rId19"/>
-    <p:sldId id="269" r:id="rId20"/>
-    <p:sldId id="270" r:id="rId21"/>
-    <p:sldId id="271" r:id="rId22"/>
-    <p:sldId id="272" r:id="rId23"/>
-    <p:sldId id="273" r:id="rId24"/>
-    <p:sldId id="274" r:id="rId25"/>
-    <p:sldId id="275" r:id="rId26"/>
+    <p:sldId id="256" r:id="rId2"/>
+    <p:sldId id="257" r:id="rId3"/>
+    <p:sldId id="258" r:id="rId4"/>
+    <p:sldId id="259" r:id="rId5"/>
+    <p:sldId id="260" r:id="rId6"/>
+    <p:sldId id="261" r:id="rId7"/>
+    <p:sldId id="262" r:id="rId8"/>
+    <p:sldId id="263" r:id="rId9"/>
+    <p:sldId id="264" r:id="rId10"/>
+    <p:sldId id="265" r:id="rId11"/>
+    <p:sldId id="266" r:id="rId12"/>
+    <p:sldId id="267" r:id="rId13"/>
+    <p:sldId id="268" r:id="rId14"/>
+    <p:sldId id="269" r:id="rId15"/>
+    <p:sldId id="270" r:id="rId16"/>
+    <p:sldId id="271" r:id="rId17"/>
+    <p:sldId id="272" r:id="rId18"/>
+    <p:sldId id="273" r:id="rId19"/>
+    <p:sldId id="274" r:id="rId20"/>
+    <p:sldId id="275" r:id="rId21"/>
   </p:sldIdLst>
-  <p:sldSz cx="12188952" cy="6858000" type="screen4x3"/>
+  <p:sldSz cx="12188825" cy="6858000"/>
   <p:notesSz cx="6858000" cy="9144000"/>
   <p:defaultTextStyle>
     <a:defPPr>
@@ -123,7 +126,457 @@
       </a:defRPr>
     </a:lvl9pPr>
   </p:defaultTextStyle>
+  <p:extLst>
+    <p:ext uri="{EFAFB233-063F-42B5-8137-9DF3F51BA10A}">
+      <p15:sldGuideLst xmlns:p15="http://schemas.microsoft.com/office/powerpoint/2012/main">
+        <p15:guide id="1" orient="horz" pos="2160">
+          <p15:clr>
+            <a:srgbClr val="A4A3A4"/>
+          </p15:clr>
+        </p15:guide>
+        <p15:guide id="2" pos="2880">
+          <p15:clr>
+            <a:srgbClr val="A4A3A4"/>
+          </p15:clr>
+        </p15:guide>
+      </p15:sldGuideLst>
+    </p:ext>
+  </p:extLst>
 </p:presentation>
+</file>
+
+<file path=ppt/notesMasters/notesMaster1.xml><?xml version="1.0" encoding="utf-8"?>
+<p:notesMaster xmlns:a="http://schemas.openxmlformats.org/drawingml/2006/main" xmlns:r="http://schemas.openxmlformats.org/officeDocument/2006/relationships" xmlns:p="http://schemas.openxmlformats.org/presentationml/2006/main">
+  <p:cSld>
+    <p:bg>
+      <p:bgRef idx="1001">
+        <a:schemeClr val="bg1"/>
+      </p:bgRef>
+    </p:bg>
+    <p:spTree>
+      <p:nvGrpSpPr>
+        <p:cNvPr id="1" name=""/>
+        <p:cNvGrpSpPr/>
+        <p:nvPr/>
+      </p:nvGrpSpPr>
+      <p:grpSpPr>
+        <a:xfrm>
+          <a:off x="0" y="0"/>
+          <a:ext cx="0" cy="0"/>
+          <a:chOff x="0" y="0"/>
+          <a:chExt cx="0" cy="0"/>
+        </a:xfrm>
+      </p:grpSpPr>
+      <p:sp>
+        <p:nvSpPr>
+          <p:cNvPr id="2" name="Header Placeholder 1"/>
+          <p:cNvSpPr>
+            <a:spLocks noGrp="1"/>
+          </p:cNvSpPr>
+          <p:nvPr>
+            <p:ph type="hdr" sz="quarter"/>
+          </p:nvPr>
+        </p:nvSpPr>
+        <p:spPr>
+          <a:xfrm>
+            <a:off x="0" y="0"/>
+            <a:ext cx="2971800" cy="458788"/>
+          </a:xfrm>
+          <a:prstGeom prst="rect">
+            <a:avLst/>
+          </a:prstGeom>
+        </p:spPr>
+        <p:txBody>
+          <a:bodyPr vert="horz" lIns="91440" tIns="45720" rIns="91440" bIns="45720" rtlCol="0"/>
+          <a:lstStyle>
+            <a:lvl1pPr algn="l">
+              <a:defRPr sz="1200"/>
+            </a:lvl1pPr>
+          </a:lstStyle>
+          <a:p>
+            <a:endParaRPr lang="en-IN"/>
+          </a:p>
+        </p:txBody>
+      </p:sp>
+      <p:sp>
+        <p:nvSpPr>
+          <p:cNvPr id="3" name="Date Placeholder 2"/>
+          <p:cNvSpPr>
+            <a:spLocks noGrp="1"/>
+          </p:cNvSpPr>
+          <p:nvPr>
+            <p:ph type="dt" idx="1"/>
+          </p:nvPr>
+        </p:nvSpPr>
+        <p:spPr>
+          <a:xfrm>
+            <a:off x="3884613" y="0"/>
+            <a:ext cx="2971800" cy="458788"/>
+          </a:xfrm>
+          <a:prstGeom prst="rect">
+            <a:avLst/>
+          </a:prstGeom>
+        </p:spPr>
+        <p:txBody>
+          <a:bodyPr vert="horz" lIns="91440" tIns="45720" rIns="91440" bIns="45720" rtlCol="0"/>
+          <a:lstStyle>
+            <a:lvl1pPr algn="r">
+              <a:defRPr sz="1200"/>
+            </a:lvl1pPr>
+          </a:lstStyle>
+          <a:p>
+            <a:fld id="{82F22250-5D5B-4EBE-8AD9-BAE428094005}" type="datetimeFigureOut">
+              <a:rPr lang="en-IN" smtClean="0"/>
+              <a:t>17-08-2026</a:t>
+            </a:fld>
+            <a:endParaRPr lang="en-IN"/>
+          </a:p>
+        </p:txBody>
+      </p:sp>
+      <p:sp>
+        <p:nvSpPr>
+          <p:cNvPr id="4" name="Slide Image Placeholder 3"/>
+          <p:cNvSpPr>
+            <a:spLocks noGrp="1" noRot="1" noChangeAspect="1"/>
+          </p:cNvSpPr>
+          <p:nvPr>
+            <p:ph type="sldImg" idx="2"/>
+          </p:nvPr>
+        </p:nvSpPr>
+        <p:spPr>
+          <a:xfrm>
+            <a:off x="685800" y="1143000"/>
+            <a:ext cx="5486400" cy="3086100"/>
+          </a:xfrm>
+          <a:prstGeom prst="rect">
+            <a:avLst/>
+          </a:prstGeom>
+          <a:noFill/>
+          <a:ln w="12700">
+            <a:solidFill>
+              <a:prstClr val="black"/>
+            </a:solidFill>
+          </a:ln>
+        </p:spPr>
+        <p:txBody>
+          <a:bodyPr vert="horz" lIns="91440" tIns="45720" rIns="91440" bIns="45720" rtlCol="0" anchor="ctr"/>
+          <a:lstStyle/>
+          <a:p>
+            <a:endParaRPr lang="en-IN"/>
+          </a:p>
+        </p:txBody>
+      </p:sp>
+      <p:sp>
+        <p:nvSpPr>
+          <p:cNvPr id="5" name="Notes Placeholder 4"/>
+          <p:cNvSpPr>
+            <a:spLocks noGrp="1"/>
+          </p:cNvSpPr>
+          <p:nvPr>
+            <p:ph type="body" sz="quarter" idx="3"/>
+          </p:nvPr>
+        </p:nvSpPr>
+        <p:spPr>
+          <a:xfrm>
+            <a:off x="685800" y="4400550"/>
+            <a:ext cx="5486400" cy="3600450"/>
+          </a:xfrm>
+          <a:prstGeom prst="rect">
+            <a:avLst/>
+          </a:prstGeom>
+        </p:spPr>
+        <p:txBody>
+          <a:bodyPr vert="horz" lIns="91440" tIns="45720" rIns="91440" bIns="45720" rtlCol="0"/>
+          <a:lstStyle/>
+          <a:p>
+            <a:pPr lvl="0"/>
+            <a:r>
+              <a:rPr lang="en-US"/>
+              <a:t>Click to edit Master text styles</a:t>
+            </a:r>
+          </a:p>
+          <a:p>
+            <a:pPr lvl="1"/>
+            <a:r>
+              <a:rPr lang="en-US"/>
+              <a:t>Second level</a:t>
+            </a:r>
+          </a:p>
+          <a:p>
+            <a:pPr lvl="2"/>
+            <a:r>
+              <a:rPr lang="en-US"/>
+              <a:t>Third level</a:t>
+            </a:r>
+          </a:p>
+          <a:p>
+            <a:pPr lvl="3"/>
+            <a:r>
+              <a:rPr lang="en-US"/>
+              <a:t>Fourth level</a:t>
+            </a:r>
+          </a:p>
+          <a:p>
+            <a:pPr lvl="4"/>
+            <a:r>
+              <a:rPr lang="en-US"/>
+              <a:t>Fifth level</a:t>
+            </a:r>
+            <a:endParaRPr lang="en-IN"/>
+          </a:p>
+        </p:txBody>
+      </p:sp>
+      <p:sp>
+        <p:nvSpPr>
+          <p:cNvPr id="6" name="Footer Placeholder 5"/>
+          <p:cNvSpPr>
+            <a:spLocks noGrp="1"/>
+          </p:cNvSpPr>
+          <p:nvPr>
+            <p:ph type="ftr" sz="quarter" idx="4"/>
+          </p:nvPr>
+        </p:nvSpPr>
+        <p:spPr>
+          <a:xfrm>
+            <a:off x="0" y="8685213"/>
+            <a:ext cx="2971800" cy="458787"/>
+          </a:xfrm>
+          <a:prstGeom prst="rect">
+            <a:avLst/>
+          </a:prstGeom>
+        </p:spPr>
+        <p:txBody>
+          <a:bodyPr vert="horz" lIns="91440" tIns="45720" rIns="91440" bIns="45720" rtlCol="0" anchor="b"/>
+          <a:lstStyle>
+            <a:lvl1pPr algn="l">
+              <a:defRPr sz="1200"/>
+            </a:lvl1pPr>
+          </a:lstStyle>
+          <a:p>
+            <a:endParaRPr lang="en-IN"/>
+          </a:p>
+        </p:txBody>
+      </p:sp>
+      <p:sp>
+        <p:nvSpPr>
+          <p:cNvPr id="7" name="Slide Number Placeholder 6"/>
+          <p:cNvSpPr>
+            <a:spLocks noGrp="1"/>
+          </p:cNvSpPr>
+          <p:nvPr>
+            <p:ph type="sldNum" sz="quarter" idx="5"/>
+          </p:nvPr>
+        </p:nvSpPr>
+        <p:spPr>
+          <a:xfrm>
+            <a:off x="3884613" y="8685213"/>
+            <a:ext cx="2971800" cy="458787"/>
+          </a:xfrm>
+          <a:prstGeom prst="rect">
+            <a:avLst/>
+          </a:prstGeom>
+        </p:spPr>
+        <p:txBody>
+          <a:bodyPr vert="horz" lIns="91440" tIns="45720" rIns="91440" bIns="45720" rtlCol="0" anchor="b"/>
+          <a:lstStyle>
+            <a:lvl1pPr algn="r">
+              <a:defRPr sz="1200"/>
+            </a:lvl1pPr>
+          </a:lstStyle>
+          <a:p>
+            <a:fld id="{EE2FBFDF-BF14-4A92-8450-6978D181CA0E}" type="slidenum">
+              <a:rPr lang="en-IN" smtClean="0"/>
+              <a:t>‹#›</a:t>
+            </a:fld>
+            <a:endParaRPr lang="en-IN"/>
+          </a:p>
+        </p:txBody>
+      </p:sp>
+    </p:spTree>
+    <p:extLst>
+      <p:ext uri="{BB962C8B-B14F-4D97-AF65-F5344CB8AC3E}">
+        <p14:creationId xmlns:p14="http://schemas.microsoft.com/office/powerpoint/2010/main" val="537859180"/>
+      </p:ext>
+    </p:extLst>
+  </p:cSld>
+  <p:clrMap bg1="lt1" tx1="dk1" bg2="lt2" tx2="dk2" accent1="accent1" accent2="accent2" accent3="accent3" accent4="accent4" accent5="accent5" accent6="accent6" hlink="hlink" folHlink="folHlink"/>
+  <p:notesStyle>
+    <a:lvl1pPr marL="0" algn="l" defTabSz="914400" rtl="0" eaLnBrk="1" latinLnBrk="0" hangingPunct="1">
+      <a:defRPr sz="1200" kern="1200">
+        <a:solidFill>
+          <a:schemeClr val="tx1"/>
+        </a:solidFill>
+        <a:latin typeface="+mn-lt"/>
+        <a:ea typeface="+mn-ea"/>
+        <a:cs typeface="+mn-cs"/>
+      </a:defRPr>
+    </a:lvl1pPr>
+    <a:lvl2pPr marL="457200" algn="l" defTabSz="914400" rtl="0" eaLnBrk="1" latinLnBrk="0" hangingPunct="1">
+      <a:defRPr sz="1200" kern="1200">
+        <a:solidFill>
+          <a:schemeClr val="tx1"/>
+        </a:solidFill>
+        <a:latin typeface="+mn-lt"/>
+        <a:ea typeface="+mn-ea"/>
+        <a:cs typeface="+mn-cs"/>
+      </a:defRPr>
+    </a:lvl2pPr>
+    <a:lvl3pPr marL="914400" algn="l" defTabSz="914400" rtl="0" eaLnBrk="1" latinLnBrk="0" hangingPunct="1">
+      <a:defRPr sz="1200" kern="1200">
+        <a:solidFill>
+          <a:schemeClr val="tx1"/>
+        </a:solidFill>
+        <a:latin typeface="+mn-lt"/>
+        <a:ea typeface="+mn-ea"/>
+        <a:cs typeface="+mn-cs"/>
+      </a:defRPr>
+    </a:lvl3pPr>
+    <a:lvl4pPr marL="1371600" algn="l" defTabSz="914400" rtl="0" eaLnBrk="1" latinLnBrk="0" hangingPunct="1">
+      <a:defRPr sz="1200" kern="1200">
+        <a:solidFill>
+          <a:schemeClr val="tx1"/>
+        </a:solidFill>
+        <a:latin typeface="+mn-lt"/>
+        <a:ea typeface="+mn-ea"/>
+        <a:cs typeface="+mn-cs"/>
+      </a:defRPr>
+    </a:lvl4pPr>
+    <a:lvl5pPr marL="1828800" algn="l" defTabSz="914400" rtl="0" eaLnBrk="1" latinLnBrk="0" hangingPunct="1">
+      <a:defRPr sz="1200" kern="1200">
+        <a:solidFill>
+          <a:schemeClr val="tx1"/>
+        </a:solidFill>
+        <a:latin typeface="+mn-lt"/>
+        <a:ea typeface="+mn-ea"/>
+        <a:cs typeface="+mn-cs"/>
+      </a:defRPr>
+    </a:lvl5pPr>
+    <a:lvl6pPr marL="2286000" algn="l" defTabSz="914400" rtl="0" eaLnBrk="1" latinLnBrk="0" hangingPunct="1">
+      <a:defRPr sz="1200" kern="1200">
+        <a:solidFill>
+          <a:schemeClr val="tx1"/>
+        </a:solidFill>
+        <a:latin typeface="+mn-lt"/>
+        <a:ea typeface="+mn-ea"/>
+        <a:cs typeface="+mn-cs"/>
+      </a:defRPr>
+    </a:lvl6pPr>
+    <a:lvl7pPr marL="2743200" algn="l" defTabSz="914400" rtl="0" eaLnBrk="1" latinLnBrk="0" hangingPunct="1">
+      <a:defRPr sz="1200" kern="1200">
+        <a:solidFill>
+          <a:schemeClr val="tx1"/>
+        </a:solidFill>
+        <a:latin typeface="+mn-lt"/>
+        <a:ea typeface="+mn-ea"/>
+        <a:cs typeface="+mn-cs"/>
+      </a:defRPr>
+    </a:lvl7pPr>
+    <a:lvl8pPr marL="3200400" algn="l" defTabSz="914400" rtl="0" eaLnBrk="1" latinLnBrk="0" hangingPunct="1">
+      <a:defRPr sz="1200" kern="1200">
+        <a:solidFill>
+          <a:schemeClr val="tx1"/>
+        </a:solidFill>
+        <a:latin typeface="+mn-lt"/>
+        <a:ea typeface="+mn-ea"/>
+        <a:cs typeface="+mn-cs"/>
+      </a:defRPr>
+    </a:lvl8pPr>
+    <a:lvl9pPr marL="3657600" algn="l" defTabSz="914400" rtl="0" eaLnBrk="1" latinLnBrk="0" hangingPunct="1">
+      <a:defRPr sz="1200" kern="1200">
+        <a:solidFill>
+          <a:schemeClr val="tx1"/>
+        </a:solidFill>
+        <a:latin typeface="+mn-lt"/>
+        <a:ea typeface="+mn-ea"/>
+        <a:cs typeface="+mn-cs"/>
+      </a:defRPr>
+    </a:lvl9pPr>
+  </p:notesStyle>
+</p:notesMaster>
+</file>
+
+<file path=ppt/notesSlides/notesSlide1.xml><?xml version="1.0" encoding="utf-8"?>
+<p:notes xmlns:a="http://schemas.openxmlformats.org/drawingml/2006/main" xmlns:r="http://schemas.openxmlformats.org/officeDocument/2006/relationships" xmlns:p="http://schemas.openxmlformats.org/presentationml/2006/main">
+  <p:cSld>
+    <p:spTree>
+      <p:nvGrpSpPr>
+        <p:cNvPr id="1" name=""/>
+        <p:cNvGrpSpPr/>
+        <p:nvPr/>
+      </p:nvGrpSpPr>
+      <p:grpSpPr>
+        <a:xfrm>
+          <a:off x="0" y="0"/>
+          <a:ext cx="0" cy="0"/>
+          <a:chOff x="0" y="0"/>
+          <a:chExt cx="0" cy="0"/>
+        </a:xfrm>
+      </p:grpSpPr>
+      <p:sp>
+        <p:nvSpPr>
+          <p:cNvPr id="2" name="Slide Image Placeholder 1"/>
+          <p:cNvSpPr>
+            <a:spLocks noGrp="1" noRot="1" noChangeAspect="1"/>
+          </p:cNvSpPr>
+          <p:nvPr>
+            <p:ph type="sldImg"/>
+          </p:nvPr>
+        </p:nvSpPr>
+        <p:spPr/>
+      </p:sp>
+      <p:sp>
+        <p:nvSpPr>
+          <p:cNvPr id="3" name="Notes Placeholder 2"/>
+          <p:cNvSpPr>
+            <a:spLocks noGrp="1"/>
+          </p:cNvSpPr>
+          <p:nvPr>
+            <p:ph type="body" idx="1"/>
+          </p:nvPr>
+        </p:nvSpPr>
+        <p:spPr/>
+        <p:txBody>
+          <a:bodyPr/>
+          <a:lstStyle/>
+          <a:p>
+            <a:endParaRPr lang="en-IN" dirty="0"/>
+          </a:p>
+        </p:txBody>
+      </p:sp>
+      <p:sp>
+        <p:nvSpPr>
+          <p:cNvPr id="4" name="Slide Number Placeholder 3"/>
+          <p:cNvSpPr>
+            <a:spLocks noGrp="1"/>
+          </p:cNvSpPr>
+          <p:nvPr>
+            <p:ph type="sldNum" sz="quarter" idx="5"/>
+          </p:nvPr>
+        </p:nvSpPr>
+        <p:spPr/>
+        <p:txBody>
+          <a:bodyPr/>
+          <a:lstStyle/>
+          <a:p>
+            <a:fld id="{EE2FBFDF-BF14-4A92-8450-6978D181CA0E}" type="slidenum">
+              <a:rPr lang="en-IN" smtClean="0"/>
+              <a:t>1</a:t>
+            </a:fld>
+            <a:endParaRPr lang="en-IN"/>
+          </a:p>
+        </p:txBody>
+      </p:sp>
+    </p:spTree>
+    <p:extLst>
+      <p:ext uri="{BB962C8B-B14F-4D97-AF65-F5344CB8AC3E}">
+        <p14:creationId xmlns:p14="http://schemas.microsoft.com/office/powerpoint/2010/main" val="3499947384"/>
+      </p:ext>
+    </p:extLst>
+  </p:cSld>
+  <p:clrMapOvr>
+    <a:masterClrMapping/>
+  </p:clrMapOvr>
+</p:notes>
 </file>
 
 <file path=ppt/slideLayouts/slideLayout1.xml><?xml version="1.0" encoding="utf-8"?>
@@ -164,10 +617,9 @@
           <a:lstStyle/>
           <a:p>
             <a:r>
-              <a:rPr lang="en-US" smtClean="0"/>
+              <a:rPr lang="en-US"/>
               <a:t>Click to edit Master title style</a:t>
             </a:r>
-            <a:endParaRPr lang="en-US"/>
           </a:p>
         </p:txBody>
       </p:sp>
@@ -283,10 +735,9 @@
           </a:lstStyle>
           <a:p>
             <a:r>
-              <a:rPr lang="en-US" smtClean="0"/>
+              <a:rPr lang="en-US"/>
               <a:t>Click to edit Master subtitle style</a:t>
             </a:r>
-            <a:endParaRPr lang="en-US"/>
           </a:p>
         </p:txBody>
       </p:sp>
@@ -307,7 +758,7 @@
           <a:p>
             <a:fld id="{5BCAD085-E8A6-8845-BD4E-CB4CCA059FC4}" type="datetimeFigureOut">
               <a:rPr lang="en-US" smtClean="0"/>
-              <a:t>1/27/13</a:t>
+              <a:t>8/17/2026</a:t>
             </a:fld>
             <a:endParaRPr lang="en-US"/>
           </a:p>
@@ -401,10 +852,9 @@
           <a:lstStyle/>
           <a:p>
             <a:r>
-              <a:rPr lang="en-US" smtClean="0"/>
+              <a:rPr lang="en-US"/>
               <a:t>Click to edit Master title style</a:t>
             </a:r>
-            <a:endParaRPr lang="en-US"/>
           </a:p>
         </p:txBody>
       </p:sp>
@@ -425,38 +875,37 @@
           <a:p>
             <a:pPr lvl="0"/>
             <a:r>
-              <a:rPr lang="en-US" smtClean="0"/>
+              <a:rPr lang="en-US"/>
               <a:t>Click to edit Master text styles</a:t>
             </a:r>
           </a:p>
           <a:p>
             <a:pPr lvl="1"/>
             <a:r>
-              <a:rPr lang="en-US" smtClean="0"/>
+              <a:rPr lang="en-US"/>
               <a:t>Second level</a:t>
             </a:r>
           </a:p>
           <a:p>
             <a:pPr lvl="2"/>
             <a:r>
-              <a:rPr lang="en-US" smtClean="0"/>
+              <a:rPr lang="en-US"/>
               <a:t>Third level</a:t>
             </a:r>
           </a:p>
           <a:p>
             <a:pPr lvl="3"/>
             <a:r>
-              <a:rPr lang="en-US" smtClean="0"/>
+              <a:rPr lang="en-US"/>
               <a:t>Fourth level</a:t>
             </a:r>
           </a:p>
           <a:p>
             <a:pPr lvl="4"/>
             <a:r>
-              <a:rPr lang="en-US" smtClean="0"/>
+              <a:rPr lang="en-US"/>
               <a:t>Fifth level</a:t>
             </a:r>
-            <a:endParaRPr lang="en-US"/>
           </a:p>
         </p:txBody>
       </p:sp>
@@ -477,7 +926,7 @@
           <a:p>
             <a:fld id="{5BCAD085-E8A6-8845-BD4E-CB4CCA059FC4}" type="datetimeFigureOut">
               <a:rPr lang="en-US" smtClean="0"/>
-              <a:t>1/27/13</a:t>
+              <a:t>8/17/2026</a:t>
             </a:fld>
             <a:endParaRPr lang="en-US"/>
           </a:p>
@@ -576,10 +1025,9 @@
           <a:lstStyle/>
           <a:p>
             <a:r>
-              <a:rPr lang="en-US" smtClean="0"/>
+              <a:rPr lang="en-US"/>
               <a:t>Click to edit Master title style</a:t>
             </a:r>
-            <a:endParaRPr lang="en-US"/>
           </a:p>
         </p:txBody>
       </p:sp>
@@ -605,38 +1053,37 @@
           <a:p>
             <a:pPr lvl="0"/>
             <a:r>
-              <a:rPr lang="en-US" smtClean="0"/>
+              <a:rPr lang="en-US"/>
               <a:t>Click to edit Master text styles</a:t>
             </a:r>
           </a:p>
           <a:p>
             <a:pPr lvl="1"/>
             <a:r>
-              <a:rPr lang="en-US" smtClean="0"/>
+              <a:rPr lang="en-US"/>
               <a:t>Second level</a:t>
             </a:r>
           </a:p>
           <a:p>
             <a:pPr lvl="2"/>
             <a:r>
-              <a:rPr lang="en-US" smtClean="0"/>
+              <a:rPr lang="en-US"/>
               <a:t>Third level</a:t>
             </a:r>
           </a:p>
           <a:p>
             <a:pPr lvl="3"/>
             <a:r>
-              <a:rPr lang="en-US" smtClean="0"/>
+              <a:rPr lang="en-US"/>
               <a:t>Fourth level</a:t>
             </a:r>
           </a:p>
           <a:p>
             <a:pPr lvl="4"/>
             <a:r>
-              <a:rPr lang="en-US" smtClean="0"/>
+              <a:rPr lang="en-US"/>
               <a:t>Fifth level</a:t>
             </a:r>
-            <a:endParaRPr lang="en-US"/>
           </a:p>
         </p:txBody>
       </p:sp>
@@ -657,7 +1104,7 @@
           <a:p>
             <a:fld id="{5BCAD085-E8A6-8845-BD4E-CB4CCA059FC4}" type="datetimeFigureOut">
               <a:rPr lang="en-US" smtClean="0"/>
-              <a:t>1/27/13</a:t>
+              <a:t>8/17/2026</a:t>
             </a:fld>
             <a:endParaRPr lang="en-US"/>
           </a:p>
@@ -751,10 +1198,9 @@
           <a:lstStyle/>
           <a:p>
             <a:r>
-              <a:rPr lang="en-US" smtClean="0"/>
+              <a:rPr lang="en-US"/>
               <a:t>Click to edit Master title style</a:t>
             </a:r>
-            <a:endParaRPr lang="en-US"/>
           </a:p>
         </p:txBody>
       </p:sp>
@@ -775,38 +1221,37 @@
           <a:p>
             <a:pPr lvl="0"/>
             <a:r>
-              <a:rPr lang="en-US" smtClean="0"/>
+              <a:rPr lang="en-US"/>
               <a:t>Click to edit Master text styles</a:t>
             </a:r>
           </a:p>
           <a:p>
             <a:pPr lvl="1"/>
             <a:r>
-              <a:rPr lang="en-US" smtClean="0"/>
+              <a:rPr lang="en-US"/>
               <a:t>Second level</a:t>
             </a:r>
           </a:p>
           <a:p>
             <a:pPr lvl="2"/>
             <a:r>
-              <a:rPr lang="en-US" smtClean="0"/>
+              <a:rPr lang="en-US"/>
               <a:t>Third level</a:t>
             </a:r>
           </a:p>
           <a:p>
             <a:pPr lvl="3"/>
             <a:r>
-              <a:rPr lang="en-US" smtClean="0"/>
+              <a:rPr lang="en-US"/>
               <a:t>Fourth level</a:t>
             </a:r>
           </a:p>
           <a:p>
             <a:pPr lvl="4"/>
             <a:r>
-              <a:rPr lang="en-US" smtClean="0"/>
+              <a:rPr lang="en-US"/>
               <a:t>Fifth level</a:t>
             </a:r>
-            <a:endParaRPr lang="en-US"/>
           </a:p>
         </p:txBody>
       </p:sp>
@@ -827,7 +1272,7 @@
           <a:p>
             <a:fld id="{5BCAD085-E8A6-8845-BD4E-CB4CCA059FC4}" type="datetimeFigureOut">
               <a:rPr lang="en-US" smtClean="0"/>
-              <a:t>1/27/13</a:t>
+              <a:t>8/17/2026</a:t>
             </a:fld>
             <a:endParaRPr lang="en-US"/>
           </a:p>
@@ -930,10 +1375,9 @@
           </a:lstStyle>
           <a:p>
             <a:r>
-              <a:rPr lang="en-US" smtClean="0"/>
+              <a:rPr lang="en-US"/>
               <a:t>Click to edit Master title style</a:t>
             </a:r>
-            <a:endParaRPr lang="en-US"/>
           </a:p>
         </p:txBody>
       </p:sp>
@@ -1050,7 +1494,7 @@
           <a:p>
             <a:pPr lvl="0"/>
             <a:r>
-              <a:rPr lang="en-US" smtClean="0"/>
+              <a:rPr lang="en-US"/>
               <a:t>Click to edit Master text styles</a:t>
             </a:r>
           </a:p>
@@ -1073,7 +1517,7 @@
           <a:p>
             <a:fld id="{5BCAD085-E8A6-8845-BD4E-CB4CCA059FC4}" type="datetimeFigureOut">
               <a:rPr lang="en-US" smtClean="0"/>
-              <a:t>1/27/13</a:t>
+              <a:t>8/17/2026</a:t>
             </a:fld>
             <a:endParaRPr lang="en-US"/>
           </a:p>
@@ -1167,10 +1611,9 @@
           <a:lstStyle/>
           <a:p>
             <a:r>
-              <a:rPr lang="en-US" smtClean="0"/>
+              <a:rPr lang="en-US"/>
               <a:t>Click to edit Master title style</a:t>
             </a:r>
-            <a:endParaRPr lang="en-US"/>
           </a:p>
         </p:txBody>
       </p:sp>
@@ -1224,38 +1667,37 @@
           <a:p>
             <a:pPr lvl="0"/>
             <a:r>
-              <a:rPr lang="en-US" smtClean="0"/>
+              <a:rPr lang="en-US"/>
               <a:t>Click to edit Master text styles</a:t>
             </a:r>
           </a:p>
           <a:p>
             <a:pPr lvl="1"/>
             <a:r>
-              <a:rPr lang="en-US" smtClean="0"/>
+              <a:rPr lang="en-US"/>
               <a:t>Second level</a:t>
             </a:r>
           </a:p>
           <a:p>
             <a:pPr lvl="2"/>
             <a:r>
-              <a:rPr lang="en-US" smtClean="0"/>
+              <a:rPr lang="en-US"/>
               <a:t>Third level</a:t>
             </a:r>
           </a:p>
           <a:p>
             <a:pPr lvl="3"/>
             <a:r>
-              <a:rPr lang="en-US" smtClean="0"/>
+              <a:rPr lang="en-US"/>
               <a:t>Fourth level</a:t>
             </a:r>
           </a:p>
           <a:p>
             <a:pPr lvl="4"/>
             <a:r>
-              <a:rPr lang="en-US" smtClean="0"/>
+              <a:rPr lang="en-US"/>
               <a:t>Fifth level</a:t>
             </a:r>
-            <a:endParaRPr lang="en-US"/>
           </a:p>
         </p:txBody>
       </p:sp>
@@ -1309,38 +1751,37 @@
           <a:p>
             <a:pPr lvl="0"/>
             <a:r>
-              <a:rPr lang="en-US" smtClean="0"/>
+              <a:rPr lang="en-US"/>
               <a:t>Click to edit Master text styles</a:t>
             </a:r>
           </a:p>
           <a:p>
             <a:pPr lvl="1"/>
             <a:r>
-              <a:rPr lang="en-US" smtClean="0"/>
+              <a:rPr lang="en-US"/>
               <a:t>Second level</a:t>
             </a:r>
           </a:p>
           <a:p>
             <a:pPr lvl="2"/>
             <a:r>
-              <a:rPr lang="en-US" smtClean="0"/>
+              <a:rPr lang="en-US"/>
               <a:t>Third level</a:t>
             </a:r>
           </a:p>
           <a:p>
             <a:pPr lvl="3"/>
             <a:r>
-              <a:rPr lang="en-US" smtClean="0"/>
+              <a:rPr lang="en-US"/>
               <a:t>Fourth level</a:t>
             </a:r>
           </a:p>
           <a:p>
             <a:pPr lvl="4"/>
             <a:r>
-              <a:rPr lang="en-US" smtClean="0"/>
+              <a:rPr lang="en-US"/>
               <a:t>Fifth level</a:t>
             </a:r>
-            <a:endParaRPr lang="en-US"/>
           </a:p>
         </p:txBody>
       </p:sp>
@@ -1361,7 +1802,7 @@
           <a:p>
             <a:fld id="{5BCAD085-E8A6-8845-BD4E-CB4CCA059FC4}" type="datetimeFigureOut">
               <a:rPr lang="en-US" smtClean="0"/>
-              <a:t>1/27/13</a:t>
+              <a:t>8/17/2026</a:t>
             </a:fld>
             <a:endParaRPr lang="en-US"/>
           </a:p>
@@ -1459,10 +1900,9 @@
           </a:lstStyle>
           <a:p>
             <a:r>
-              <a:rPr lang="en-US" smtClean="0"/>
+              <a:rPr lang="en-US"/>
               <a:t>Click to edit Master title style</a:t>
             </a:r>
-            <a:endParaRPr lang="en-US"/>
           </a:p>
         </p:txBody>
       </p:sp>
@@ -1525,7 +1965,7 @@
           <a:p>
             <a:pPr lvl="0"/>
             <a:r>
-              <a:rPr lang="en-US" smtClean="0"/>
+              <a:rPr lang="en-US"/>
               <a:t>Click to edit Master text styles</a:t>
             </a:r>
           </a:p>
@@ -1581,38 +2021,37 @@
           <a:p>
             <a:pPr lvl="0"/>
             <a:r>
-              <a:rPr lang="en-US" smtClean="0"/>
+              <a:rPr lang="en-US"/>
               <a:t>Click to edit Master text styles</a:t>
             </a:r>
           </a:p>
           <a:p>
             <a:pPr lvl="1"/>
             <a:r>
-              <a:rPr lang="en-US" smtClean="0"/>
+              <a:rPr lang="en-US"/>
               <a:t>Second level</a:t>
             </a:r>
           </a:p>
           <a:p>
             <a:pPr lvl="2"/>
             <a:r>
-              <a:rPr lang="en-US" smtClean="0"/>
+              <a:rPr lang="en-US"/>
               <a:t>Third level</a:t>
             </a:r>
           </a:p>
           <a:p>
             <a:pPr lvl="3"/>
             <a:r>
-              <a:rPr lang="en-US" smtClean="0"/>
+              <a:rPr lang="en-US"/>
               <a:t>Fourth level</a:t>
             </a:r>
           </a:p>
           <a:p>
             <a:pPr lvl="4"/>
             <a:r>
-              <a:rPr lang="en-US" smtClean="0"/>
+              <a:rPr lang="en-US"/>
               <a:t>Fifth level</a:t>
             </a:r>
-            <a:endParaRPr lang="en-US"/>
           </a:p>
         </p:txBody>
       </p:sp>
@@ -1675,7 +2114,7 @@
           <a:p>
             <a:pPr lvl="0"/>
             <a:r>
-              <a:rPr lang="en-US" smtClean="0"/>
+              <a:rPr lang="en-US"/>
               <a:t>Click to edit Master text styles</a:t>
             </a:r>
           </a:p>
@@ -1731,38 +2170,37 @@
           <a:p>
             <a:pPr lvl="0"/>
             <a:r>
-              <a:rPr lang="en-US" smtClean="0"/>
+              <a:rPr lang="en-US"/>
               <a:t>Click to edit Master text styles</a:t>
             </a:r>
           </a:p>
           <a:p>
             <a:pPr lvl="1"/>
             <a:r>
-              <a:rPr lang="en-US" smtClean="0"/>
+              <a:rPr lang="en-US"/>
               <a:t>Second level</a:t>
             </a:r>
           </a:p>
           <a:p>
             <a:pPr lvl="2"/>
             <a:r>
-              <a:rPr lang="en-US" smtClean="0"/>
+              <a:rPr lang="en-US"/>
               <a:t>Third level</a:t>
             </a:r>
           </a:p>
           <a:p>
             <a:pPr lvl="3"/>
             <a:r>
-              <a:rPr lang="en-US" smtClean="0"/>
+              <a:rPr lang="en-US"/>
               <a:t>Fourth level</a:t>
             </a:r>
           </a:p>
           <a:p>
             <a:pPr lvl="4"/>
             <a:r>
-              <a:rPr lang="en-US" smtClean="0"/>
+              <a:rPr lang="en-US"/>
               <a:t>Fifth level</a:t>
             </a:r>
-            <a:endParaRPr lang="en-US"/>
           </a:p>
         </p:txBody>
       </p:sp>
@@ -1783,7 +2221,7 @@
           <a:p>
             <a:fld id="{5BCAD085-E8A6-8845-BD4E-CB4CCA059FC4}" type="datetimeFigureOut">
               <a:rPr lang="en-US" smtClean="0"/>
-              <a:t>1/27/13</a:t>
+              <a:t>8/17/2026</a:t>
             </a:fld>
             <a:endParaRPr lang="en-US"/>
           </a:p>
@@ -1877,10 +2315,9 @@
           <a:lstStyle/>
           <a:p>
             <a:r>
-              <a:rPr lang="en-US" smtClean="0"/>
+              <a:rPr lang="en-US"/>
               <a:t>Click to edit Master title style</a:t>
             </a:r>
-            <a:endParaRPr lang="en-US"/>
           </a:p>
         </p:txBody>
       </p:sp>
@@ -1901,7 +2338,7 @@
           <a:p>
             <a:fld id="{5BCAD085-E8A6-8845-BD4E-CB4CCA059FC4}" type="datetimeFigureOut">
               <a:rPr lang="en-US" smtClean="0"/>
-              <a:t>1/27/13</a:t>
+              <a:t>8/17/2026</a:t>
             </a:fld>
             <a:endParaRPr lang="en-US"/>
           </a:p>
@@ -1996,7 +2433,7 @@
           <a:p>
             <a:fld id="{5BCAD085-E8A6-8845-BD4E-CB4CCA059FC4}" type="datetimeFigureOut">
               <a:rPr lang="en-US" smtClean="0"/>
-              <a:t>1/27/13</a:t>
+              <a:t>8/17/2026</a:t>
             </a:fld>
             <a:endParaRPr lang="en-US"/>
           </a:p>
@@ -2099,10 +2536,9 @@
           </a:lstStyle>
           <a:p>
             <a:r>
-              <a:rPr lang="en-US" smtClean="0"/>
+              <a:rPr lang="en-US"/>
               <a:t>Click to edit Master title style</a:t>
             </a:r>
-            <a:endParaRPr lang="en-US"/>
           </a:p>
         </p:txBody>
       </p:sp>
@@ -2156,38 +2592,37 @@
           <a:p>
             <a:pPr lvl="0"/>
             <a:r>
-              <a:rPr lang="en-US" smtClean="0"/>
+              <a:rPr lang="en-US"/>
               <a:t>Click to edit Master text styles</a:t>
             </a:r>
           </a:p>
           <a:p>
             <a:pPr lvl="1"/>
             <a:r>
-              <a:rPr lang="en-US" smtClean="0"/>
+              <a:rPr lang="en-US"/>
               <a:t>Second level</a:t>
             </a:r>
           </a:p>
           <a:p>
             <a:pPr lvl="2"/>
             <a:r>
-              <a:rPr lang="en-US" smtClean="0"/>
+              <a:rPr lang="en-US"/>
               <a:t>Third level</a:t>
             </a:r>
           </a:p>
           <a:p>
             <a:pPr lvl="3"/>
             <a:r>
-              <a:rPr lang="en-US" smtClean="0"/>
+              <a:rPr lang="en-US"/>
               <a:t>Fourth level</a:t>
             </a:r>
           </a:p>
           <a:p>
             <a:pPr lvl="4"/>
             <a:r>
-              <a:rPr lang="en-US" smtClean="0"/>
+              <a:rPr lang="en-US"/>
               <a:t>Fifth level</a:t>
             </a:r>
-            <a:endParaRPr lang="en-US"/>
           </a:p>
         </p:txBody>
       </p:sp>
@@ -2250,7 +2685,7 @@
           <a:p>
             <a:pPr lvl="0"/>
             <a:r>
-              <a:rPr lang="en-US" smtClean="0"/>
+              <a:rPr lang="en-US"/>
               <a:t>Click to edit Master text styles</a:t>
             </a:r>
           </a:p>
@@ -2273,7 +2708,7 @@
           <a:p>
             <a:fld id="{5BCAD085-E8A6-8845-BD4E-CB4CCA059FC4}" type="datetimeFigureOut">
               <a:rPr lang="en-US" smtClean="0"/>
-              <a:t>1/27/13</a:t>
+              <a:t>8/17/2026</a:t>
             </a:fld>
             <a:endParaRPr lang="en-US"/>
           </a:p>
@@ -2376,10 +2811,9 @@
           </a:lstStyle>
           <a:p>
             <a:r>
-              <a:rPr lang="en-US" smtClean="0"/>
+              <a:rPr lang="en-US"/>
               <a:t>Click to edit Master title style</a:t>
             </a:r>
-            <a:endParaRPr lang="en-US"/>
           </a:p>
         </p:txBody>
       </p:sp>
@@ -2503,7 +2937,7 @@
           <a:p>
             <a:pPr lvl="0"/>
             <a:r>
-              <a:rPr lang="en-US" smtClean="0"/>
+              <a:rPr lang="en-US"/>
               <a:t>Click to edit Master text styles</a:t>
             </a:r>
           </a:p>
@@ -2526,7 +2960,7 @@
           <a:p>
             <a:fld id="{5BCAD085-E8A6-8845-BD4E-CB4CCA059FC4}" type="datetimeFigureOut">
               <a:rPr lang="en-US" smtClean="0"/>
-              <a:t>1/27/13</a:t>
+              <a:t>8/17/2026</a:t>
             </a:fld>
             <a:endParaRPr lang="en-US"/>
           </a:p>
@@ -2635,10 +3069,9 @@
           <a:lstStyle/>
           <a:p>
             <a:r>
-              <a:rPr lang="en-US" smtClean="0"/>
+              <a:rPr lang="en-US"/>
               <a:t>Click to edit Master title style</a:t>
             </a:r>
-            <a:endParaRPr lang="en-US"/>
           </a:p>
         </p:txBody>
       </p:sp>
@@ -2669,38 +3102,37 @@
           <a:p>
             <a:pPr lvl="0"/>
             <a:r>
-              <a:rPr lang="en-US" smtClean="0"/>
+              <a:rPr lang="en-US"/>
               <a:t>Click to edit Master text styles</a:t>
             </a:r>
           </a:p>
           <a:p>
             <a:pPr lvl="1"/>
             <a:r>
-              <a:rPr lang="en-US" smtClean="0"/>
+              <a:rPr lang="en-US"/>
               <a:t>Second level</a:t>
             </a:r>
           </a:p>
           <a:p>
             <a:pPr lvl="2"/>
             <a:r>
-              <a:rPr lang="en-US" smtClean="0"/>
+              <a:rPr lang="en-US"/>
               <a:t>Third level</a:t>
             </a:r>
           </a:p>
           <a:p>
             <a:pPr lvl="3"/>
             <a:r>
-              <a:rPr lang="en-US" smtClean="0"/>
+              <a:rPr lang="en-US"/>
               <a:t>Fourth level</a:t>
             </a:r>
           </a:p>
           <a:p>
             <a:pPr lvl="4"/>
             <a:r>
-              <a:rPr lang="en-US" smtClean="0"/>
+              <a:rPr lang="en-US"/>
               <a:t>Fifth level</a:t>
             </a:r>
-            <a:endParaRPr lang="en-US"/>
           </a:p>
         </p:txBody>
       </p:sp>
@@ -2739,7 +3171,7 @@
           <a:p>
             <a:fld id="{5BCAD085-E8A6-8845-BD4E-CB4CCA059FC4}" type="datetimeFigureOut">
               <a:rPr lang="en-US" smtClean="0"/>
-              <a:t>1/27/13</a:t>
+              <a:t>8/17/2026</a:t>
             </a:fld>
             <a:endParaRPr lang="en-US"/>
           </a:p>
@@ -3098,7 +3530,7 @@
 </file>
 
 <file path=ppt/slides/slide1.xml><?xml version="1.0" encoding="utf-8"?>
-<p:sld xmlns:a="http://schemas.openxmlformats.org/drawingml/2006/main" xmlns:p="http://schemas.openxmlformats.org/presentationml/2006/main" xmlns:r="http://schemas.openxmlformats.org/officeDocument/2006/relationships">
+<p:sld xmlns:a="http://schemas.openxmlformats.org/drawingml/2006/main" xmlns:r="http://schemas.openxmlformats.org/officeDocument/2006/relationships" xmlns:p="http://schemas.openxmlformats.org/presentationml/2006/main">
   <p:cSld>
     <p:spTree>
       <p:nvGrpSpPr>
@@ -3106,7 +3538,14 @@
         <p:cNvGrpSpPr/>
         <p:nvPr/>
       </p:nvGrpSpPr>
-      <p:grpSpPr/>
+      <p:grpSpPr>
+        <a:xfrm>
+          <a:off x="0" y="0"/>
+          <a:ext cx="0" cy="0"/>
+          <a:chOff x="0" y="0"/>
+          <a:chExt cx="0" cy="0"/>
+        </a:xfrm>
+      </p:grpSpPr>
       <p:sp>
         <p:nvSpPr>
           <p:cNvPr id="2" name="Rectangle 1"/>
@@ -3147,6 +3586,7 @@
           <a:lstStyle/>
           <a:p>
             <a:pPr algn="ctr"/>
+            <a:endParaRPr/>
           </a:p>
         </p:txBody>
       </p:sp>
@@ -3190,6 +3630,7 @@
           <a:lstStyle/>
           <a:p>
             <a:pPr algn="ctr"/>
+            <a:endParaRPr/>
           </a:p>
         </p:txBody>
       </p:sp>
@@ -3302,6 +3743,7 @@
           <a:lstStyle/>
           <a:p>
             <a:pPr algn="ctr"/>
+            <a:endParaRPr/>
           </a:p>
         </p:txBody>
       </p:sp>
@@ -3414,6 +3856,7 @@
           <a:lstStyle/>
           <a:p>
             <a:pPr algn="ctr"/>
+            <a:endParaRPr/>
           </a:p>
         </p:txBody>
       </p:sp>
@@ -3526,6 +3969,7 @@
           <a:lstStyle/>
           <a:p>
             <a:pPr algn="ctr"/>
+            <a:endParaRPr/>
           </a:p>
         </p:txBody>
       </p:sp>
@@ -3638,6 +4082,7 @@
           <a:lstStyle/>
           <a:p>
             <a:pPr algn="ctr"/>
+            <a:endParaRPr/>
           </a:p>
         </p:txBody>
       </p:sp>
@@ -3740,40 +4185,6 @@
                 </a:solidFill>
               </a:rPr>
               <a:t>Shared SQLite State  ·  Deterministic Evaluator  ·  Fully Reproducible from Seed</a:t>
-            </a:r>
-          </a:p>
-        </p:txBody>
-      </p:sp>
-      <p:sp>
-        <p:nvSpPr>
-          <p:cNvPr id="19" name="TextBox 18"/>
-          <p:cNvSpPr txBox="1"/>
-          <p:nvPr/>
-        </p:nvSpPr>
-        <p:spPr>
-          <a:xfrm>
-            <a:off x="274320" y="6291072"/>
-            <a:ext cx="3657600" cy="274320"/>
-          </a:xfrm>
-          <a:prstGeom prst="rect">
-            <a:avLst/>
-          </a:prstGeom>
-          <a:noFill/>
-        </p:spPr>
-        <p:txBody>
-          <a:bodyPr wrap="square">
-            <a:spAutoFit/>
-          </a:bodyPr>
-          <a:lstStyle/>
-          <a:p>
-            <a:pPr algn="l"/>
-            <a:r>
-              <a:rPr sz="1100" b="0" i="0">
-                <a:solidFill>
-                  <a:srgbClr val="FFFFFF"/>
-                </a:solidFill>
-              </a:rPr>
-              <a:t>v1.3  |  2025</a:t>
             </a:r>
           </a:p>
         </p:txBody>
@@ -3787,7 +4198,7 @@
 </file>
 
 <file path=ppt/slides/slide10.xml><?xml version="1.0" encoding="utf-8"?>
-<p:sld xmlns:a="http://schemas.openxmlformats.org/drawingml/2006/main" xmlns:p="http://schemas.openxmlformats.org/presentationml/2006/main" xmlns:r="http://schemas.openxmlformats.org/officeDocument/2006/relationships">
+<p:sld xmlns:a="http://schemas.openxmlformats.org/drawingml/2006/main" xmlns:r="http://schemas.openxmlformats.org/officeDocument/2006/relationships" xmlns:p="http://schemas.openxmlformats.org/presentationml/2006/main">
   <p:cSld>
     <p:spTree>
       <p:nvGrpSpPr>
@@ -3795,7 +4206,14 @@
         <p:cNvGrpSpPr/>
         <p:nvPr/>
       </p:nvGrpSpPr>
-      <p:grpSpPr/>
+      <p:grpSpPr>
+        <a:xfrm>
+          <a:off x="0" y="0"/>
+          <a:ext cx="0" cy="0"/>
+          <a:chOff x="0" y="0"/>
+          <a:chExt cx="0" cy="0"/>
+        </a:xfrm>
+      </p:grpSpPr>
       <p:sp>
         <p:nvSpPr>
           <p:cNvPr id="2" name="Rectangle 1"/>
@@ -3836,6 +4254,7 @@
           <a:lstStyle/>
           <a:p>
             <a:pPr algn="ctr"/>
+            <a:endParaRPr/>
           </a:p>
         </p:txBody>
       </p:sp>
@@ -3879,6 +4298,7 @@
           <a:lstStyle/>
           <a:p>
             <a:pPr algn="ctr"/>
+            <a:endParaRPr/>
           </a:p>
         </p:txBody>
       </p:sp>
@@ -4024,6 +4444,7 @@
           <a:lstStyle/>
           <a:p>
             <a:pPr algn="ctr"/>
+            <a:endParaRPr/>
           </a:p>
         </p:txBody>
       </p:sp>
@@ -4135,6 +4556,7 @@
           <a:lstStyle/>
           <a:p>
             <a:pPr algn="ctr"/>
+            <a:endParaRPr/>
           </a:p>
         </p:txBody>
       </p:sp>
@@ -4246,6 +4668,7 @@
           <a:lstStyle/>
           <a:p>
             <a:pPr algn="ctr"/>
+            <a:endParaRPr/>
           </a:p>
         </p:txBody>
       </p:sp>
@@ -4357,6 +4780,7 @@
           <a:lstStyle/>
           <a:p>
             <a:pPr algn="ctr"/>
+            <a:endParaRPr/>
           </a:p>
         </p:txBody>
       </p:sp>
@@ -4400,6 +4824,7 @@
           <a:lstStyle/>
           <a:p>
             <a:pPr algn="ctr"/>
+            <a:endParaRPr/>
           </a:p>
         </p:txBody>
       </p:sp>
@@ -4547,6 +4972,7 @@
           <a:lstStyle/>
           <a:p>
             <a:pPr algn="ctr"/>
+            <a:endParaRPr/>
           </a:p>
         </p:txBody>
       </p:sp>
@@ -4694,6 +5120,7 @@
           <a:lstStyle/>
           <a:p>
             <a:pPr algn="ctr"/>
+            <a:endParaRPr/>
           </a:p>
         </p:txBody>
       </p:sp>
@@ -4841,6 +5268,7 @@
           <a:lstStyle/>
           <a:p>
             <a:pPr algn="ctr"/>
+            <a:endParaRPr/>
           </a:p>
         </p:txBody>
       </p:sp>
@@ -4955,7 +5383,7 @@
 </file>
 
 <file path=ppt/slides/slide11.xml><?xml version="1.0" encoding="utf-8"?>
-<p:sld xmlns:a="http://schemas.openxmlformats.org/drawingml/2006/main" xmlns:p="http://schemas.openxmlformats.org/presentationml/2006/main" xmlns:r="http://schemas.openxmlformats.org/officeDocument/2006/relationships">
+<p:sld xmlns:a="http://schemas.openxmlformats.org/drawingml/2006/main" xmlns:r="http://schemas.openxmlformats.org/officeDocument/2006/relationships" xmlns:p="http://schemas.openxmlformats.org/presentationml/2006/main">
   <p:cSld>
     <p:spTree>
       <p:nvGrpSpPr>
@@ -4963,7 +5391,14 @@
         <p:cNvGrpSpPr/>
         <p:nvPr/>
       </p:nvGrpSpPr>
-      <p:grpSpPr/>
+      <p:grpSpPr>
+        <a:xfrm>
+          <a:off x="0" y="0"/>
+          <a:ext cx="0" cy="0"/>
+          <a:chOff x="0" y="0"/>
+          <a:chExt cx="0" cy="0"/>
+        </a:xfrm>
+      </p:grpSpPr>
       <p:sp>
         <p:nvSpPr>
           <p:cNvPr id="2" name="Rectangle 1"/>
@@ -5004,6 +5439,7 @@
           <a:lstStyle/>
           <a:p>
             <a:pPr algn="ctr"/>
+            <a:endParaRPr/>
           </a:p>
         </p:txBody>
       </p:sp>
@@ -5047,6 +5483,7 @@
           <a:lstStyle/>
           <a:p>
             <a:pPr algn="ctr"/>
+            <a:endParaRPr/>
           </a:p>
         </p:txBody>
       </p:sp>
@@ -5194,6 +5631,7 @@
           <a:lstStyle/>
           <a:p>
             <a:pPr algn="ctr"/>
+            <a:endParaRPr/>
           </a:p>
         </p:txBody>
       </p:sp>
@@ -5545,6 +5983,7 @@
           <a:lstStyle/>
           <a:p>
             <a:pPr algn="ctr"/>
+            <a:endParaRPr/>
           </a:p>
         </p:txBody>
       </p:sp>
@@ -5761,7 +6200,7 @@
 </file>
 
 <file path=ppt/slides/slide12.xml><?xml version="1.0" encoding="utf-8"?>
-<p:sld xmlns:a="http://schemas.openxmlformats.org/drawingml/2006/main" xmlns:p="http://schemas.openxmlformats.org/presentationml/2006/main" xmlns:r="http://schemas.openxmlformats.org/officeDocument/2006/relationships">
+<p:sld xmlns:a="http://schemas.openxmlformats.org/drawingml/2006/main" xmlns:r="http://schemas.openxmlformats.org/officeDocument/2006/relationships" xmlns:p="http://schemas.openxmlformats.org/presentationml/2006/main">
   <p:cSld>
     <p:spTree>
       <p:nvGrpSpPr>
@@ -5769,7 +6208,14 @@
         <p:cNvGrpSpPr/>
         <p:nvPr/>
       </p:nvGrpSpPr>
-      <p:grpSpPr/>
+      <p:grpSpPr>
+        <a:xfrm>
+          <a:off x="0" y="0"/>
+          <a:ext cx="0" cy="0"/>
+          <a:chOff x="0" y="0"/>
+          <a:chExt cx="0" cy="0"/>
+        </a:xfrm>
+      </p:grpSpPr>
       <p:sp>
         <p:nvSpPr>
           <p:cNvPr id="2" name="Rectangle 1"/>
@@ -5810,6 +6256,7 @@
           <a:lstStyle/>
           <a:p>
             <a:pPr algn="ctr"/>
+            <a:endParaRPr/>
           </a:p>
         </p:txBody>
       </p:sp>
@@ -5853,6 +6300,7 @@
           <a:lstStyle/>
           <a:p>
             <a:pPr algn="ctr"/>
+            <a:endParaRPr/>
           </a:p>
         </p:txBody>
       </p:sp>
@@ -6000,6 +6448,7 @@
           <a:lstStyle/>
           <a:p>
             <a:pPr algn="ctr"/>
+            <a:endParaRPr/>
           </a:p>
         </p:txBody>
       </p:sp>
@@ -6283,6 +6732,7 @@
           <a:lstStyle/>
           <a:p>
             <a:pPr algn="ctr"/>
+            <a:endParaRPr/>
           </a:p>
         </p:txBody>
       </p:sp>
@@ -6398,6 +6848,7 @@
           <a:lstStyle/>
           <a:p>
             <a:pPr algn="ctr"/>
+            <a:endParaRPr/>
           </a:p>
         </p:txBody>
       </p:sp>
@@ -6511,6 +6962,7 @@
           <a:lstStyle/>
           <a:p>
             <a:pPr algn="ctr"/>
+            <a:endParaRPr/>
           </a:p>
         </p:txBody>
       </p:sp>
@@ -6593,7 +7045,7 @@
 </file>
 
 <file path=ppt/slides/slide13.xml><?xml version="1.0" encoding="utf-8"?>
-<p:sld xmlns:a="http://schemas.openxmlformats.org/drawingml/2006/main" xmlns:p="http://schemas.openxmlformats.org/presentationml/2006/main" xmlns:r="http://schemas.openxmlformats.org/officeDocument/2006/relationships">
+<p:sld xmlns:a="http://schemas.openxmlformats.org/drawingml/2006/main" xmlns:r="http://schemas.openxmlformats.org/officeDocument/2006/relationships" xmlns:p="http://schemas.openxmlformats.org/presentationml/2006/main">
   <p:cSld>
     <p:spTree>
       <p:nvGrpSpPr>
@@ -6601,7 +7053,14 @@
         <p:cNvGrpSpPr/>
         <p:nvPr/>
       </p:nvGrpSpPr>
-      <p:grpSpPr/>
+      <p:grpSpPr>
+        <a:xfrm>
+          <a:off x="0" y="0"/>
+          <a:ext cx="0" cy="0"/>
+          <a:chOff x="0" y="0"/>
+          <a:chExt cx="0" cy="0"/>
+        </a:xfrm>
+      </p:grpSpPr>
       <p:sp>
         <p:nvSpPr>
           <p:cNvPr id="2" name="Rectangle 1"/>
@@ -6642,6 +7101,7 @@
           <a:lstStyle/>
           <a:p>
             <a:pPr algn="ctr"/>
+            <a:endParaRPr/>
           </a:p>
         </p:txBody>
       </p:sp>
@@ -6685,6 +7145,7 @@
           <a:lstStyle/>
           <a:p>
             <a:pPr algn="ctr"/>
+            <a:endParaRPr/>
           </a:p>
         </p:txBody>
       </p:sp>
@@ -6830,6 +7291,7 @@
           <a:lstStyle/>
           <a:p>
             <a:pPr algn="ctr"/>
+            <a:endParaRPr/>
           </a:p>
         </p:txBody>
       </p:sp>
@@ -6977,6 +7439,7 @@
           <a:lstStyle/>
           <a:p>
             <a:pPr algn="ctr"/>
+            <a:endParaRPr/>
           </a:p>
         </p:txBody>
       </p:sp>
@@ -7124,6 +7587,7 @@
           <a:lstStyle/>
           <a:p>
             <a:pPr algn="ctr"/>
+            <a:endParaRPr/>
           </a:p>
         </p:txBody>
       </p:sp>
@@ -7271,6 +7735,7 @@
           <a:lstStyle/>
           <a:p>
             <a:pPr algn="ctr"/>
+            <a:endParaRPr/>
           </a:p>
         </p:txBody>
       </p:sp>
@@ -7418,6 +7883,7 @@
           <a:lstStyle/>
           <a:p>
             <a:pPr algn="ctr"/>
+            <a:endParaRPr/>
           </a:p>
         </p:txBody>
       </p:sp>
@@ -7565,6 +8031,7 @@
           <a:lstStyle/>
           <a:p>
             <a:pPr algn="ctr"/>
+            <a:endParaRPr/>
           </a:p>
         </p:txBody>
       </p:sp>
@@ -7712,6 +8179,7 @@
           <a:lstStyle/>
           <a:p>
             <a:pPr algn="ctr"/>
+            <a:endParaRPr/>
           </a:p>
         </p:txBody>
       </p:sp>
@@ -7859,6 +8327,7 @@
           <a:lstStyle/>
           <a:p>
             <a:pPr algn="ctr"/>
+            <a:endParaRPr/>
           </a:p>
         </p:txBody>
       </p:sp>
@@ -8004,6 +8473,7 @@
           <a:lstStyle/>
           <a:p>
             <a:pPr algn="ctr"/>
+            <a:endParaRPr/>
           </a:p>
         </p:txBody>
       </p:sp>
@@ -8050,7 +8520,7 @@
 </file>
 
 <file path=ppt/slides/slide14.xml><?xml version="1.0" encoding="utf-8"?>
-<p:sld xmlns:a="http://schemas.openxmlformats.org/drawingml/2006/main" xmlns:p="http://schemas.openxmlformats.org/presentationml/2006/main" xmlns:r="http://schemas.openxmlformats.org/officeDocument/2006/relationships">
+<p:sld xmlns:a="http://schemas.openxmlformats.org/drawingml/2006/main" xmlns:r="http://schemas.openxmlformats.org/officeDocument/2006/relationships" xmlns:p="http://schemas.openxmlformats.org/presentationml/2006/main">
   <p:cSld>
     <p:spTree>
       <p:nvGrpSpPr>
@@ -8058,7 +8528,14 @@
         <p:cNvGrpSpPr/>
         <p:nvPr/>
       </p:nvGrpSpPr>
-      <p:grpSpPr/>
+      <p:grpSpPr>
+        <a:xfrm>
+          <a:off x="0" y="0"/>
+          <a:ext cx="0" cy="0"/>
+          <a:chOff x="0" y="0"/>
+          <a:chExt cx="0" cy="0"/>
+        </a:xfrm>
+      </p:grpSpPr>
       <p:sp>
         <p:nvSpPr>
           <p:cNvPr id="2" name="Rectangle 1"/>
@@ -8099,6 +8576,7 @@
           <a:lstStyle/>
           <a:p>
             <a:pPr algn="ctr"/>
+            <a:endParaRPr/>
           </a:p>
         </p:txBody>
       </p:sp>
@@ -8142,6 +8620,7 @@
           <a:lstStyle/>
           <a:p>
             <a:pPr algn="ctr"/>
+            <a:endParaRPr/>
           </a:p>
         </p:txBody>
       </p:sp>
@@ -8288,6 +8767,7 @@
           <a:lstStyle/>
           <a:p>
             <a:pPr algn="ctr"/>
+            <a:endParaRPr/>
           </a:p>
         </p:txBody>
       </p:sp>
@@ -8366,6 +8846,7 @@
           <a:lstStyle/>
           <a:p>
             <a:pPr algn="ctr"/>
+            <a:endParaRPr/>
           </a:p>
         </p:txBody>
       </p:sp>
@@ -8413,7 +8894,7 @@
 </file>
 
 <file path=ppt/slides/slide15.xml><?xml version="1.0" encoding="utf-8"?>
-<p:sld xmlns:a="http://schemas.openxmlformats.org/drawingml/2006/main" xmlns:p="http://schemas.openxmlformats.org/presentationml/2006/main" xmlns:r="http://schemas.openxmlformats.org/officeDocument/2006/relationships">
+<p:sld xmlns:a="http://schemas.openxmlformats.org/drawingml/2006/main" xmlns:r="http://schemas.openxmlformats.org/officeDocument/2006/relationships" xmlns:p="http://schemas.openxmlformats.org/presentationml/2006/main">
   <p:cSld>
     <p:spTree>
       <p:nvGrpSpPr>
@@ -8421,7 +8902,14 @@
         <p:cNvGrpSpPr/>
         <p:nvPr/>
       </p:nvGrpSpPr>
-      <p:grpSpPr/>
+      <p:grpSpPr>
+        <a:xfrm>
+          <a:off x="0" y="0"/>
+          <a:ext cx="0" cy="0"/>
+          <a:chOff x="0" y="0"/>
+          <a:chExt cx="0" cy="0"/>
+        </a:xfrm>
+      </p:grpSpPr>
       <p:sp>
         <p:nvSpPr>
           <p:cNvPr id="2" name="Rectangle 1"/>
@@ -8462,6 +8950,7 @@
           <a:lstStyle/>
           <a:p>
             <a:pPr algn="ctr"/>
+            <a:endParaRPr/>
           </a:p>
         </p:txBody>
       </p:sp>
@@ -8505,6 +8994,7 @@
           <a:lstStyle/>
           <a:p>
             <a:pPr algn="ctr"/>
+            <a:endParaRPr/>
           </a:p>
         </p:txBody>
       </p:sp>
@@ -8650,6 +9140,7 @@
           <a:lstStyle/>
           <a:p>
             <a:pPr algn="ctr"/>
+            <a:endParaRPr/>
           </a:p>
         </p:txBody>
       </p:sp>
@@ -8797,6 +9288,7 @@
           <a:lstStyle/>
           <a:p>
             <a:pPr algn="ctr"/>
+            <a:endParaRPr/>
           </a:p>
         </p:txBody>
       </p:sp>
@@ -8944,6 +9436,7 @@
           <a:lstStyle/>
           <a:p>
             <a:pPr algn="ctr"/>
+            <a:endParaRPr/>
           </a:p>
         </p:txBody>
       </p:sp>
@@ -9091,6 +9584,7 @@
           <a:lstStyle/>
           <a:p>
             <a:pPr algn="ctr"/>
+            <a:endParaRPr/>
           </a:p>
         </p:txBody>
       </p:sp>
@@ -9238,6 +9732,7 @@
           <a:lstStyle/>
           <a:p>
             <a:pPr algn="ctr"/>
+            <a:endParaRPr/>
           </a:p>
         </p:txBody>
       </p:sp>
@@ -9385,6 +9880,7 @@
           <a:lstStyle/>
           <a:p>
             <a:pPr algn="ctr"/>
+            <a:endParaRPr/>
           </a:p>
         </p:txBody>
       </p:sp>
@@ -9499,7 +9995,7 @@
 </file>
 
 <file path=ppt/slides/slide16.xml><?xml version="1.0" encoding="utf-8"?>
-<p:sld xmlns:a="http://schemas.openxmlformats.org/drawingml/2006/main" xmlns:p="http://schemas.openxmlformats.org/presentationml/2006/main" xmlns:r="http://schemas.openxmlformats.org/officeDocument/2006/relationships">
+<p:sld xmlns:a="http://schemas.openxmlformats.org/drawingml/2006/main" xmlns:r="http://schemas.openxmlformats.org/officeDocument/2006/relationships" xmlns:p="http://schemas.openxmlformats.org/presentationml/2006/main">
   <p:cSld>
     <p:spTree>
       <p:nvGrpSpPr>
@@ -9507,7 +10003,14 @@
         <p:cNvGrpSpPr/>
         <p:nvPr/>
       </p:nvGrpSpPr>
-      <p:grpSpPr/>
+      <p:grpSpPr>
+        <a:xfrm>
+          <a:off x="0" y="0"/>
+          <a:ext cx="0" cy="0"/>
+          <a:chOff x="0" y="0"/>
+          <a:chExt cx="0" cy="0"/>
+        </a:xfrm>
+      </p:grpSpPr>
       <p:sp>
         <p:nvSpPr>
           <p:cNvPr id="2" name="Rectangle 1"/>
@@ -9548,6 +10051,7 @@
           <a:lstStyle/>
           <a:p>
             <a:pPr algn="ctr"/>
+            <a:endParaRPr/>
           </a:p>
         </p:txBody>
       </p:sp>
@@ -9591,6 +10095,7 @@
           <a:lstStyle/>
           <a:p>
             <a:pPr algn="ctr"/>
+            <a:endParaRPr/>
           </a:p>
         </p:txBody>
       </p:sp>
@@ -9738,6 +10243,7 @@
           <a:lstStyle/>
           <a:p>
             <a:pPr algn="ctr"/>
+            <a:endParaRPr/>
           </a:p>
         </p:txBody>
       </p:sp>
@@ -9781,6 +10287,7 @@
           <a:lstStyle/>
           <a:p>
             <a:pPr algn="ctr"/>
+            <a:endParaRPr/>
           </a:p>
         </p:txBody>
       </p:sp>
@@ -9793,22 +10300,22 @@
         <p:spPr>
           <a:xfrm>
             <a:off x="457200" y="1828800"/>
-            <a:ext cx="320040" cy="320040"/>
-          </a:xfrm>
-          <a:prstGeom prst="rect">
-            <a:avLst/>
-          </a:prstGeom>
-          <a:noFill/>
-        </p:spPr>
-        <p:txBody>
-          <a:bodyPr wrap="square">
-            <a:spAutoFit/>
-          </a:bodyPr>
-          <a:lstStyle/>
-          <a:p>
-            <a:pPr algn="ctr"/>
-            <a:r>
-              <a:rPr sz="900" b="1" i="0">
+            <a:ext cx="320040" cy="369332"/>
+          </a:xfrm>
+          <a:prstGeom prst="rect">
+            <a:avLst/>
+          </a:prstGeom>
+          <a:noFill/>
+        </p:spPr>
+        <p:txBody>
+          <a:bodyPr wrap="square">
+            <a:spAutoFit/>
+          </a:bodyPr>
+          <a:lstStyle/>
+          <a:p>
+            <a:pPr algn="ctr"/>
+            <a:r>
+              <a:rPr sz="900" b="1" i="0" dirty="0">
                 <a:solidFill>
                   <a:srgbClr val="FFFFFF"/>
                 </a:solidFill>
@@ -9928,6 +10435,7 @@
           <a:lstStyle/>
           <a:p>
             <a:pPr algn="ctr"/>
+            <a:endParaRPr/>
           </a:p>
         </p:txBody>
       </p:sp>
@@ -9971,6 +10479,7 @@
           <a:lstStyle/>
           <a:p>
             <a:pPr algn="ctr"/>
+            <a:endParaRPr/>
           </a:p>
         </p:txBody>
       </p:sp>
@@ -10118,6 +10627,7 @@
           <a:lstStyle/>
           <a:p>
             <a:pPr algn="ctr"/>
+            <a:endParaRPr/>
           </a:p>
         </p:txBody>
       </p:sp>
@@ -10161,6 +10671,7 @@
           <a:lstStyle/>
           <a:p>
             <a:pPr algn="ctr"/>
+            <a:endParaRPr/>
           </a:p>
         </p:txBody>
       </p:sp>
@@ -10308,6 +10819,7 @@
           <a:lstStyle/>
           <a:p>
             <a:pPr algn="ctr"/>
+            <a:endParaRPr/>
           </a:p>
         </p:txBody>
       </p:sp>
@@ -10351,6 +10863,7 @@
           <a:lstStyle/>
           <a:p>
             <a:pPr algn="ctr"/>
+            <a:endParaRPr/>
           </a:p>
         </p:txBody>
       </p:sp>
@@ -10498,6 +11011,7 @@
           <a:lstStyle/>
           <a:p>
             <a:pPr algn="ctr"/>
+            <a:endParaRPr/>
           </a:p>
         </p:txBody>
       </p:sp>
@@ -10541,6 +11055,7 @@
           <a:lstStyle/>
           <a:p>
             <a:pPr algn="ctr"/>
+            <a:endParaRPr/>
           </a:p>
         </p:txBody>
       </p:sp>
@@ -10688,6 +11203,7 @@
           <a:lstStyle/>
           <a:p>
             <a:pPr algn="ctr"/>
+            <a:endParaRPr/>
           </a:p>
         </p:txBody>
       </p:sp>
@@ -10731,6 +11247,7 @@
           <a:lstStyle/>
           <a:p>
             <a:pPr algn="ctr"/>
+            <a:endParaRPr/>
           </a:p>
         </p:txBody>
       </p:sp>
@@ -10878,6 +11395,7 @@
           <a:lstStyle/>
           <a:p>
             <a:pPr algn="ctr"/>
+            <a:endParaRPr/>
           </a:p>
         </p:txBody>
       </p:sp>
@@ -10921,6 +11439,7 @@
           <a:lstStyle/>
           <a:p>
             <a:pPr algn="ctr"/>
+            <a:endParaRPr/>
           </a:p>
         </p:txBody>
       </p:sp>
@@ -10933,22 +11452,22 @@
         <p:spPr>
           <a:xfrm>
             <a:off x="457200" y="5230367"/>
-            <a:ext cx="320040" cy="320040"/>
-          </a:xfrm>
-          <a:prstGeom prst="rect">
-            <a:avLst/>
-          </a:prstGeom>
-          <a:noFill/>
-        </p:spPr>
-        <p:txBody>
-          <a:bodyPr wrap="square">
-            <a:spAutoFit/>
-          </a:bodyPr>
-          <a:lstStyle/>
-          <a:p>
-            <a:pPr algn="ctr"/>
-            <a:r>
-              <a:rPr sz="900" b="1" i="0">
+            <a:ext cx="320040" cy="369332"/>
+          </a:xfrm>
+          <a:prstGeom prst="rect">
+            <a:avLst/>
+          </a:prstGeom>
+          <a:noFill/>
+        </p:spPr>
+        <p:txBody>
+          <a:bodyPr wrap="square">
+            <a:spAutoFit/>
+          </a:bodyPr>
+          <a:lstStyle/>
+          <a:p>
+            <a:pPr algn="ctr"/>
+            <a:r>
+              <a:rPr sz="900" b="1" i="0" dirty="0">
                 <a:solidFill>
                   <a:srgbClr val="FFFFFF"/>
                 </a:solidFill>
@@ -11066,6 +11585,7 @@
           <a:lstStyle/>
           <a:p>
             <a:pPr algn="ctr"/>
+            <a:endParaRPr/>
           </a:p>
         </p:txBody>
       </p:sp>
@@ -11114,7 +11634,7 @@
 </file>
 
 <file path=ppt/slides/slide17.xml><?xml version="1.0" encoding="utf-8"?>
-<p:sld xmlns:a="http://schemas.openxmlformats.org/drawingml/2006/main" xmlns:p="http://schemas.openxmlformats.org/presentationml/2006/main" xmlns:r="http://schemas.openxmlformats.org/officeDocument/2006/relationships">
+<p:sld xmlns:a="http://schemas.openxmlformats.org/drawingml/2006/main" xmlns:r="http://schemas.openxmlformats.org/officeDocument/2006/relationships" xmlns:p="http://schemas.openxmlformats.org/presentationml/2006/main">
   <p:cSld>
     <p:spTree>
       <p:nvGrpSpPr>
@@ -11122,7 +11642,14 @@
         <p:cNvGrpSpPr/>
         <p:nvPr/>
       </p:nvGrpSpPr>
-      <p:grpSpPr/>
+      <p:grpSpPr>
+        <a:xfrm>
+          <a:off x="0" y="0"/>
+          <a:ext cx="0" cy="0"/>
+          <a:chOff x="0" y="0"/>
+          <a:chExt cx="0" cy="0"/>
+        </a:xfrm>
+      </p:grpSpPr>
       <p:sp>
         <p:nvSpPr>
           <p:cNvPr id="2" name="Rectangle 1"/>
@@ -11163,6 +11690,7 @@
           <a:lstStyle/>
           <a:p>
             <a:pPr algn="ctr"/>
+            <a:endParaRPr/>
           </a:p>
         </p:txBody>
       </p:sp>
@@ -11206,6 +11734,7 @@
           <a:lstStyle/>
           <a:p>
             <a:pPr algn="ctr"/>
+            <a:endParaRPr/>
           </a:p>
         </p:txBody>
       </p:sp>
@@ -11353,6 +11882,7 @@
           <a:lstStyle/>
           <a:p>
             <a:pPr algn="ctr"/>
+            <a:endParaRPr/>
           </a:p>
         </p:txBody>
       </p:sp>
@@ -11549,14 +12079,7 @@
           <a:lstStyle/>
           <a:p>
             <a:pPr algn="l"/>
-            <a:r>
-              <a:rPr sz="1200" b="0" i="0">
-                <a:solidFill>
-                  <a:srgbClr val="1A2B3C"/>
-                </a:solidFill>
-              </a:rPr>
-              <a:t/>
-            </a:r>
+            <a:endParaRPr/>
           </a:p>
         </p:txBody>
       </p:sp>
@@ -11636,6 +12159,7 @@
           <a:lstStyle/>
           <a:p>
             <a:pPr algn="ctr"/>
+            <a:endParaRPr/>
           </a:p>
         </p:txBody>
       </p:sp>
@@ -11832,14 +12356,7 @@
           <a:lstStyle/>
           <a:p>
             <a:pPr algn="l"/>
-            <a:r>
-              <a:rPr sz="1200" b="0" i="0">
-                <a:solidFill>
-                  <a:srgbClr val="1A2B3C"/>
-                </a:solidFill>
-              </a:rPr>
-              <a:t/>
-            </a:r>
+            <a:endParaRPr/>
           </a:p>
         </p:txBody>
       </p:sp>
@@ -11917,6 +12434,7 @@
           <a:lstStyle/>
           <a:p>
             <a:pPr algn="ctr"/>
+            <a:endParaRPr/>
           </a:p>
         </p:txBody>
       </p:sp>
@@ -11964,7 +12482,7 @@
 </file>
 
 <file path=ppt/slides/slide18.xml><?xml version="1.0" encoding="utf-8"?>
-<p:sld xmlns:a="http://schemas.openxmlformats.org/drawingml/2006/main" xmlns:p="http://schemas.openxmlformats.org/presentationml/2006/main" xmlns:r="http://schemas.openxmlformats.org/officeDocument/2006/relationships">
+<p:sld xmlns:a="http://schemas.openxmlformats.org/drawingml/2006/main" xmlns:r="http://schemas.openxmlformats.org/officeDocument/2006/relationships" xmlns:p="http://schemas.openxmlformats.org/presentationml/2006/main">
   <p:cSld>
     <p:spTree>
       <p:nvGrpSpPr>
@@ -11972,7 +12490,14 @@
         <p:cNvGrpSpPr/>
         <p:nvPr/>
       </p:nvGrpSpPr>
-      <p:grpSpPr/>
+      <p:grpSpPr>
+        <a:xfrm>
+          <a:off x="0" y="0"/>
+          <a:ext cx="0" cy="0"/>
+          <a:chOff x="0" y="0"/>
+          <a:chExt cx="0" cy="0"/>
+        </a:xfrm>
+      </p:grpSpPr>
       <p:sp>
         <p:nvSpPr>
           <p:cNvPr id="2" name="Rectangle 1"/>
@@ -12013,6 +12538,7 @@
           <a:lstStyle/>
           <a:p>
             <a:pPr algn="ctr"/>
+            <a:endParaRPr/>
           </a:p>
         </p:txBody>
       </p:sp>
@@ -12056,6 +12582,7 @@
           <a:lstStyle/>
           <a:p>
             <a:pPr algn="ctr"/>
+            <a:endParaRPr/>
           </a:p>
         </p:txBody>
       </p:sp>
@@ -12201,6 +12728,7 @@
           <a:lstStyle/>
           <a:p>
             <a:pPr algn="ctr"/>
+            <a:endParaRPr/>
           </a:p>
         </p:txBody>
       </p:sp>
@@ -12280,6 +12808,7 @@
           <a:lstStyle/>
           <a:p>
             <a:pPr algn="ctr"/>
+            <a:endParaRPr/>
           </a:p>
         </p:txBody>
       </p:sp>
@@ -12359,6 +12888,7 @@
           <a:lstStyle/>
           <a:p>
             <a:pPr algn="ctr"/>
+            <a:endParaRPr/>
           </a:p>
         </p:txBody>
       </p:sp>
@@ -12438,6 +12968,7 @@
           <a:lstStyle/>
           <a:p>
             <a:pPr algn="ctr"/>
+            <a:endParaRPr/>
           </a:p>
         </p:txBody>
       </p:sp>
@@ -12517,6 +13048,7 @@
           <a:lstStyle/>
           <a:p>
             <a:pPr algn="ctr"/>
+            <a:endParaRPr/>
           </a:p>
         </p:txBody>
       </p:sp>
@@ -12596,6 +13128,7 @@
           <a:lstStyle/>
           <a:p>
             <a:pPr algn="ctr"/>
+            <a:endParaRPr/>
           </a:p>
         </p:txBody>
       </p:sp>
@@ -12675,6 +13208,7 @@
           <a:lstStyle/>
           <a:p>
             <a:pPr algn="ctr"/>
+            <a:endParaRPr/>
           </a:p>
         </p:txBody>
       </p:sp>
@@ -12754,6 +13288,7 @@
           <a:lstStyle/>
           <a:p>
             <a:pPr algn="ctr"/>
+            <a:endParaRPr/>
           </a:p>
         </p:txBody>
       </p:sp>
@@ -12833,6 +13368,7 @@
           <a:lstStyle/>
           <a:p>
             <a:pPr algn="ctr"/>
+            <a:endParaRPr/>
           </a:p>
         </p:txBody>
       </p:sp>
@@ -12912,6 +13448,7 @@
           <a:lstStyle/>
           <a:p>
             <a:pPr algn="ctr"/>
+            <a:endParaRPr/>
           </a:p>
         </p:txBody>
       </p:sp>
@@ -12989,6 +13526,7 @@
           <a:lstStyle/>
           <a:p>
             <a:pPr algn="ctr"/>
+            <a:endParaRPr/>
           </a:p>
         </p:txBody>
       </p:sp>
@@ -13068,6 +13606,7 @@
           <a:lstStyle/>
           <a:p>
             <a:pPr algn="ctr"/>
+            <a:endParaRPr/>
           </a:p>
         </p:txBody>
       </p:sp>
@@ -13147,6 +13686,7 @@
           <a:lstStyle/>
           <a:p>
             <a:pPr algn="ctr"/>
+            <a:endParaRPr/>
           </a:p>
         </p:txBody>
       </p:sp>
@@ -13226,6 +13766,7 @@
           <a:lstStyle/>
           <a:p>
             <a:pPr algn="ctr"/>
+            <a:endParaRPr/>
           </a:p>
         </p:txBody>
       </p:sp>
@@ -13305,6 +13846,7 @@
           <a:lstStyle/>
           <a:p>
             <a:pPr algn="ctr"/>
+            <a:endParaRPr/>
           </a:p>
         </p:txBody>
       </p:sp>
@@ -13382,6 +13924,7 @@
           <a:lstStyle/>
           <a:p>
             <a:pPr algn="ctr"/>
+            <a:endParaRPr/>
           </a:p>
         </p:txBody>
       </p:sp>
@@ -13461,6 +14004,7 @@
           <a:lstStyle/>
           <a:p>
             <a:pPr algn="ctr"/>
+            <a:endParaRPr/>
           </a:p>
         </p:txBody>
       </p:sp>
@@ -13540,6 +14084,7 @@
           <a:lstStyle/>
           <a:p>
             <a:pPr algn="ctr"/>
+            <a:endParaRPr/>
           </a:p>
         </p:txBody>
       </p:sp>
@@ -13619,6 +14164,7 @@
           <a:lstStyle/>
           <a:p>
             <a:pPr algn="ctr"/>
+            <a:endParaRPr/>
           </a:p>
         </p:txBody>
       </p:sp>
@@ -13698,6 +14244,7 @@
           <a:lstStyle/>
           <a:p>
             <a:pPr algn="ctr"/>
+            <a:endParaRPr/>
           </a:p>
         </p:txBody>
       </p:sp>
@@ -13777,6 +14324,7 @@
           <a:lstStyle/>
           <a:p>
             <a:pPr algn="ctr"/>
+            <a:endParaRPr/>
           </a:p>
         </p:txBody>
       </p:sp>
@@ -13856,6 +14404,7 @@
           <a:lstStyle/>
           <a:p>
             <a:pPr algn="ctr"/>
+            <a:endParaRPr/>
           </a:p>
         </p:txBody>
       </p:sp>
@@ -13933,6 +14482,7 @@
           <a:lstStyle/>
           <a:p>
             <a:pPr algn="ctr"/>
+            <a:endParaRPr/>
           </a:p>
         </p:txBody>
       </p:sp>
@@ -13979,7 +14529,7 @@
 </file>
 
 <file path=ppt/slides/slide19.xml><?xml version="1.0" encoding="utf-8"?>
-<p:sld xmlns:a="http://schemas.openxmlformats.org/drawingml/2006/main" xmlns:p="http://schemas.openxmlformats.org/presentationml/2006/main" xmlns:r="http://schemas.openxmlformats.org/officeDocument/2006/relationships">
+<p:sld xmlns:a="http://schemas.openxmlformats.org/drawingml/2006/main" xmlns:r="http://schemas.openxmlformats.org/officeDocument/2006/relationships" xmlns:p="http://schemas.openxmlformats.org/presentationml/2006/main">
   <p:cSld>
     <p:spTree>
       <p:nvGrpSpPr>
@@ -13987,7 +14537,14 @@
         <p:cNvGrpSpPr/>
         <p:nvPr/>
       </p:nvGrpSpPr>
-      <p:grpSpPr/>
+      <p:grpSpPr>
+        <a:xfrm>
+          <a:off x="0" y="0"/>
+          <a:ext cx="0" cy="0"/>
+          <a:chOff x="0" y="0"/>
+          <a:chExt cx="0" cy="0"/>
+        </a:xfrm>
+      </p:grpSpPr>
       <p:sp>
         <p:nvSpPr>
           <p:cNvPr id="2" name="Rectangle 1"/>
@@ -14028,6 +14585,7 @@
           <a:lstStyle/>
           <a:p>
             <a:pPr algn="ctr"/>
+            <a:endParaRPr/>
           </a:p>
         </p:txBody>
       </p:sp>
@@ -14071,6 +14629,7 @@
           <a:lstStyle/>
           <a:p>
             <a:pPr algn="ctr"/>
+            <a:endParaRPr/>
           </a:p>
         </p:txBody>
       </p:sp>
@@ -14216,6 +14775,7 @@
           <a:lstStyle/>
           <a:p>
             <a:pPr algn="ctr"/>
+            <a:endParaRPr/>
           </a:p>
         </p:txBody>
       </p:sp>
@@ -14363,6 +14923,7 @@
           <a:lstStyle/>
           <a:p>
             <a:pPr algn="ctr"/>
+            <a:endParaRPr/>
           </a:p>
         </p:txBody>
       </p:sp>
@@ -14406,6 +14967,7 @@
           <a:lstStyle/>
           <a:p>
             <a:pPr algn="ctr"/>
+            <a:endParaRPr/>
           </a:p>
         </p:txBody>
       </p:sp>
@@ -14553,6 +15115,7 @@
           <a:lstStyle/>
           <a:p>
             <a:pPr algn="ctr"/>
+            <a:endParaRPr/>
           </a:p>
         </p:txBody>
       </p:sp>
@@ -14596,6 +15159,7 @@
           <a:lstStyle/>
           <a:p>
             <a:pPr algn="ctr"/>
+            <a:endParaRPr/>
           </a:p>
         </p:txBody>
       </p:sp>
@@ -14743,6 +15307,7 @@
           <a:lstStyle/>
           <a:p>
             <a:pPr algn="ctr"/>
+            <a:endParaRPr/>
           </a:p>
         </p:txBody>
       </p:sp>
@@ -14786,6 +15351,7 @@
           <a:lstStyle/>
           <a:p>
             <a:pPr algn="ctr"/>
+            <a:endParaRPr/>
           </a:p>
         </p:txBody>
       </p:sp>
@@ -14933,6 +15499,7 @@
           <a:lstStyle/>
           <a:p>
             <a:pPr algn="ctr"/>
+            <a:endParaRPr/>
           </a:p>
         </p:txBody>
       </p:sp>
@@ -14976,6 +15543,7 @@
           <a:lstStyle/>
           <a:p>
             <a:pPr algn="ctr"/>
+            <a:endParaRPr/>
           </a:p>
         </p:txBody>
       </p:sp>
@@ -15121,6 +15689,7 @@
           <a:lstStyle/>
           <a:p>
             <a:pPr algn="ctr"/>
+            <a:endParaRPr/>
           </a:p>
         </p:txBody>
       </p:sp>
@@ -15404,6 +15973,7 @@
           <a:lstStyle/>
           <a:p>
             <a:pPr algn="ctr"/>
+            <a:endParaRPr/>
           </a:p>
         </p:txBody>
       </p:sp>
@@ -15549,6 +16119,7 @@
           <a:lstStyle/>
           <a:p>
             <a:pPr algn="ctr"/>
+            <a:endParaRPr/>
           </a:p>
         </p:txBody>
       </p:sp>
@@ -15595,7 +16166,7 @@
 </file>
 
 <file path=ppt/slides/slide2.xml><?xml version="1.0" encoding="utf-8"?>
-<p:sld xmlns:a="http://schemas.openxmlformats.org/drawingml/2006/main" xmlns:p="http://schemas.openxmlformats.org/presentationml/2006/main" xmlns:r="http://schemas.openxmlformats.org/officeDocument/2006/relationships">
+<p:sld xmlns:a="http://schemas.openxmlformats.org/drawingml/2006/main" xmlns:r="http://schemas.openxmlformats.org/officeDocument/2006/relationships" xmlns:p="http://schemas.openxmlformats.org/presentationml/2006/main">
   <p:cSld>
     <p:spTree>
       <p:nvGrpSpPr>
@@ -15603,7 +16174,14 @@
         <p:cNvGrpSpPr/>
         <p:nvPr/>
       </p:nvGrpSpPr>
-      <p:grpSpPr/>
+      <p:grpSpPr>
+        <a:xfrm>
+          <a:off x="0" y="0"/>
+          <a:ext cx="0" cy="0"/>
+          <a:chOff x="0" y="0"/>
+          <a:chExt cx="0" cy="0"/>
+        </a:xfrm>
+      </p:grpSpPr>
       <p:sp>
         <p:nvSpPr>
           <p:cNvPr id="2" name="Rectangle 1"/>
@@ -15644,6 +16222,7 @@
           <a:lstStyle/>
           <a:p>
             <a:pPr algn="ctr"/>
+            <a:endParaRPr/>
           </a:p>
         </p:txBody>
       </p:sp>
@@ -15687,6 +16266,7 @@
           <a:lstStyle/>
           <a:p>
             <a:pPr algn="ctr"/>
+            <a:endParaRPr/>
           </a:p>
         </p:txBody>
       </p:sp>
@@ -15832,6 +16412,7 @@
           <a:lstStyle/>
           <a:p>
             <a:pPr algn="ctr"/>
+            <a:endParaRPr/>
           </a:p>
         </p:txBody>
       </p:sp>
@@ -15909,6 +16490,7 @@
           <a:lstStyle/>
           <a:p>
             <a:pPr algn="ctr"/>
+            <a:endParaRPr/>
           </a:p>
         </p:txBody>
       </p:sp>
@@ -15986,6 +16568,7 @@
           <a:lstStyle/>
           <a:p>
             <a:pPr algn="ctr"/>
+            <a:endParaRPr/>
           </a:p>
         </p:txBody>
       </p:sp>
@@ -16065,6 +16648,7 @@
           <a:lstStyle/>
           <a:p>
             <a:pPr algn="ctr"/>
+            <a:endParaRPr/>
           </a:p>
         </p:txBody>
       </p:sp>
@@ -16144,6 +16728,7 @@
           <a:lstStyle/>
           <a:p>
             <a:pPr algn="ctr"/>
+            <a:endParaRPr/>
           </a:p>
         </p:txBody>
       </p:sp>
@@ -16223,6 +16808,7 @@
           <a:lstStyle/>
           <a:p>
             <a:pPr algn="ctr"/>
+            <a:endParaRPr/>
           </a:p>
         </p:txBody>
       </p:sp>
@@ -16302,6 +16888,7 @@
           <a:lstStyle/>
           <a:p>
             <a:pPr algn="ctr"/>
+            <a:endParaRPr/>
           </a:p>
         </p:txBody>
       </p:sp>
@@ -16381,6 +16968,7 @@
           <a:lstStyle/>
           <a:p>
             <a:pPr algn="ctr"/>
+            <a:endParaRPr/>
           </a:p>
         </p:txBody>
       </p:sp>
@@ -16460,6 +17048,7 @@
           <a:lstStyle/>
           <a:p>
             <a:pPr algn="ctr"/>
+            <a:endParaRPr/>
           </a:p>
         </p:txBody>
       </p:sp>
@@ -16539,6 +17128,7 @@
           <a:lstStyle/>
           <a:p>
             <a:pPr algn="ctr"/>
+            <a:endParaRPr/>
           </a:p>
         </p:txBody>
       </p:sp>
@@ -16618,6 +17208,7 @@
           <a:lstStyle/>
           <a:p>
             <a:pPr algn="ctr"/>
+            <a:endParaRPr/>
           </a:p>
         </p:txBody>
       </p:sp>
@@ -16697,6 +17288,7 @@
           <a:lstStyle/>
           <a:p>
             <a:pPr algn="ctr"/>
+            <a:endParaRPr/>
           </a:p>
         </p:txBody>
       </p:sp>
@@ -16776,6 +17368,7 @@
           <a:lstStyle/>
           <a:p>
             <a:pPr algn="ctr"/>
+            <a:endParaRPr/>
           </a:p>
         </p:txBody>
       </p:sp>
@@ -16855,6 +17448,7 @@
           <a:lstStyle/>
           <a:p>
             <a:pPr algn="ctr"/>
+            <a:endParaRPr/>
           </a:p>
         </p:txBody>
       </p:sp>
@@ -16934,6 +17528,7 @@
           <a:lstStyle/>
           <a:p>
             <a:pPr algn="ctr"/>
+            <a:endParaRPr/>
           </a:p>
         </p:txBody>
       </p:sp>
@@ -17013,6 +17608,7 @@
           <a:lstStyle/>
           <a:p>
             <a:pPr algn="ctr"/>
+            <a:endParaRPr/>
           </a:p>
         </p:txBody>
       </p:sp>
@@ -17092,6 +17688,7 @@
           <a:lstStyle/>
           <a:p>
             <a:pPr algn="ctr"/>
+            <a:endParaRPr/>
           </a:p>
         </p:txBody>
       </p:sp>
@@ -17171,6 +17768,7 @@
           <a:lstStyle/>
           <a:p>
             <a:pPr algn="ctr"/>
+            <a:endParaRPr/>
           </a:p>
         </p:txBody>
       </p:sp>
@@ -17250,6 +17848,7 @@
           <a:lstStyle/>
           <a:p>
             <a:pPr algn="ctr"/>
+            <a:endParaRPr/>
           </a:p>
         </p:txBody>
       </p:sp>
@@ -17329,6 +17928,7 @@
           <a:lstStyle/>
           <a:p>
             <a:pPr algn="ctr"/>
+            <a:endParaRPr/>
           </a:p>
         </p:txBody>
       </p:sp>
@@ -17408,6 +18008,7 @@
           <a:lstStyle/>
           <a:p>
             <a:pPr algn="ctr"/>
+            <a:endParaRPr/>
           </a:p>
         </p:txBody>
       </p:sp>
@@ -17487,6 +18088,7 @@
           <a:lstStyle/>
           <a:p>
             <a:pPr algn="ctr"/>
+            <a:endParaRPr/>
           </a:p>
         </p:txBody>
       </p:sp>
@@ -17566,6 +18168,7 @@
           <a:lstStyle/>
           <a:p>
             <a:pPr algn="ctr"/>
+            <a:endParaRPr/>
           </a:p>
         </p:txBody>
       </p:sp>
@@ -17645,6 +18248,7 @@
           <a:lstStyle/>
           <a:p>
             <a:pPr algn="ctr"/>
+            <a:endParaRPr/>
           </a:p>
         </p:txBody>
       </p:sp>
@@ -17722,6 +18326,7 @@
           <a:lstStyle/>
           <a:p>
             <a:pPr algn="ctr"/>
+            <a:endParaRPr/>
           </a:p>
         </p:txBody>
       </p:sp>
@@ -17768,7 +18373,7 @@
 </file>
 
 <file path=ppt/slides/slide20.xml><?xml version="1.0" encoding="utf-8"?>
-<p:sld xmlns:a="http://schemas.openxmlformats.org/drawingml/2006/main" xmlns:p="http://schemas.openxmlformats.org/presentationml/2006/main" xmlns:r="http://schemas.openxmlformats.org/officeDocument/2006/relationships">
+<p:sld xmlns:a="http://schemas.openxmlformats.org/drawingml/2006/main" xmlns:r="http://schemas.openxmlformats.org/officeDocument/2006/relationships" xmlns:p="http://schemas.openxmlformats.org/presentationml/2006/main">
   <p:cSld>
     <p:spTree>
       <p:nvGrpSpPr>
@@ -17776,7 +18381,14 @@
         <p:cNvGrpSpPr/>
         <p:nvPr/>
       </p:nvGrpSpPr>
-      <p:grpSpPr/>
+      <p:grpSpPr>
+        <a:xfrm>
+          <a:off x="0" y="0"/>
+          <a:ext cx="0" cy="0"/>
+          <a:chOff x="0" y="0"/>
+          <a:chExt cx="0" cy="0"/>
+        </a:xfrm>
+      </p:grpSpPr>
       <p:sp>
         <p:nvSpPr>
           <p:cNvPr id="2" name="Rectangle 1"/>
@@ -17817,6 +18429,7 @@
           <a:lstStyle/>
           <a:p>
             <a:pPr algn="ctr"/>
+            <a:endParaRPr/>
           </a:p>
         </p:txBody>
       </p:sp>
@@ -17860,6 +18473,7 @@
           <a:lstStyle/>
           <a:p>
             <a:pPr algn="ctr"/>
+            <a:endParaRPr/>
           </a:p>
         </p:txBody>
       </p:sp>
@@ -17971,6 +18585,7 @@
           <a:lstStyle/>
           <a:p>
             <a:pPr algn="ctr"/>
+            <a:endParaRPr/>
           </a:p>
         </p:txBody>
       </p:sp>
@@ -18116,6 +18731,7 @@
           <a:lstStyle/>
           <a:p>
             <a:pPr algn="ctr"/>
+            <a:endParaRPr/>
           </a:p>
         </p:txBody>
       </p:sp>
@@ -18569,6 +19185,7 @@
           <a:lstStyle/>
           <a:p>
             <a:pPr algn="ctr"/>
+            <a:endParaRPr/>
           </a:p>
         </p:txBody>
       </p:sp>
@@ -18615,7 +19232,7 @@
 </file>
 
 <file path=ppt/slides/slide3.xml><?xml version="1.0" encoding="utf-8"?>
-<p:sld xmlns:a="http://schemas.openxmlformats.org/drawingml/2006/main" xmlns:p="http://schemas.openxmlformats.org/presentationml/2006/main" xmlns:r="http://schemas.openxmlformats.org/officeDocument/2006/relationships">
+<p:sld xmlns:a="http://schemas.openxmlformats.org/drawingml/2006/main" xmlns:r="http://schemas.openxmlformats.org/officeDocument/2006/relationships" xmlns:p="http://schemas.openxmlformats.org/presentationml/2006/main">
   <p:cSld>
     <p:spTree>
       <p:nvGrpSpPr>
@@ -18623,7 +19240,14 @@
         <p:cNvGrpSpPr/>
         <p:nvPr/>
       </p:nvGrpSpPr>
-      <p:grpSpPr/>
+      <p:grpSpPr>
+        <a:xfrm>
+          <a:off x="0" y="0"/>
+          <a:ext cx="0" cy="0"/>
+          <a:chOff x="0" y="0"/>
+          <a:chExt cx="0" cy="0"/>
+        </a:xfrm>
+      </p:grpSpPr>
       <p:sp>
         <p:nvSpPr>
           <p:cNvPr id="2" name="Rectangle 1"/>
@@ -18664,6 +19288,7 @@
           <a:lstStyle/>
           <a:p>
             <a:pPr algn="ctr"/>
+            <a:endParaRPr/>
           </a:p>
         </p:txBody>
       </p:sp>
@@ -18707,6 +19332,7 @@
           <a:lstStyle/>
           <a:p>
             <a:pPr algn="ctr"/>
+            <a:endParaRPr/>
           </a:p>
         </p:txBody>
       </p:sp>
@@ -18852,6 +19478,7 @@
           <a:lstStyle/>
           <a:p>
             <a:pPr algn="ctr"/>
+            <a:endParaRPr/>
           </a:p>
         </p:txBody>
       </p:sp>
@@ -18929,6 +19556,7 @@
           <a:lstStyle/>
           <a:p>
             <a:pPr algn="ctr"/>
+            <a:endParaRPr/>
           </a:p>
         </p:txBody>
       </p:sp>
@@ -19006,6 +19634,7 @@
           <a:lstStyle/>
           <a:p>
             <a:pPr algn="ctr"/>
+            <a:endParaRPr/>
           </a:p>
         </p:txBody>
       </p:sp>
@@ -19083,6 +19712,7 @@
           <a:lstStyle/>
           <a:p>
             <a:pPr algn="ctr"/>
+            <a:endParaRPr/>
           </a:p>
         </p:txBody>
       </p:sp>
@@ -19160,6 +19790,7 @@
           <a:lstStyle/>
           <a:p>
             <a:pPr algn="ctr"/>
+            <a:endParaRPr/>
           </a:p>
         </p:txBody>
       </p:sp>
@@ -19271,6 +19902,7 @@
           <a:lstStyle/>
           <a:p>
             <a:pPr algn="ctr"/>
+            <a:endParaRPr/>
           </a:p>
         </p:txBody>
       </p:sp>
@@ -19348,6 +19980,7 @@
           <a:lstStyle/>
           <a:p>
             <a:pPr algn="ctr"/>
+            <a:endParaRPr/>
           </a:p>
         </p:txBody>
       </p:sp>
@@ -19426,6 +20059,7 @@
           <a:lstStyle/>
           <a:p>
             <a:pPr algn="ctr"/>
+            <a:endParaRPr/>
           </a:p>
         </p:txBody>
       </p:sp>
@@ -19609,7 +20243,7 @@
 </file>
 
 <file path=ppt/slides/slide4.xml><?xml version="1.0" encoding="utf-8"?>
-<p:sld xmlns:a="http://schemas.openxmlformats.org/drawingml/2006/main" xmlns:p="http://schemas.openxmlformats.org/presentationml/2006/main" xmlns:r="http://schemas.openxmlformats.org/officeDocument/2006/relationships">
+<p:sld xmlns:a="http://schemas.openxmlformats.org/drawingml/2006/main" xmlns:r="http://schemas.openxmlformats.org/officeDocument/2006/relationships" xmlns:p="http://schemas.openxmlformats.org/presentationml/2006/main">
   <p:cSld>
     <p:spTree>
       <p:nvGrpSpPr>
@@ -19617,7 +20251,14 @@
         <p:cNvGrpSpPr/>
         <p:nvPr/>
       </p:nvGrpSpPr>
-      <p:grpSpPr/>
+      <p:grpSpPr>
+        <a:xfrm>
+          <a:off x="0" y="0"/>
+          <a:ext cx="0" cy="0"/>
+          <a:chOff x="0" y="0"/>
+          <a:chExt cx="0" cy="0"/>
+        </a:xfrm>
+      </p:grpSpPr>
       <p:sp>
         <p:nvSpPr>
           <p:cNvPr id="2" name="Rectangle 1"/>
@@ -19658,6 +20299,7 @@
           <a:lstStyle/>
           <a:p>
             <a:pPr algn="ctr"/>
+            <a:endParaRPr/>
           </a:p>
         </p:txBody>
       </p:sp>
@@ -19701,6 +20343,7 @@
           <a:lstStyle/>
           <a:p>
             <a:pPr algn="ctr"/>
+            <a:endParaRPr/>
           </a:p>
         </p:txBody>
       </p:sp>
@@ -19846,6 +20489,7 @@
           <a:lstStyle/>
           <a:p>
             <a:pPr algn="ctr"/>
+            <a:endParaRPr/>
           </a:p>
         </p:txBody>
       </p:sp>
@@ -19991,6 +20635,7 @@
           <a:lstStyle/>
           <a:p>
             <a:pPr algn="ctr"/>
+            <a:endParaRPr/>
           </a:p>
         </p:txBody>
       </p:sp>
@@ -20136,6 +20781,7 @@
           <a:lstStyle/>
           <a:p>
             <a:pPr algn="ctr"/>
+            <a:endParaRPr/>
           </a:p>
         </p:txBody>
       </p:sp>
@@ -20281,6 +20927,7 @@
           <a:lstStyle/>
           <a:p>
             <a:pPr algn="ctr"/>
+            <a:endParaRPr/>
           </a:p>
         </p:txBody>
       </p:sp>
@@ -20426,6 +21073,7 @@
           <a:lstStyle/>
           <a:p>
             <a:pPr algn="ctr"/>
+            <a:endParaRPr/>
           </a:p>
         </p:txBody>
       </p:sp>
@@ -20608,7 +21256,7 @@
 </file>
 
 <file path=ppt/slides/slide5.xml><?xml version="1.0" encoding="utf-8"?>
-<p:sld xmlns:a="http://schemas.openxmlformats.org/drawingml/2006/main" xmlns:p="http://schemas.openxmlformats.org/presentationml/2006/main" xmlns:r="http://schemas.openxmlformats.org/officeDocument/2006/relationships">
+<p:sld xmlns:a="http://schemas.openxmlformats.org/drawingml/2006/main" xmlns:r="http://schemas.openxmlformats.org/officeDocument/2006/relationships" xmlns:p="http://schemas.openxmlformats.org/presentationml/2006/main">
   <p:cSld>
     <p:spTree>
       <p:nvGrpSpPr>
@@ -20616,7 +21264,14 @@
         <p:cNvGrpSpPr/>
         <p:nvPr/>
       </p:nvGrpSpPr>
-      <p:grpSpPr/>
+      <p:grpSpPr>
+        <a:xfrm>
+          <a:off x="0" y="0"/>
+          <a:ext cx="0" cy="0"/>
+          <a:chOff x="0" y="0"/>
+          <a:chExt cx="0" cy="0"/>
+        </a:xfrm>
+      </p:grpSpPr>
       <p:sp>
         <p:nvSpPr>
           <p:cNvPr id="2" name="Rectangle 1"/>
@@ -20657,6 +21312,7 @@
           <a:lstStyle/>
           <a:p>
             <a:pPr algn="ctr"/>
+            <a:endParaRPr/>
           </a:p>
         </p:txBody>
       </p:sp>
@@ -20700,6 +21356,7 @@
           <a:lstStyle/>
           <a:p>
             <a:pPr algn="ctr"/>
+            <a:endParaRPr/>
           </a:p>
         </p:txBody>
       </p:sp>
@@ -20845,6 +21502,7 @@
           <a:lstStyle/>
           <a:p>
             <a:pPr algn="ctr"/>
+            <a:endParaRPr/>
           </a:p>
         </p:txBody>
       </p:sp>
@@ -20922,6 +21580,7 @@
           <a:lstStyle/>
           <a:p>
             <a:pPr algn="ctr"/>
+            <a:endParaRPr/>
           </a:p>
         </p:txBody>
       </p:sp>
@@ -20999,6 +21658,7 @@
           <a:lstStyle/>
           <a:p>
             <a:pPr algn="ctr"/>
+            <a:endParaRPr/>
           </a:p>
         </p:txBody>
       </p:sp>
@@ -21076,6 +21736,7 @@
           <a:lstStyle/>
           <a:p>
             <a:pPr algn="ctr"/>
+            <a:endParaRPr/>
           </a:p>
         </p:txBody>
       </p:sp>
@@ -21153,6 +21814,7 @@
           <a:lstStyle/>
           <a:p>
             <a:pPr algn="ctr"/>
+            <a:endParaRPr/>
           </a:p>
         </p:txBody>
       </p:sp>
@@ -21230,6 +21892,7 @@
           <a:lstStyle/>
           <a:p>
             <a:pPr algn="ctr"/>
+            <a:endParaRPr/>
           </a:p>
         </p:txBody>
       </p:sp>
@@ -21307,6 +21970,7 @@
           <a:lstStyle/>
           <a:p>
             <a:pPr algn="ctr"/>
+            <a:endParaRPr/>
           </a:p>
         </p:txBody>
       </p:sp>
@@ -21386,6 +22050,7 @@
           <a:lstStyle/>
           <a:p>
             <a:pPr algn="ctr"/>
+            <a:endParaRPr/>
           </a:p>
         </p:txBody>
       </p:sp>
@@ -21465,6 +22130,7 @@
           <a:lstStyle/>
           <a:p>
             <a:pPr algn="ctr"/>
+            <a:endParaRPr/>
           </a:p>
         </p:txBody>
       </p:sp>
@@ -21544,6 +22210,7 @@
           <a:lstStyle/>
           <a:p>
             <a:pPr algn="ctr"/>
+            <a:endParaRPr/>
           </a:p>
         </p:txBody>
       </p:sp>
@@ -21623,6 +22290,7 @@
           <a:lstStyle/>
           <a:p>
             <a:pPr algn="ctr"/>
+            <a:endParaRPr/>
           </a:p>
         </p:txBody>
       </p:sp>
@@ -21702,6 +22370,7 @@
           <a:lstStyle/>
           <a:p>
             <a:pPr algn="ctr"/>
+            <a:endParaRPr/>
           </a:p>
         </p:txBody>
       </p:sp>
@@ -21781,6 +22450,7 @@
           <a:lstStyle/>
           <a:p>
             <a:pPr algn="ctr"/>
+            <a:endParaRPr/>
           </a:p>
         </p:txBody>
       </p:sp>
@@ -21860,6 +22530,7 @@
           <a:lstStyle/>
           <a:p>
             <a:pPr algn="ctr"/>
+            <a:endParaRPr/>
           </a:p>
         </p:txBody>
       </p:sp>
@@ -21939,6 +22610,7 @@
           <a:lstStyle/>
           <a:p>
             <a:pPr algn="ctr"/>
+            <a:endParaRPr/>
           </a:p>
         </p:txBody>
       </p:sp>
@@ -22018,6 +22690,7 @@
           <a:lstStyle/>
           <a:p>
             <a:pPr algn="ctr"/>
+            <a:endParaRPr/>
           </a:p>
         </p:txBody>
       </p:sp>
@@ -22097,6 +22770,7 @@
           <a:lstStyle/>
           <a:p>
             <a:pPr algn="ctr"/>
+            <a:endParaRPr/>
           </a:p>
         </p:txBody>
       </p:sp>
@@ -22176,6 +22850,7 @@
           <a:lstStyle/>
           <a:p>
             <a:pPr algn="ctr"/>
+            <a:endParaRPr/>
           </a:p>
         </p:txBody>
       </p:sp>
@@ -22255,6 +22930,7 @@
           <a:lstStyle/>
           <a:p>
             <a:pPr algn="ctr"/>
+            <a:endParaRPr/>
           </a:p>
         </p:txBody>
       </p:sp>
@@ -22334,6 +23010,7 @@
           <a:lstStyle/>
           <a:p>
             <a:pPr algn="ctr"/>
+            <a:endParaRPr/>
           </a:p>
         </p:txBody>
       </p:sp>
@@ -22413,6 +23090,7 @@
           <a:lstStyle/>
           <a:p>
             <a:pPr algn="ctr"/>
+            <a:endParaRPr/>
           </a:p>
         </p:txBody>
       </p:sp>
@@ -22492,6 +23170,7 @@
           <a:lstStyle/>
           <a:p>
             <a:pPr algn="ctr"/>
+            <a:endParaRPr/>
           </a:p>
         </p:txBody>
       </p:sp>
@@ -22571,6 +23250,7 @@
           <a:lstStyle/>
           <a:p>
             <a:pPr algn="ctr"/>
+            <a:endParaRPr/>
           </a:p>
         </p:txBody>
       </p:sp>
@@ -22650,6 +23330,7 @@
           <a:lstStyle/>
           <a:p>
             <a:pPr algn="ctr"/>
+            <a:endParaRPr/>
           </a:p>
         </p:txBody>
       </p:sp>
@@ -22729,6 +23410,7 @@
           <a:lstStyle/>
           <a:p>
             <a:pPr algn="ctr"/>
+            <a:endParaRPr/>
           </a:p>
         </p:txBody>
       </p:sp>
@@ -22808,6 +23490,7 @@
           <a:lstStyle/>
           <a:p>
             <a:pPr algn="ctr"/>
+            <a:endParaRPr/>
           </a:p>
         </p:txBody>
       </p:sp>
@@ -22887,6 +23570,7 @@
           <a:lstStyle/>
           <a:p>
             <a:pPr algn="ctr"/>
+            <a:endParaRPr/>
           </a:p>
         </p:txBody>
       </p:sp>
@@ -22966,6 +23650,7 @@
           <a:lstStyle/>
           <a:p>
             <a:pPr algn="ctr"/>
+            <a:endParaRPr/>
           </a:p>
         </p:txBody>
       </p:sp>
@@ -23045,6 +23730,7 @@
           <a:lstStyle/>
           <a:p>
             <a:pPr algn="ctr"/>
+            <a:endParaRPr/>
           </a:p>
         </p:txBody>
       </p:sp>
@@ -23124,6 +23810,7 @@
           <a:lstStyle/>
           <a:p>
             <a:pPr algn="ctr"/>
+            <a:endParaRPr/>
           </a:p>
         </p:txBody>
       </p:sp>
@@ -23203,6 +23890,7 @@
           <a:lstStyle/>
           <a:p>
             <a:pPr algn="ctr"/>
+            <a:endParaRPr/>
           </a:p>
         </p:txBody>
       </p:sp>
@@ -23282,6 +23970,7 @@
           <a:lstStyle/>
           <a:p>
             <a:pPr algn="ctr"/>
+            <a:endParaRPr/>
           </a:p>
         </p:txBody>
       </p:sp>
@@ -23361,6 +24050,7 @@
           <a:lstStyle/>
           <a:p>
             <a:pPr algn="ctr"/>
+            <a:endParaRPr/>
           </a:p>
         </p:txBody>
       </p:sp>
@@ -23440,6 +24130,7 @@
           <a:lstStyle/>
           <a:p>
             <a:pPr algn="ctr"/>
+            <a:endParaRPr/>
           </a:p>
         </p:txBody>
       </p:sp>
@@ -23519,6 +24210,7 @@
           <a:lstStyle/>
           <a:p>
             <a:pPr algn="ctr"/>
+            <a:endParaRPr/>
           </a:p>
         </p:txBody>
       </p:sp>
@@ -23598,6 +24290,7 @@
           <a:lstStyle/>
           <a:p>
             <a:pPr algn="ctr"/>
+            <a:endParaRPr/>
           </a:p>
         </p:txBody>
       </p:sp>
@@ -23677,6 +24370,7 @@
           <a:lstStyle/>
           <a:p>
             <a:pPr algn="ctr"/>
+            <a:endParaRPr/>
           </a:p>
         </p:txBody>
       </p:sp>
@@ -23756,6 +24450,7 @@
           <a:lstStyle/>
           <a:p>
             <a:pPr algn="ctr"/>
+            <a:endParaRPr/>
           </a:p>
         </p:txBody>
       </p:sp>
@@ -23835,6 +24530,7 @@
           <a:lstStyle/>
           <a:p>
             <a:pPr algn="ctr"/>
+            <a:endParaRPr/>
           </a:p>
         </p:txBody>
       </p:sp>
@@ -23914,6 +24610,7 @@
           <a:lstStyle/>
           <a:p>
             <a:pPr algn="ctr"/>
+            <a:endParaRPr/>
           </a:p>
         </p:txBody>
       </p:sp>
@@ -23993,6 +24690,7 @@
           <a:lstStyle/>
           <a:p>
             <a:pPr algn="ctr"/>
+            <a:endParaRPr/>
           </a:p>
         </p:txBody>
       </p:sp>
@@ -24072,6 +24770,7 @@
           <a:lstStyle/>
           <a:p>
             <a:pPr algn="ctr"/>
+            <a:endParaRPr/>
           </a:p>
         </p:txBody>
       </p:sp>
@@ -24186,7 +24885,7 @@
 </file>
 
 <file path=ppt/slides/slide6.xml><?xml version="1.0" encoding="utf-8"?>
-<p:sld xmlns:a="http://schemas.openxmlformats.org/drawingml/2006/main" xmlns:p="http://schemas.openxmlformats.org/presentationml/2006/main" xmlns:r="http://schemas.openxmlformats.org/officeDocument/2006/relationships">
+<p:sld xmlns:a="http://schemas.openxmlformats.org/drawingml/2006/main" xmlns:r="http://schemas.openxmlformats.org/officeDocument/2006/relationships" xmlns:p="http://schemas.openxmlformats.org/presentationml/2006/main">
   <p:cSld>
     <p:spTree>
       <p:nvGrpSpPr>
@@ -24194,7 +24893,14 @@
         <p:cNvGrpSpPr/>
         <p:nvPr/>
       </p:nvGrpSpPr>
-      <p:grpSpPr/>
+      <p:grpSpPr>
+        <a:xfrm>
+          <a:off x="0" y="0"/>
+          <a:ext cx="0" cy="0"/>
+          <a:chOff x="0" y="0"/>
+          <a:chExt cx="0" cy="0"/>
+        </a:xfrm>
+      </p:grpSpPr>
       <p:sp>
         <p:nvSpPr>
           <p:cNvPr id="2" name="Rectangle 1"/>
@@ -24235,6 +24941,7 @@
           <a:lstStyle/>
           <a:p>
             <a:pPr algn="ctr"/>
+            <a:endParaRPr/>
           </a:p>
         </p:txBody>
       </p:sp>
@@ -24278,6 +24985,7 @@
           <a:lstStyle/>
           <a:p>
             <a:pPr algn="ctr"/>
+            <a:endParaRPr/>
           </a:p>
         </p:txBody>
       </p:sp>
@@ -24423,6 +25131,7 @@
           <a:lstStyle/>
           <a:p>
             <a:pPr algn="ctr"/>
+            <a:endParaRPr/>
           </a:p>
         </p:txBody>
       </p:sp>
@@ -24502,6 +25211,7 @@
           <a:lstStyle/>
           <a:p>
             <a:pPr algn="ctr"/>
+            <a:endParaRPr/>
           </a:p>
         </p:txBody>
       </p:sp>
@@ -24579,6 +25289,7 @@
           <a:lstStyle/>
           <a:p>
             <a:pPr algn="ctr"/>
+            <a:endParaRPr/>
           </a:p>
         </p:txBody>
       </p:sp>
@@ -24656,6 +25367,7 @@
           <a:lstStyle/>
           <a:p>
             <a:pPr algn="ctr"/>
+            <a:endParaRPr/>
           </a:p>
         </p:txBody>
       </p:sp>
@@ -24735,6 +25447,7 @@
           <a:lstStyle/>
           <a:p>
             <a:pPr algn="ctr"/>
+            <a:endParaRPr/>
           </a:p>
         </p:txBody>
       </p:sp>
@@ -24812,6 +25525,7 @@
           <a:lstStyle/>
           <a:p>
             <a:pPr algn="ctr"/>
+            <a:endParaRPr/>
           </a:p>
         </p:txBody>
       </p:sp>
@@ -24923,6 +25637,7 @@
           <a:lstStyle/>
           <a:p>
             <a:pPr algn="ctr"/>
+            <a:endParaRPr/>
           </a:p>
         </p:txBody>
       </p:sp>
@@ -25002,6 +25717,7 @@
           <a:lstStyle/>
           <a:p>
             <a:pPr algn="ctr"/>
+            <a:endParaRPr/>
           </a:p>
         </p:txBody>
       </p:sp>
@@ -25079,6 +25795,7 @@
           <a:lstStyle/>
           <a:p>
             <a:pPr algn="ctr"/>
+            <a:endParaRPr/>
           </a:p>
         </p:txBody>
       </p:sp>
@@ -25190,6 +25907,7 @@
           <a:lstStyle/>
           <a:p>
             <a:pPr algn="ctr"/>
+            <a:endParaRPr/>
           </a:p>
         </p:txBody>
       </p:sp>
@@ -25269,6 +25987,7 @@
           <a:lstStyle/>
           <a:p>
             <a:pPr algn="ctr"/>
+            <a:endParaRPr/>
           </a:p>
         </p:txBody>
       </p:sp>
@@ -25346,6 +26065,7 @@
           <a:lstStyle/>
           <a:p>
             <a:pPr algn="ctr"/>
+            <a:endParaRPr/>
           </a:p>
         </p:txBody>
       </p:sp>
@@ -25423,6 +26143,7 @@
           <a:lstStyle/>
           <a:p>
             <a:pPr algn="ctr"/>
+            <a:endParaRPr/>
           </a:p>
         </p:txBody>
       </p:sp>
@@ -25502,6 +26223,7 @@
           <a:lstStyle/>
           <a:p>
             <a:pPr algn="ctr"/>
+            <a:endParaRPr/>
           </a:p>
         </p:txBody>
       </p:sp>
@@ -25579,6 +26301,7 @@
           <a:lstStyle/>
           <a:p>
             <a:pPr algn="ctr"/>
+            <a:endParaRPr/>
           </a:p>
         </p:txBody>
       </p:sp>
@@ -25656,6 +26379,7 @@
           <a:lstStyle/>
           <a:p>
             <a:pPr algn="ctr"/>
+            <a:endParaRPr/>
           </a:p>
         </p:txBody>
       </p:sp>
@@ -25735,6 +26459,7 @@
           <a:lstStyle/>
           <a:p>
             <a:pPr algn="ctr"/>
+            <a:endParaRPr/>
           </a:p>
         </p:txBody>
       </p:sp>
@@ -25812,6 +26537,7 @@
           <a:lstStyle/>
           <a:p>
             <a:pPr algn="ctr"/>
+            <a:endParaRPr/>
           </a:p>
         </p:txBody>
       </p:sp>
@@ -25889,6 +26615,7 @@
           <a:lstStyle/>
           <a:p>
             <a:pPr algn="ctr"/>
+            <a:endParaRPr/>
           </a:p>
         </p:txBody>
       </p:sp>
@@ -25968,6 +26695,7 @@
           <a:lstStyle/>
           <a:p>
             <a:pPr algn="ctr"/>
+            <a:endParaRPr/>
           </a:p>
         </p:txBody>
       </p:sp>
@@ -26045,6 +26773,7 @@
           <a:lstStyle/>
           <a:p>
             <a:pPr algn="ctr"/>
+            <a:endParaRPr/>
           </a:p>
         </p:txBody>
       </p:sp>
@@ -26122,6 +26851,7 @@
           <a:lstStyle/>
           <a:p>
             <a:pPr algn="ctr"/>
+            <a:endParaRPr/>
           </a:p>
         </p:txBody>
       </p:sp>
@@ -26199,6 +26929,7 @@
           <a:lstStyle/>
           <a:p>
             <a:pPr algn="ctr"/>
+            <a:endParaRPr/>
           </a:p>
         </p:txBody>
       </p:sp>
@@ -26276,6 +27007,7 @@
           <a:lstStyle/>
           <a:p>
             <a:pPr algn="ctr"/>
+            <a:endParaRPr/>
           </a:p>
         </p:txBody>
       </p:sp>
@@ -26353,6 +27085,7 @@
           <a:lstStyle/>
           <a:p>
             <a:pPr algn="ctr"/>
+            <a:endParaRPr/>
           </a:p>
         </p:txBody>
       </p:sp>
@@ -26399,7 +27132,7 @@
 </file>
 
 <file path=ppt/slides/slide7.xml><?xml version="1.0" encoding="utf-8"?>
-<p:sld xmlns:a="http://schemas.openxmlformats.org/drawingml/2006/main" xmlns:p="http://schemas.openxmlformats.org/presentationml/2006/main" xmlns:r="http://schemas.openxmlformats.org/officeDocument/2006/relationships">
+<p:sld xmlns:a="http://schemas.openxmlformats.org/drawingml/2006/main" xmlns:r="http://schemas.openxmlformats.org/officeDocument/2006/relationships" xmlns:p="http://schemas.openxmlformats.org/presentationml/2006/main">
   <p:cSld>
     <p:spTree>
       <p:nvGrpSpPr>
@@ -26407,7 +27140,14 @@
         <p:cNvGrpSpPr/>
         <p:nvPr/>
       </p:nvGrpSpPr>
-      <p:grpSpPr/>
+      <p:grpSpPr>
+        <a:xfrm>
+          <a:off x="0" y="0"/>
+          <a:ext cx="0" cy="0"/>
+          <a:chOff x="0" y="0"/>
+          <a:chExt cx="0" cy="0"/>
+        </a:xfrm>
+      </p:grpSpPr>
       <p:sp>
         <p:nvSpPr>
           <p:cNvPr id="2" name="Rectangle 1"/>
@@ -26448,6 +27188,7 @@
           <a:lstStyle/>
           <a:p>
             <a:pPr algn="ctr"/>
+            <a:endParaRPr/>
           </a:p>
         </p:txBody>
       </p:sp>
@@ -26491,6 +27232,7 @@
           <a:lstStyle/>
           <a:p>
             <a:pPr algn="ctr"/>
+            <a:endParaRPr/>
           </a:p>
         </p:txBody>
       </p:sp>
@@ -26636,6 +27378,7 @@
           <a:lstStyle/>
           <a:p>
             <a:pPr algn="ctr"/>
+            <a:endParaRPr/>
           </a:p>
         </p:txBody>
       </p:sp>
@@ -26747,6 +27490,7 @@
           <a:lstStyle/>
           <a:p>
             <a:pPr algn="ctr"/>
+            <a:endParaRPr/>
           </a:p>
         </p:txBody>
       </p:sp>
@@ -26858,6 +27602,7 @@
           <a:lstStyle/>
           <a:p>
             <a:pPr algn="ctr"/>
+            <a:endParaRPr/>
           </a:p>
         </p:txBody>
       </p:sp>
@@ -26969,6 +27714,7 @@
           <a:lstStyle/>
           <a:p>
             <a:pPr algn="ctr"/>
+            <a:endParaRPr/>
           </a:p>
         </p:txBody>
       </p:sp>
@@ -27080,6 +27826,7 @@
           <a:lstStyle/>
           <a:p>
             <a:pPr algn="ctr"/>
+            <a:endParaRPr/>
           </a:p>
         </p:txBody>
       </p:sp>
@@ -27191,6 +27938,7 @@
           <a:lstStyle/>
           <a:p>
             <a:pPr algn="ctr"/>
+            <a:endParaRPr/>
           </a:p>
         </p:txBody>
       </p:sp>
@@ -27302,6 +28050,7 @@
           <a:lstStyle/>
           <a:p>
             <a:pPr algn="ctr"/>
+            <a:endParaRPr/>
           </a:p>
         </p:txBody>
       </p:sp>
@@ -27413,6 +28162,7 @@
           <a:lstStyle/>
           <a:p>
             <a:pPr algn="ctr"/>
+            <a:endParaRPr/>
           </a:p>
         </p:txBody>
       </p:sp>
@@ -27492,7 +28242,7 @@
         </p:nvSpPr>
         <p:spPr>
           <a:xfrm>
-            <a:off x="4572000" y="2103120"/>
+            <a:off x="4572000" y="2039112"/>
             <a:ext cx="365760" cy="274320"/>
           </a:xfrm>
           <a:prstGeom prst="rect">
@@ -27508,7 +28258,7 @@
           <a:p>
             <a:pPr algn="ctr"/>
             <a:r>
-              <a:rPr sz="1600" b="0" i="0">
+              <a:rPr sz="1600" b="0" i="0" dirty="0">
                 <a:solidFill>
                   <a:srgbClr val="2E9CFF"/>
                 </a:solidFill>
@@ -27560,7 +28310,7 @@
         </p:nvSpPr>
         <p:spPr>
           <a:xfrm>
-            <a:off x="4572000" y="3840480"/>
+            <a:off x="4572000" y="3758750"/>
             <a:ext cx="365760" cy="274320"/>
           </a:xfrm>
           <a:prstGeom prst="rect">
@@ -27576,7 +28326,7 @@
           <a:p>
             <a:pPr algn="ctr"/>
             <a:r>
-              <a:rPr sz="1600" b="0" i="0">
+              <a:rPr sz="1600" b="0" i="0" dirty="0">
                 <a:solidFill>
                   <a:srgbClr val="2E9CFF"/>
                 </a:solidFill>
@@ -27594,7 +28344,7 @@
         </p:nvSpPr>
         <p:spPr>
           <a:xfrm>
-            <a:off x="4572000" y="4709160"/>
+            <a:off x="4572000" y="4654296"/>
             <a:ext cx="365760" cy="274320"/>
           </a:xfrm>
           <a:prstGeom prst="rect">
@@ -27610,7 +28360,7 @@
           <a:p>
             <a:pPr algn="ctr"/>
             <a:r>
-              <a:rPr sz="1600" b="0" i="0">
+              <a:rPr sz="1600" b="0" i="0" dirty="0">
                 <a:solidFill>
                   <a:srgbClr val="2E9CFF"/>
                 </a:solidFill>
@@ -27628,7 +28378,7 @@
         </p:nvSpPr>
         <p:spPr>
           <a:xfrm>
-            <a:off x="2286000" y="3840480"/>
+            <a:off x="2651760" y="2869849"/>
             <a:ext cx="365760" cy="274320"/>
           </a:xfrm>
           <a:prstGeom prst="rect">
@@ -27644,7 +28394,7 @@
           <a:p>
             <a:pPr algn="ctr"/>
             <a:r>
-              <a:rPr sz="1600" b="0" i="0">
+              <a:rPr sz="1600" b="0" i="0" dirty="0">
                 <a:solidFill>
                   <a:srgbClr val="2E9CFF"/>
                 </a:solidFill>
@@ -27662,7 +28412,7 @@
         </p:nvSpPr>
         <p:spPr>
           <a:xfrm>
-            <a:off x="6858000" y="3840480"/>
+            <a:off x="6126480" y="2884932"/>
             <a:ext cx="365760" cy="274320"/>
           </a:xfrm>
           <a:prstGeom prst="rect">
@@ -27678,80 +28428,12 @@
           <a:p>
             <a:pPr algn="ctr"/>
             <a:r>
-              <a:rPr sz="1600" b="0" i="0">
+              <a:rPr sz="1600" b="0" i="0" dirty="0">
                 <a:solidFill>
                   <a:srgbClr val="2E9CFF"/>
                 </a:solidFill>
               </a:rPr>
               <a:t>↘</a:t>
-            </a:r>
-          </a:p>
-        </p:txBody>
-      </p:sp>
-      <p:sp>
-        <p:nvSpPr>
-          <p:cNvPr id="37" name="TextBox 36"/>
-          <p:cNvSpPr txBox="1"/>
-          <p:nvPr/>
-        </p:nvSpPr>
-        <p:spPr>
-          <a:xfrm>
-            <a:off x="2286000" y="5577840"/>
-            <a:ext cx="365760" cy="274320"/>
-          </a:xfrm>
-          <a:prstGeom prst="rect">
-            <a:avLst/>
-          </a:prstGeom>
-          <a:noFill/>
-        </p:spPr>
-        <p:txBody>
-          <a:bodyPr wrap="square">
-            <a:spAutoFit/>
-          </a:bodyPr>
-          <a:lstStyle/>
-          <a:p>
-            <a:pPr algn="ctr"/>
-            <a:r>
-              <a:rPr sz="1600" b="0" i="0">
-                <a:solidFill>
-                  <a:srgbClr val="2E9CFF"/>
-                </a:solidFill>
-              </a:rPr>
-              <a:t>↓</a:t>
-            </a:r>
-          </a:p>
-        </p:txBody>
-      </p:sp>
-      <p:sp>
-        <p:nvSpPr>
-          <p:cNvPr id="38" name="TextBox 37"/>
-          <p:cNvSpPr txBox="1"/>
-          <p:nvPr/>
-        </p:nvSpPr>
-        <p:spPr>
-          <a:xfrm>
-            <a:off x="6858000" y="5577840"/>
-            <a:ext cx="365760" cy="274320"/>
-          </a:xfrm>
-          <a:prstGeom prst="rect">
-            <a:avLst/>
-          </a:prstGeom>
-          <a:noFill/>
-        </p:spPr>
-        <p:txBody>
-          <a:bodyPr wrap="square">
-            <a:spAutoFit/>
-          </a:bodyPr>
-          <a:lstStyle/>
-          <a:p>
-            <a:pPr algn="ctr"/>
-            <a:r>
-              <a:rPr sz="1600" b="0" i="0">
-                <a:solidFill>
-                  <a:srgbClr val="2E9CFF"/>
-                </a:solidFill>
-              </a:rPr>
-              <a:t>↓</a:t>
             </a:r>
           </a:p>
         </p:txBody>
@@ -27854,6 +28536,86 @@
                 </a:solidFill>
               </a:rPr>
               <a:t>•  Verifier is negation-hardened: "NOT provisioned" fails · "Provisioned and confirmed" passes</a:t>
+            </a:r>
+          </a:p>
+        </p:txBody>
+      </p:sp>
+      <p:sp>
+        <p:nvSpPr>
+          <p:cNvPr id="43" name="TextBox 42">
+            <a:extLst>
+              <a:ext uri="{FF2B5EF4-FFF2-40B4-BE49-F238E27FC236}">
+                <a16:creationId xmlns:a16="http://schemas.microsoft.com/office/drawing/2014/main" id="{09FD8394-0D59-2730-4422-622B6A607403}"/>
+              </a:ext>
+            </a:extLst>
+          </p:cNvPr>
+          <p:cNvSpPr txBox="1"/>
+          <p:nvPr/>
+        </p:nvSpPr>
+        <p:spPr>
+          <a:xfrm>
+            <a:off x="6134493" y="5417820"/>
+            <a:ext cx="365760" cy="274320"/>
+          </a:xfrm>
+          <a:prstGeom prst="rect">
+            <a:avLst/>
+          </a:prstGeom>
+          <a:noFill/>
+        </p:spPr>
+        <p:txBody>
+          <a:bodyPr wrap="square">
+            <a:spAutoFit/>
+          </a:bodyPr>
+          <a:lstStyle/>
+          <a:p>
+            <a:pPr algn="ctr"/>
+            <a:r>
+              <a:rPr sz="1600" b="0" i="0" dirty="0">
+                <a:solidFill>
+                  <a:srgbClr val="2E9CFF"/>
+                </a:solidFill>
+              </a:rPr>
+              <a:t>↘</a:t>
+            </a:r>
+          </a:p>
+        </p:txBody>
+      </p:sp>
+      <p:sp>
+        <p:nvSpPr>
+          <p:cNvPr id="47" name="TextBox 46">
+            <a:extLst>
+              <a:ext uri="{FF2B5EF4-FFF2-40B4-BE49-F238E27FC236}">
+                <a16:creationId xmlns:a16="http://schemas.microsoft.com/office/drawing/2014/main" id="{3EA85F26-F72C-2BA3-DC4B-94F77A7FC402}"/>
+              </a:ext>
+            </a:extLst>
+          </p:cNvPr>
+          <p:cNvSpPr txBox="1"/>
+          <p:nvPr/>
+        </p:nvSpPr>
+        <p:spPr>
+          <a:xfrm>
+            <a:off x="2585537" y="5413248"/>
+            <a:ext cx="365760" cy="274320"/>
+          </a:xfrm>
+          <a:prstGeom prst="rect">
+            <a:avLst/>
+          </a:prstGeom>
+          <a:noFill/>
+        </p:spPr>
+        <p:txBody>
+          <a:bodyPr wrap="square">
+            <a:spAutoFit/>
+          </a:bodyPr>
+          <a:lstStyle/>
+          <a:p>
+            <a:pPr algn="ctr"/>
+            <a:r>
+              <a:rPr sz="1600" b="0" i="0" dirty="0">
+                <a:solidFill>
+                  <a:srgbClr val="2E9CFF"/>
+                </a:solidFill>
+              </a:rPr>
+              <a:t>↙</a:t>
             </a:r>
           </a:p>
         </p:txBody>
@@ -27867,7 +28629,7 @@
 </file>
 
 <file path=ppt/slides/slide8.xml><?xml version="1.0" encoding="utf-8"?>
-<p:sld xmlns:a="http://schemas.openxmlformats.org/drawingml/2006/main" xmlns:p="http://schemas.openxmlformats.org/presentationml/2006/main" xmlns:r="http://schemas.openxmlformats.org/officeDocument/2006/relationships">
+<p:sld xmlns:a="http://schemas.openxmlformats.org/drawingml/2006/main" xmlns:r="http://schemas.openxmlformats.org/officeDocument/2006/relationships" xmlns:p="http://schemas.openxmlformats.org/presentationml/2006/main">
   <p:cSld>
     <p:spTree>
       <p:nvGrpSpPr>
@@ -27875,7 +28637,14 @@
         <p:cNvGrpSpPr/>
         <p:nvPr/>
       </p:nvGrpSpPr>
-      <p:grpSpPr/>
+      <p:grpSpPr>
+        <a:xfrm>
+          <a:off x="0" y="0"/>
+          <a:ext cx="0" cy="0"/>
+          <a:chOff x="0" y="0"/>
+          <a:chExt cx="0" cy="0"/>
+        </a:xfrm>
+      </p:grpSpPr>
       <p:sp>
         <p:nvSpPr>
           <p:cNvPr id="2" name="Rectangle 1"/>
@@ -27916,6 +28685,7 @@
           <a:lstStyle/>
           <a:p>
             <a:pPr algn="ctr"/>
+            <a:endParaRPr/>
           </a:p>
         </p:txBody>
       </p:sp>
@@ -27959,6 +28729,7 @@
           <a:lstStyle/>
           <a:p>
             <a:pPr algn="ctr"/>
+            <a:endParaRPr/>
           </a:p>
         </p:txBody>
       </p:sp>
@@ -28106,6 +28877,7 @@
           <a:lstStyle/>
           <a:p>
             <a:pPr algn="ctr"/>
+            <a:endParaRPr/>
           </a:p>
         </p:txBody>
       </p:sp>
@@ -28321,6 +29093,7 @@
           <a:lstStyle/>
           <a:p>
             <a:pPr algn="ctr"/>
+            <a:endParaRPr/>
           </a:p>
         </p:txBody>
       </p:sp>
@@ -28534,6 +29307,7 @@
           <a:lstStyle/>
           <a:p>
             <a:pPr algn="ctr"/>
+            <a:endParaRPr/>
           </a:p>
         </p:txBody>
       </p:sp>
@@ -28611,6 +29385,7 @@
           <a:lstStyle/>
           <a:p>
             <a:pPr algn="ctr"/>
+            <a:endParaRPr/>
           </a:p>
         </p:txBody>
       </p:sp>
@@ -28657,7 +29432,7 @@
 </file>
 
 <file path=ppt/slides/slide9.xml><?xml version="1.0" encoding="utf-8"?>
-<p:sld xmlns:a="http://schemas.openxmlformats.org/drawingml/2006/main" xmlns:p="http://schemas.openxmlformats.org/presentationml/2006/main" xmlns:r="http://schemas.openxmlformats.org/officeDocument/2006/relationships">
+<p:sld xmlns:a="http://schemas.openxmlformats.org/drawingml/2006/main" xmlns:r="http://schemas.openxmlformats.org/officeDocument/2006/relationships" xmlns:p="http://schemas.openxmlformats.org/presentationml/2006/main">
   <p:cSld>
     <p:spTree>
       <p:nvGrpSpPr>
@@ -28665,7 +29440,14 @@
         <p:cNvGrpSpPr/>
         <p:nvPr/>
       </p:nvGrpSpPr>
-      <p:grpSpPr/>
+      <p:grpSpPr>
+        <a:xfrm>
+          <a:off x="0" y="0"/>
+          <a:ext cx="0" cy="0"/>
+          <a:chOff x="0" y="0"/>
+          <a:chExt cx="0" cy="0"/>
+        </a:xfrm>
+      </p:grpSpPr>
       <p:sp>
         <p:nvSpPr>
           <p:cNvPr id="2" name="Rectangle 1"/>
@@ -28706,6 +29488,7 @@
           <a:lstStyle/>
           <a:p>
             <a:pPr algn="ctr"/>
+            <a:endParaRPr/>
           </a:p>
         </p:txBody>
       </p:sp>
@@ -28749,6 +29532,7 @@
           <a:lstStyle/>
           <a:p>
             <a:pPr algn="ctr"/>
+            <a:endParaRPr/>
           </a:p>
         </p:txBody>
       </p:sp>
@@ -28894,6 +29678,7 @@
           <a:lstStyle/>
           <a:p>
             <a:pPr algn="ctr"/>
+            <a:endParaRPr/>
           </a:p>
         </p:txBody>
       </p:sp>
@@ -29041,6 +29826,7 @@
           <a:lstStyle/>
           <a:p>
             <a:pPr algn="ctr"/>
+            <a:endParaRPr/>
           </a:p>
         </p:txBody>
       </p:sp>
@@ -29188,6 +29974,7 @@
           <a:lstStyle/>
           <a:p>
             <a:pPr algn="ctr"/>
+            <a:endParaRPr/>
           </a:p>
         </p:txBody>
       </p:sp>
@@ -29335,6 +30122,7 @@
           <a:lstStyle/>
           <a:p>
             <a:pPr algn="ctr"/>
+            <a:endParaRPr/>
           </a:p>
         </p:txBody>
       </p:sp>
@@ -29482,6 +30270,7 @@
           <a:lstStyle/>
           <a:p>
             <a:pPr algn="ctr"/>
+            <a:endParaRPr/>
           </a:p>
         </p:txBody>
       </p:sp>
@@ -29629,6 +30418,7 @@
           <a:lstStyle/>
           <a:p>
             <a:pPr algn="ctr"/>
+            <a:endParaRPr/>
           </a:p>
         </p:txBody>
       </p:sp>
@@ -29776,6 +30566,7 @@
           <a:lstStyle/>
           <a:p>
             <a:pPr algn="ctr"/>
+            <a:endParaRPr/>
           </a:p>
         </p:txBody>
       </p:sp>
@@ -29923,6 +30714,7 @@
           <a:lstStyle/>
           <a:p>
             <a:pPr algn="ctr"/>
+            <a:endParaRPr/>
           </a:p>
         </p:txBody>
       </p:sp>
@@ -30068,6 +30860,7 @@
           <a:lstStyle/>
           <a:p>
             <a:pPr algn="ctr"/>
+            <a:endParaRPr/>
           </a:p>
         </p:txBody>
       </p:sp>
@@ -30431,4 +31224,299 @@
   </a:objectDefaults>
   <a:extraClrSchemeLst/>
 </a:theme>
+</file>
+
+<file path=ppt/theme/theme2.xml><?xml version="1.0" encoding="utf-8"?>
+<a:theme xmlns:a="http://schemas.openxmlformats.org/drawingml/2006/main" name="Office Theme">
+  <a:themeElements>
+    <a:clrScheme name="Office">
+      <a:dk1>
+        <a:sysClr val="windowText" lastClr="000000"/>
+      </a:dk1>
+      <a:lt1>
+        <a:sysClr val="window" lastClr="FFFFFF"/>
+      </a:lt1>
+      <a:dk2>
+        <a:srgbClr val="44546A"/>
+      </a:dk2>
+      <a:lt2>
+        <a:srgbClr val="E7E6E6"/>
+      </a:lt2>
+      <a:accent1>
+        <a:srgbClr val="4472C4"/>
+      </a:accent1>
+      <a:accent2>
+        <a:srgbClr val="ED7D31"/>
+      </a:accent2>
+      <a:accent3>
+        <a:srgbClr val="A5A5A5"/>
+      </a:accent3>
+      <a:accent4>
+        <a:srgbClr val="FFC000"/>
+      </a:accent4>
+      <a:accent5>
+        <a:srgbClr val="5B9BD5"/>
+      </a:accent5>
+      <a:accent6>
+        <a:srgbClr val="70AD47"/>
+      </a:accent6>
+      <a:hlink>
+        <a:srgbClr val="0563C1"/>
+      </a:hlink>
+      <a:folHlink>
+        <a:srgbClr val="954F72"/>
+      </a:folHlink>
+    </a:clrScheme>
+    <a:fontScheme name="Office">
+      <a:majorFont>
+        <a:latin typeface="Calibri Light" panose="020F0302020204030204"/>
+        <a:ea typeface=""/>
+        <a:cs typeface=""/>
+        <a:font script="Jpan" typeface="游ゴシック Light"/>
+        <a:font script="Hang" typeface="맑은 고딕"/>
+        <a:font script="Hans" typeface="等线 Light"/>
+        <a:font script="Hant" typeface="新細明體"/>
+        <a:font script="Arab" typeface="Times New Roman"/>
+        <a:font script="Hebr" typeface="Times New Roman"/>
+        <a:font script="Thai" typeface="Angsana New"/>
+        <a:font script="Ethi" typeface="Nyala"/>
+        <a:font script="Beng" typeface="Vrinda"/>
+        <a:font script="Gujr" typeface="Shruti"/>
+        <a:font script="Khmr" typeface="MoolBoran"/>
+        <a:font script="Knda" typeface="Tunga"/>
+        <a:font script="Guru" typeface="Raavi"/>
+        <a:font script="Cans" typeface="Euphemia"/>
+        <a:font script="Cher" typeface="Plantagenet Cherokee"/>
+        <a:font script="Yiii" typeface="Microsoft Yi Baiti"/>
+        <a:font script="Tibt" typeface="Microsoft Himalaya"/>
+        <a:font script="Thaa" typeface="MV Boli"/>
+        <a:font script="Deva" typeface="Mangal"/>
+        <a:font script="Telu" typeface="Gautami"/>
+        <a:font script="Taml" typeface="Latha"/>
+        <a:font script="Syrc" typeface="Estrangelo Edessa"/>
+        <a:font script="Orya" typeface="Kalinga"/>
+        <a:font script="Mlym" typeface="Kartika"/>
+        <a:font script="Laoo" typeface="DokChampa"/>
+        <a:font script="Sinh" typeface="Iskoola Pota"/>
+        <a:font script="Mong" typeface="Mongolian Baiti"/>
+        <a:font script="Viet" typeface="Times New Roman"/>
+        <a:font script="Uigh" typeface="Microsoft Uighur"/>
+        <a:font script="Geor" typeface="Sylfaen"/>
+        <a:font script="Armn" typeface="Arial"/>
+        <a:font script="Bugi" typeface="Leelawadee UI"/>
+        <a:font script="Bopo" typeface="Microsoft JhengHei"/>
+        <a:font script="Java" typeface="Javanese Text"/>
+        <a:font script="Lisu" typeface="Segoe UI"/>
+        <a:font script="Mymr" typeface="Myanmar Text"/>
+        <a:font script="Nkoo" typeface="Ebrima"/>
+        <a:font script="Olck" typeface="Nirmala UI"/>
+        <a:font script="Osma" typeface="Ebrima"/>
+        <a:font script="Phag" typeface="Phagspa"/>
+        <a:font script="Syrn" typeface="Estrangelo Edessa"/>
+        <a:font script="Syrj" typeface="Estrangelo Edessa"/>
+        <a:font script="Syre" typeface="Estrangelo Edessa"/>
+        <a:font script="Sora" typeface="Nirmala UI"/>
+        <a:font script="Tale" typeface="Microsoft Tai Le"/>
+        <a:font script="Talu" typeface="Microsoft New Tai Lue"/>
+        <a:font script="Tfng" typeface="Ebrima"/>
+      </a:majorFont>
+      <a:minorFont>
+        <a:latin typeface="Calibri" panose="020F0502020204030204"/>
+        <a:ea typeface=""/>
+        <a:cs typeface=""/>
+        <a:font script="Jpan" typeface="游ゴシック"/>
+        <a:font script="Hang" typeface="맑은 고딕"/>
+        <a:font script="Hans" typeface="等线"/>
+        <a:font script="Hant" typeface="新細明體"/>
+        <a:font script="Arab" typeface="Arial"/>
+        <a:font script="Hebr" typeface="Arial"/>
+        <a:font script="Thai" typeface="Cordia New"/>
+        <a:font script="Ethi" typeface="Nyala"/>
+        <a:font script="Beng" typeface="Vrinda"/>
+        <a:font script="Gujr" typeface="Shruti"/>
+        <a:font script="Khmr" typeface="DaunPenh"/>
+        <a:font script="Knda" typeface="Tunga"/>
+        <a:font script="Guru" typeface="Raavi"/>
+        <a:font script="Cans" typeface="Euphemia"/>
+        <a:font script="Cher" typeface="Plantagenet Cherokee"/>
+        <a:font script="Yiii" typeface="Microsoft Yi Baiti"/>
+        <a:font script="Tibt" typeface="Microsoft Himalaya"/>
+        <a:font script="Thaa" typeface="MV Boli"/>
+        <a:font script="Deva" typeface="Mangal"/>
+        <a:font script="Telu" typeface="Gautami"/>
+        <a:font script="Taml" typeface="Latha"/>
+        <a:font script="Syrc" typeface="Estrangelo Edessa"/>
+        <a:font script="Orya" typeface="Kalinga"/>
+        <a:font script="Mlym" typeface="Kartika"/>
+        <a:font script="Laoo" typeface="DokChampa"/>
+        <a:font script="Sinh" typeface="Iskoola Pota"/>
+        <a:font script="Mong" typeface="Mongolian Baiti"/>
+        <a:font script="Viet" typeface="Arial"/>
+        <a:font script="Uigh" typeface="Microsoft Uighur"/>
+        <a:font script="Geor" typeface="Sylfaen"/>
+        <a:font script="Armn" typeface="Arial"/>
+        <a:font script="Bugi" typeface="Leelawadee UI"/>
+        <a:font script="Bopo" typeface="Microsoft JhengHei"/>
+        <a:font script="Java" typeface="Javanese Text"/>
+        <a:font script="Lisu" typeface="Segoe UI"/>
+        <a:font script="Mymr" typeface="Myanmar Text"/>
+        <a:font script="Nkoo" typeface="Ebrima"/>
+        <a:font script="Olck" typeface="Nirmala UI"/>
+        <a:font script="Osma" typeface="Ebrima"/>
+        <a:font script="Phag" typeface="Phagspa"/>
+        <a:font script="Syrn" typeface="Estrangelo Edessa"/>
+        <a:font script="Syrj" typeface="Estrangelo Edessa"/>
+        <a:font script="Syre" typeface="Estrangelo Edessa"/>
+        <a:font script="Sora" typeface="Nirmala UI"/>
+        <a:font script="Tale" typeface="Microsoft Tai Le"/>
+        <a:font script="Talu" typeface="Microsoft New Tai Lue"/>
+        <a:font script="Tfng" typeface="Ebrima"/>
+      </a:minorFont>
+    </a:fontScheme>
+    <a:fmtScheme name="Office">
+      <a:fillStyleLst>
+        <a:solidFill>
+          <a:schemeClr val="phClr"/>
+        </a:solidFill>
+        <a:gradFill rotWithShape="1">
+          <a:gsLst>
+            <a:gs pos="0">
+              <a:schemeClr val="phClr">
+                <a:lumMod val="110000"/>
+                <a:satMod val="105000"/>
+                <a:tint val="67000"/>
+              </a:schemeClr>
+            </a:gs>
+            <a:gs pos="50000">
+              <a:schemeClr val="phClr">
+                <a:lumMod val="105000"/>
+                <a:satMod val="103000"/>
+                <a:tint val="73000"/>
+              </a:schemeClr>
+            </a:gs>
+            <a:gs pos="100000">
+              <a:schemeClr val="phClr">
+                <a:lumMod val="105000"/>
+                <a:satMod val="109000"/>
+                <a:tint val="81000"/>
+              </a:schemeClr>
+            </a:gs>
+          </a:gsLst>
+          <a:lin ang="5400000" scaled="0"/>
+        </a:gradFill>
+        <a:gradFill rotWithShape="1">
+          <a:gsLst>
+            <a:gs pos="0">
+              <a:schemeClr val="phClr">
+                <a:satMod val="103000"/>
+                <a:lumMod val="102000"/>
+                <a:tint val="94000"/>
+              </a:schemeClr>
+            </a:gs>
+            <a:gs pos="50000">
+              <a:schemeClr val="phClr">
+                <a:satMod val="110000"/>
+                <a:lumMod val="100000"/>
+                <a:shade val="100000"/>
+              </a:schemeClr>
+            </a:gs>
+            <a:gs pos="100000">
+              <a:schemeClr val="phClr">
+                <a:lumMod val="99000"/>
+                <a:satMod val="120000"/>
+                <a:shade val="78000"/>
+              </a:schemeClr>
+            </a:gs>
+          </a:gsLst>
+          <a:lin ang="5400000" scaled="0"/>
+        </a:gradFill>
+      </a:fillStyleLst>
+      <a:lnStyleLst>
+        <a:ln w="6350" cap="flat" cmpd="sng" algn="ctr">
+          <a:solidFill>
+            <a:schemeClr val="phClr"/>
+          </a:solidFill>
+          <a:prstDash val="solid"/>
+          <a:miter lim="800000"/>
+        </a:ln>
+        <a:ln w="12700" cap="flat" cmpd="sng" algn="ctr">
+          <a:solidFill>
+            <a:schemeClr val="phClr"/>
+          </a:solidFill>
+          <a:prstDash val="solid"/>
+          <a:miter lim="800000"/>
+        </a:ln>
+        <a:ln w="19050" cap="flat" cmpd="sng" algn="ctr">
+          <a:solidFill>
+            <a:schemeClr val="phClr"/>
+          </a:solidFill>
+          <a:prstDash val="solid"/>
+          <a:miter lim="800000"/>
+        </a:ln>
+      </a:lnStyleLst>
+      <a:effectStyleLst>
+        <a:effectStyle>
+          <a:effectLst/>
+        </a:effectStyle>
+        <a:effectStyle>
+          <a:effectLst/>
+        </a:effectStyle>
+        <a:effectStyle>
+          <a:effectLst>
+            <a:outerShdw blurRad="57150" dist="19050" dir="5400000" algn="ctr" rotWithShape="0">
+              <a:srgbClr val="000000">
+                <a:alpha val="63000"/>
+              </a:srgbClr>
+            </a:outerShdw>
+          </a:effectLst>
+        </a:effectStyle>
+      </a:effectStyleLst>
+      <a:bgFillStyleLst>
+        <a:solidFill>
+          <a:schemeClr val="phClr"/>
+        </a:solidFill>
+        <a:solidFill>
+          <a:schemeClr val="phClr">
+            <a:tint val="95000"/>
+            <a:satMod val="170000"/>
+          </a:schemeClr>
+        </a:solidFill>
+        <a:gradFill rotWithShape="1">
+          <a:gsLst>
+            <a:gs pos="0">
+              <a:schemeClr val="phClr">
+                <a:tint val="93000"/>
+                <a:satMod val="150000"/>
+                <a:shade val="98000"/>
+                <a:lumMod val="102000"/>
+              </a:schemeClr>
+            </a:gs>
+            <a:gs pos="50000">
+              <a:schemeClr val="phClr">
+                <a:tint val="98000"/>
+                <a:satMod val="130000"/>
+                <a:shade val="90000"/>
+                <a:lumMod val="103000"/>
+              </a:schemeClr>
+            </a:gs>
+            <a:gs pos="100000">
+              <a:schemeClr val="phClr">
+                <a:shade val="63000"/>
+                <a:satMod val="120000"/>
+              </a:schemeClr>
+            </a:gs>
+          </a:gsLst>
+          <a:lin ang="5400000" scaled="0"/>
+        </a:gradFill>
+      </a:bgFillStyleLst>
+    </a:fmtScheme>
+  </a:themeElements>
+  <a:objectDefaults/>
+  <a:extraClrSchemeLst/>
+  <a:extLst>
+    <a:ext uri="{05A4C25C-085E-4340-85A3-A5531E510DB2}">
+      <thm15:themeFamily xmlns:thm15="http://schemas.microsoft.com/office/thememl/2012/main" name="Office Theme" id="{62F939B6-93AF-4DB8-9C6B-D6C7DFDC589F}" vid="{4A3C46E8-61CC-4603-A589-7422A47A8E4A}"/>
+    </a:ext>
+  </a:extLst>
+</a:theme>
 </file>
</xml_diff>